<commit_message>
Align hackathon pitch with judging rubric and add 60-second demo video
</commit_message>
<xml_diff>
--- a/presentation/TapeDeck-MongoDB-Hackathon.pptx
+++ b/presentation/TapeDeck-MongoDB-Hackathon.pptx
@@ -2,17 +2,18 @@
 <file path=ppt/presentation.xml><?xml version="1.0" encoding="utf-8"?>
 <p:presentation xmlns:p="http://schemas.openxmlformats.org/presentationml/2006/main">
   <p:sldMasterIdLst>
-    <p:sldMasterId xmlns:r="http://schemas.openxmlformats.org/officeDocument/2006/relationships" id="2147483648" r:id="R6a8337f4c6494117"/>
+    <p:sldMasterId xmlns:r="http://schemas.openxmlformats.org/officeDocument/2006/relationships" id="2147483648" r:id="R8e0b8ce4862d48dc"/>
   </p:sldMasterIdLst>
   <p:notesMasterIdLst>
-    <p:notesMasterId xmlns:r="http://schemas.openxmlformats.org/officeDocument/2006/relationships" r:id="R279247cdff4142c2"/>
+    <p:notesMasterId xmlns:r="http://schemas.openxmlformats.org/officeDocument/2006/relationships" r:id="R3136c2bc250449b6"/>
   </p:notesMasterIdLst>
   <p:sldIdLst>
-    <p:sldId xmlns:r="http://schemas.openxmlformats.org/officeDocument/2006/relationships" id="256" r:id="R014a1d5f167a4f9d"/>
-    <p:sldId xmlns:r="http://schemas.openxmlformats.org/officeDocument/2006/relationships" id="257" r:id="R8ea258301413497f"/>
-    <p:sldId xmlns:r="http://schemas.openxmlformats.org/officeDocument/2006/relationships" id="258" r:id="R6ea5faa33aea43b8"/>
-    <p:sldId xmlns:r="http://schemas.openxmlformats.org/officeDocument/2006/relationships" id="259" r:id="R2ec2f4a91c9e4279"/>
-    <p:sldId xmlns:r="http://schemas.openxmlformats.org/officeDocument/2006/relationships" id="260" r:id="R6c34d8e588344e51"/>
+    <p:sldId xmlns:r="http://schemas.openxmlformats.org/officeDocument/2006/relationships" id="256" r:id="R3060a759856f4484"/>
+    <p:sldId xmlns:r="http://schemas.openxmlformats.org/officeDocument/2006/relationships" id="257" r:id="Ra11166c15d074e4a"/>
+    <p:sldId xmlns:r="http://schemas.openxmlformats.org/officeDocument/2006/relationships" id="258" r:id="R37efc9de580848d9"/>
+    <p:sldId xmlns:r="http://schemas.openxmlformats.org/officeDocument/2006/relationships" id="259" r:id="Rc9d5ee8b4d0a4f65"/>
+    <p:sldId xmlns:r="http://schemas.openxmlformats.org/officeDocument/2006/relationships" id="260" r:id="R981f870ea1584f8c"/>
+    <p:sldId xmlns:r="http://schemas.openxmlformats.org/officeDocument/2006/relationships" id="261" r:id="R372ebe0b1ac8480f"/>
   </p:sldIdLst>
   <p:sldSz cx="12192000" cy="6858000"/>
   <p:notesSz cx="6858000" cy="9144000"/>
@@ -446,7 +447,7 @@
           <a:lstStyle xmlns:a="http://schemas.openxmlformats.org/drawingml/2006/main"/>
           <a:p xmlns:a="http://schemas.openxmlformats.org/drawingml/2006/main">
             <a:r>
-              <a:t>0:00–0:10</a:t>
+              <a:t>0–6 seconds</a:t>
             </a:r>
           </a:p>
           <a:p xmlns:a="http://schemas.openxmlformats.org/drawingml/2006/main">
@@ -456,7 +457,7 @@
           </a:p>
           <a:p xmlns:a="http://schemas.openxmlformats.org/drawingml/2006/main">
             <a:r>
-              <a:t>When a coding agent fails, a chat log is not enough. TapeDeck saves the experiment: its trace, files, and Git checkpoints, ready to reopen.</a:t>
+              <a:t>A failed agent run needs more than chat logs. TapeDeck saves reopenable, executable experiments.</a:t>
             </a:r>
           </a:p>
           <a:p xmlns:a="http://schemas.openxmlformats.org/drawingml/2006/main">
@@ -466,12 +467,12 @@
           </a:p>
           <a:p xmlns:a="http://schemas.openxmlformats.org/drawingml/2006/main">
             <a:r>
-              <a:t>Presenter reference, not spoken: Audience: MongoDB hackathon judges. The saved Pharo image contains trace objects and embedded file bytes, not an operating-system snapshot.</a:t>
-            </a:r>
-          </a:p>
-          <a:p xmlns:a="http://schemas.openxmlformats.org/drawingml/2006/main">
-            <a:r>
-              <a:t>Measured evidence: docs/demo-evidence.json. Model: https://ollama.com/library/qwen3.5:2b. GridFS: https://www.mongodb.com/docs/drivers/node/current/crud/gridfs/.</a:t>
+              <a:t>References, not spoken: presentation/demo-capture.json; presentation/pitch-plan.json. Actual Qwen results captured September 26, 2026. Prior Atlas snapshot is separate from the Qwen run, reverified locally, not a new live cloud transfer. [{"path":"image/src/TapeDeck-Server/TdAgentImage.class.st","symbols":["readArchive:","saveAs:","startUp:"]}]</a:t>
+            </a:r>
+          </a:p>
+          <a:p xmlns:a="http://schemas.openxmlformats.org/drawingml/2006/main">
+            <a:r>
+              <a:t>MongoDB GridFS: https://www.mongodb.com/docs/drivers/node/current/crud/gridfs/</a:t>
             </a:r>
           </a:p>
         </p:txBody>
@@ -541,7 +542,7 @@
           <a:lstStyle xmlns:a="http://schemas.openxmlformats.org/drawingml/2006/main"/>
           <a:p xmlns:a="http://schemas.openxmlformats.org/drawingml/2006/main">
             <a:r>
-              <a:t>0:10–0:25</a:t>
+              <a:t>6–20 seconds</a:t>
             </a:r>
           </a:p>
           <a:p xmlns:a="http://schemas.openxmlformats.org/drawingml/2006/main">
@@ -551,7 +552,7 @@
           </a:p>
           <a:p xmlns:a="http://schemas.openxmlformats.org/drawingml/2006/main">
             <a:r>
-              <a:t>We ran Qwen three-point-five two-B locally on a coding task. The original run, live fork, and fresh run passed. Strict replay reproduced the trace with zero model calls, measured independently.</a:t>
+              <a:t>Real local Qwen on a coding task: baseline, four calls; replay, zero; fork, three; fresh run, four. Independently counted. All live verifiers passed. Replay returns recorded behavior, not a new verdict.</a:t>
             </a:r>
           </a:p>
           <a:p xmlns:a="http://schemas.openxmlformats.org/drawingml/2006/main">
@@ -561,12 +562,12 @@
           </a:p>
           <a:p xmlns:a="http://schemas.openxmlformats.org/drawingml/2006/main">
             <a:r>
-              <a:t>Presenter reference, not spoken: One sum-function fixture on a 24 GiB Apple Silicon Mac. Ollama 0.33.2, Q8_0 weights, 16,384-token context, temperature zero, seed 42. Replay does not rerun the task verifier. Fork reuses one recorded step and explicitly permits a changed system prompt. No general benchmark claim.</a:t>
-            </a:r>
-          </a:p>
-          <a:p xmlns:a="http://schemas.openxmlformats.org/drawingml/2006/main">
-            <a:r>
-              <a:t>Measured evidence: docs/demo-evidence.json. Model: https://ollama.com/library/qwen3.5:2b. GridFS: https://www.mongodb.com/docs/drivers/node/current/crud/gridfs/.</a:t>
+              <a:t>References, not spoken: presentation/demo-capture.json; presentation/pitch-plan.json. Actual Qwen results captured September 26, 2026. Prior Atlas snapshot is separate from the Qwen run, reverified locally, not a new live cloud transfer. [{"path":"runner/src/local-demo.ts","symbols":["replayVerified","providerRequests"]},{"path":"runner/src/local-gateway.ts","symbols":["startLocalGateway","setPhase"]}]</a:t>
+            </a:r>
+          </a:p>
+          <a:p xmlns:a="http://schemas.openxmlformats.org/drawingml/2006/main">
+            <a:r>
+              <a:t>MongoDB GridFS: https://www.mongodb.com/docs/drivers/node/current/crud/gridfs/</a:t>
             </a:r>
           </a:p>
         </p:txBody>
@@ -636,7 +637,7 @@
           <a:lstStyle xmlns:a="http://schemas.openxmlformats.org/drawingml/2006/main"/>
           <a:p xmlns:a="http://schemas.openxmlformats.org/drawingml/2006/main">
             <a:r>
-              <a:t>0:25–0:40</a:t>
+              <a:t>20–30 seconds</a:t>
             </a:r>
           </a:p>
           <a:p xmlns:a="http://schemas.openxmlformats.org/drawingml/2006/main">
@@ -646,7 +647,7 @@
           </a:p>
           <a:p xmlns:a="http://schemas.openxmlformats.org/drawingml/2006/main">
             <a:r>
-              <a:t>MongoDB Atlas stores the image and companion files in GridFS. A snapshot manifest links their hashes. Download verifies the bytes before restoring the experiment. Reconnect the local model only when you choose a live continuation.</a:t>
+              <a:t>We intercept requests, record tool outcomes, and checkpoint Git. Divergence stops replay; an explicit fork restores the checkpoint before continuing live.</a:t>
             </a:r>
           </a:p>
           <a:p xmlns:a="http://schemas.openxmlformats.org/drawingml/2006/main">
@@ -656,12 +657,12 @@
           </a:p>
           <a:p xmlns:a="http://schemas.openxmlformats.org/drawingml/2006/main">
             <a:r>
-              <a:t>Presenter reference, not spoken: Implemented in runner/src/atlas.ts and archive.ts. Collections: agent_snapshots.files, agent_snapshots.chunks, agent_snapshots_manifests. Manifests publish only after all uploads succeed. Model weights and credentials stay external. No vector-search feature is claimed.</a:t>
-            </a:r>
-          </a:p>
-          <a:p xmlns:a="http://schemas.openxmlformats.org/drawingml/2006/main">
-            <a:r>
-              <a:t>Measured evidence: docs/demo-evidence.json. Model: https://ollama.com/library/qwen3.5:2b. GridFS: https://www.mongodb.com/docs/drivers/node/current/crud/gridfs/.</a:t>
+              <a:t>References, not spoken: presentation/demo-capture.json; presentation/pitch-plan.json. Actual Qwen results captured September 26, 2026. Prior Atlas snapshot is separate from the Qwen run, reverified locally, not a new live cloud transfer. [{"path":"pi-tape/extensions/tape.ts","symbols":["registerProvider"]},{"path":"pi-tape/extensions/tape/controller.ts","symbols":["checkRequest","runTool","stubResult","finishStep","diverge"]},{"path":"pi-tape/src/git.ts","symbols":["snapshot","restore"]}]</a:t>
+            </a:r>
+          </a:p>
+          <a:p xmlns:a="http://schemas.openxmlformats.org/drawingml/2006/main">
+            <a:r>
+              <a:t>MongoDB GridFS: https://www.mongodb.com/docs/drivers/node/current/crud/gridfs/</a:t>
             </a:r>
           </a:p>
         </p:txBody>
@@ -731,7 +732,7 @@
           <a:lstStyle xmlns:a="http://schemas.openxmlformats.org/drawingml/2006/main"/>
           <a:p xmlns:a="http://schemas.openxmlformats.org/drawingml/2006/main">
             <a:r>
-              <a:t>0:40–0:52</a:t>
+              <a:t>30–40 seconds</a:t>
             </a:r>
           </a:p>
           <a:p xmlns:a="http://schemas.openxmlformats.org/drawingml/2006/main">
@@ -741,7 +742,7 @@
           </a:p>
           <a:p xmlns:a="http://schemas.openxmlformats.org/drawingml/2006/main">
             <a:r>
-              <a:t>Atlas recovery is independently verified: four companion hashes matched, and the downloaded image reopened with its files and Git history intact. That earlier snapshot is separate from today’s Qwen run.</a:t>
+              <a:t>MongoDB GridFS stores checksummed images and their companions in file and chunk collections. Our manifest collection publishes a snapshot only after every upload succeeds.</a:t>
             </a:r>
           </a:p>
           <a:p xmlns:a="http://schemas.openxmlformats.org/drawingml/2006/main">
@@ -751,12 +752,12 @@
           </a:p>
           <a:p xmlns:a="http://schemas.openxmlformats.org/drawingml/2006/main">
             <a:r>
-              <a:t>Presenter reference, not spoken: Snapshot b185069cbeefb5e464e4523d, verified 2026-09-26T19:06:14.492Z. Separate prior snapshot, not the new Qwen experiment. Every companion hash matches both source and manifest. Every image-materialized file and Git bundle matches its archive digest.</a:t>
-            </a:r>
-          </a:p>
-          <a:p xmlns:a="http://schemas.openxmlformats.org/drawingml/2006/main">
-            <a:r>
-              <a:t>Measured evidence: docs/demo-evidence.json. Model: https://ollama.com/library/qwen3.5:2b. GridFS: https://www.mongodb.com/docs/drivers/node/current/crud/gridfs/.</a:t>
+              <a:t>References, not spoken: presentation/demo-capture.json; presentation/pitch-plan.json. Actual Qwen results captured September 26, 2026. Prior Atlas snapshot is separate from the Qwen run, reverified locally, not a new live cloud transfer. [{"path":"runner/src/atlas.ts","symbols":["GridFSBucket","putManifest","publish","restore"]},{"path":"runner/test/atlas.test.ts","symbols":["publishes manifest last","corrupt, truncated, oversized, or missing GridFS files"]}]</a:t>
+            </a:r>
+          </a:p>
+          <a:p xmlns:a="http://schemas.openxmlformats.org/drawingml/2006/main">
+            <a:r>
+              <a:t>MongoDB GridFS: https://www.mongodb.com/docs/drivers/node/current/crud/gridfs/</a:t>
             </a:r>
           </a:p>
         </p:txBody>
@@ -826,7 +827,7 @@
           <a:lstStyle xmlns:a="http://schemas.openxmlformats.org/drawingml/2006/main"/>
           <a:p xmlns:a="http://schemas.openxmlformats.org/drawingml/2006/main">
             <a:r>
-              <a:t>0:52–1:00</a:t>
+              <a:t>40–52 seconds</a:t>
             </a:r>
           </a:p>
           <a:p xmlns:a="http://schemas.openxmlformats.org/drawingml/2006/main">
@@ -836,7 +837,7 @@
           </a:p>
           <a:p xmlns:a="http://schemas.openxmlformats.org/drawingml/2006/main">
             <a:r>
-              <a:t>Our ask: bring one failing agent run. Recover it, inspect it, then try a live alternative. That is TapeDeck.</a:t>
+              <a:t>Pharo preserves objects and files. This earlier Atlas download reopens with four companion hashes verified. Today’s Qwen image is local; its upload remains blocked.</a:t>
             </a:r>
           </a:p>
           <a:p xmlns:a="http://schemas.openxmlformats.org/drawingml/2006/main">
@@ -846,12 +847,107 @@
           </a:p>
           <a:p xmlns:a="http://schemas.openxmlformats.org/drawingml/2006/main">
             <a:r>
-              <a:t>Presenter reference, not spoken: Prototype boundaries: one controlled coding fixture, not a general benchmark or OS sandbox. Model inference is local. Repository access may require permission.</a:t>
-            </a:r>
-          </a:p>
-          <a:p xmlns:a="http://schemas.openxmlformats.org/drawingml/2006/main">
-            <a:r>
-              <a:t>Measured evidence: docs/demo-evidence.json. Model: https://ollama.com/library/qwen3.5:2b. GridFS: https://www.mongodb.com/docs/drivers/node/current/crud/gridfs/.</a:t>
+              <a:t>References, not spoken: presentation/demo-capture.json; presentation/pitch-plan.json. Actual Qwen results captured September 26, 2026. Prior Atlas snapshot is separate from the Qwen run, reverified locally, not a new live cloud transfer. [{"path":"image/src/TapeDeck-Server/TdAgentImage.class.st","symbols":["readArchive:","decodedBytes:","restoreFilesTo:","resume","saveAs:"]},{"path":"runner/src/atlas.ts","symbols":["restore"]}]</a:t>
+            </a:r>
+          </a:p>
+          <a:p xmlns:a="http://schemas.openxmlformats.org/drawingml/2006/main">
+            <a:r>
+              <a:t>MongoDB GridFS: https://www.mongodb.com/docs/drivers/node/current/crud/gridfs/</a:t>
+            </a:r>
+          </a:p>
+        </p:txBody>
+      </p:sp>
+      <p:sp>
+        <p:nvSpPr>
+          <p:cNvPr id="4" name="Slide Number Placeholder 3"/>
+          <p:cNvSpPr>
+            <a:spLocks xmlns:a="http://schemas.openxmlformats.org/drawingml/2006/main" noGrp="1"/>
+          </p:cNvSpPr>
+          <p:nvPr>
+            <p:ph type="sldNum" idx="5"/>
+          </p:nvPr>
+        </p:nvSpPr>
+        <p:spPr/>
+        <p:txBody>
+          <a:bodyPr xmlns:a="http://schemas.openxmlformats.org/drawingml/2006/main"/>
+          <a:lstStyle xmlns:a="http://schemas.openxmlformats.org/drawingml/2006/main"/>
+          <a:p xmlns:a="http://schemas.openxmlformats.org/drawingml/2006/main"/>
+        </p:txBody>
+      </p:sp>
+    </p:spTree>
+  </p:cSld>
+  <p:clrMapOvr>
+    <a:masterClrMapping xmlns:a="http://schemas.openxmlformats.org/drawingml/2006/main"/>
+  </p:clrMapOvr>
+</p:notes>
+</file>
+
+<file path=ppt/notesSlides/notesSlide6.xml><?xml version="1.0" encoding="utf-8"?>
+<p:notes xmlns:p="http://schemas.openxmlformats.org/presentationml/2006/main">
+  <p:cSld>
+    <p:spTree>
+      <p:nvGrpSpPr>
+        <p:cNvPr id="1" name=""/>
+        <p:cNvGrpSpPr/>
+        <p:nvPr/>
+      </p:nvGrpSpPr>
+      <p:grpSpPr>
+        <a:xfrm xmlns:a="http://schemas.openxmlformats.org/drawingml/2006/main"/>
+      </p:grpSpPr>
+      <p:sp>
+        <p:nvSpPr>
+          <p:cNvPr id="2" name="Slide Image Placeholder 1"/>
+          <p:cNvSpPr>
+            <a:spLocks xmlns:a="http://schemas.openxmlformats.org/drawingml/2006/main" noGrp="1"/>
+          </p:cNvSpPr>
+          <p:nvPr>
+            <p:ph type="sldImg" idx="0"/>
+          </p:nvPr>
+        </p:nvSpPr>
+        <p:spPr/>
+      </p:sp>
+      <p:sp>
+        <p:nvSpPr>
+          <p:cNvPr id="3" name="Notes Placeholder 2"/>
+          <p:cNvSpPr>
+            <a:spLocks xmlns:a="http://schemas.openxmlformats.org/drawingml/2006/main" noGrp="1"/>
+          </p:cNvSpPr>
+          <p:nvPr>
+            <p:ph type="body" idx="1"/>
+          </p:nvPr>
+        </p:nvSpPr>
+        <p:spPr/>
+        <p:txBody>
+          <a:bodyPr xmlns:a="http://schemas.openxmlformats.org/drawingml/2006/main"/>
+          <a:lstStyle xmlns:a="http://schemas.openxmlformats.org/drawingml/2006/main"/>
+          <a:p xmlns:a="http://schemas.openxmlformats.org/drawingml/2006/main">
+            <a:r>
+              <a:t>52–60 seconds</a:t>
+            </a:r>
+          </a:p>
+          <a:p xmlns:a="http://schemas.openxmlformats.org/drawingml/2006/main">
+            <a:r>
+              <a:t/>
+            </a:r>
+          </a:p>
+          <a:p xmlns:a="http://schemas.openxmlformats.org/drawingml/2006/main">
+            <a:r>
+              <a:t>Recover, review, and debug failures without repeating inference during replay. Bring one failing run; test a live alternative.</a:t>
+            </a:r>
+          </a:p>
+          <a:p xmlns:a="http://schemas.openxmlformats.org/drawingml/2006/main">
+            <a:r>
+              <a:t/>
+            </a:r>
+          </a:p>
+          <a:p xmlns:a="http://schemas.openxmlformats.org/drawingml/2006/main">
+            <a:r>
+              <a:t>References, not spoken: presentation/demo-capture.json; presentation/pitch-plan.json. Actual Qwen results captured September 26, 2026. Prior Atlas snapshot is separate from the Qwen run, reverified locally, not a new live cloud transfer. [{"path":"pi-tape/extensions/tape/controller.ts","symbols":["stubResult","isLive","diverge"]},{"path":"image/src/TapeDeck-Server/TdAgentImage.class.st","symbols":["resume","compareRun:"]}]</a:t>
+            </a:r>
+          </a:p>
+          <a:p xmlns:a="http://schemas.openxmlformats.org/drawingml/2006/main">
+            <a:r>
+              <a:t>MongoDB GridFS: https://www.mongodb.com/docs/drivers/node/current/crud/gridfs/</a:t>
             </a:r>
           </a:p>
         </p:txBody>
@@ -919,7 +1015,7 @@
   </p:cSld>
   <p:clrMap bg1="lt1" tx1="dk1" bg2="lt2" tx2="dk2" accent1="accent1" accent2="accent2" accent3="accent3" accent4="accent4" accent5="accent5" accent6="accent6" hlink="hlink" folHlink="folHlink"/>
   <p:sldLayoutIdLst>
-    <p:sldLayoutId xmlns:r="http://schemas.openxmlformats.org/officeDocument/2006/relationships" id="2147483649" r:id="R24193bc7f17e44c1"/>
+    <p:sldLayoutId xmlns:r="http://schemas.openxmlformats.org/officeDocument/2006/relationships" id="2147483649" r:id="R9d1f4929070b4c3f"/>
   </p:sldLayoutIdLst>
   <p:txStyles>
     <p:titleStyle>
@@ -1467,10 +1563,10 @@
       </p:grpSpPr>
       <p:sp>
         <p:nvSpPr>
-          <p:cNvPr id="12" name="text-0">
+          <p:cNvPr id="13" name="text-0">
             <a:extLst xmlns:a="http://schemas.openxmlformats.org/drawingml/2006/main">
               <a:ext uri="{FF2B5EF4-FFF2-40B4-BE49-F238E27FC236}">
-                <a16:creationId xmlns:a16="http://schemas.microsoft.com/office/drawing/2014/main" id="{9E00C80B-0E5A-44EF-9A42-C57116562E5E}"/>
+                <a16:creationId xmlns:a16="http://schemas.microsoft.com/office/drawing/2014/main" id="{2C1393EE-1CBF-4911-8C02-01D032F5ACE1}"/>
               </a:ext>
             </a:extLst>
           </p:cNvPr>
@@ -1481,8 +1577,8 @@
         </p:nvSpPr>
         <p:spPr>
           <a:xfrm xmlns:a="http://schemas.openxmlformats.org/drawingml/2006/main">
-            <a:off x="10953750" y="6362700"/>
-            <a:ext cx="762000" cy="266700"/>
+            <a:off x="619125" y="314325"/>
+            <a:ext cx="10934700" cy="304800"/>
           </a:xfrm>
           <a:prstGeom xmlns:a="http://schemas.openxmlformats.org/drawingml/2006/main" prst="rect">
             <a:avLst/>
@@ -1499,9 +1595,9 @@
           <a:lstStyle xmlns:a="http://schemas.openxmlformats.org/drawingml/2006/main"/>
           <a:p xmlns:a="http://schemas.openxmlformats.org/drawingml/2006/main">
             <a:pPr>
-              <a:defRPr sz="1275">
-                <a:solidFill>
-                  <a:srgbClr val="94AFA7"/>
+              <a:defRPr sz="1575" b="1">
+                <a:solidFill>
+                  <a:srgbClr val="00ED64"/>
                 </a:solidFill>
                 <a:latin typeface="Helvetica Neue"/>
                 <a:ea typeface="Helvetica Neue"/>
@@ -1509,15 +1605,15 @@
               </a:defRPr>
             </a:pPr>
             <a:r>
-              <a:rPr sz="1275">
-                <a:solidFill>
-                  <a:srgbClr val="94AFA7"/>
+              <a:rPr sz="1575" b="1">
+                <a:solidFill>
+                  <a:srgbClr val="00ED64"/>
                 </a:solidFill>
                 <a:latin typeface="Helvetica Neue"/>
                 <a:ea typeface="Helvetica Neue"/>
                 <a:cs typeface="Helvetica Neue"/>
               </a:rPr>
-              <a:t>1 / 5</a:t>
+              <a:t>CREATIVITY 15%  /  IMPACT POTENTIAL 20%</a:t>
             </a:r>
           </a:p>
         </p:txBody>
@@ -1527,7 +1623,7 @@
           <p:cNvPr id="2" name="text-1">
             <a:extLst xmlns:a="http://schemas.openxmlformats.org/drawingml/2006/main">
               <a:ext uri="{FF2B5EF4-FFF2-40B4-BE49-F238E27FC236}">
-                <a16:creationId xmlns:a16="http://schemas.microsoft.com/office/drawing/2014/main" id="{0E107625-CDDB-4F25-A7A5-0A9699A10331}"/>
+                <a16:creationId xmlns:a16="http://schemas.microsoft.com/office/drawing/2014/main" id="{41FD3AF3-2979-48AB-B0DC-F1FF1F950C9E}"/>
               </a:ext>
             </a:extLst>
           </p:cNvPr>
@@ -1538,8 +1634,8 @@
         </p:nvSpPr>
         <p:spPr>
           <a:xfrm xmlns:a="http://schemas.openxmlformats.org/drawingml/2006/main">
-            <a:off x="609600" y="1371600"/>
-            <a:ext cx="7143750" cy="1095375"/>
+            <a:off x="10972800" y="6372225"/>
+            <a:ext cx="742950" cy="266700"/>
           </a:xfrm>
           <a:prstGeom xmlns:a="http://schemas.openxmlformats.org/drawingml/2006/main" prst="rect">
             <a:avLst/>
@@ -1556,9 +1652,9 @@
           <a:lstStyle xmlns:a="http://schemas.openxmlformats.org/drawingml/2006/main"/>
           <a:p xmlns:a="http://schemas.openxmlformats.org/drawingml/2006/main">
             <a:pPr>
-              <a:defRPr sz="7050" b="1">
-                <a:solidFill>
-                  <a:srgbClr val="FFFFFF"/>
+              <a:defRPr sz="1275">
+                <a:solidFill>
+                  <a:srgbClr val="94AFA7"/>
                 </a:solidFill>
                 <a:latin typeface="Helvetica Neue"/>
                 <a:ea typeface="Helvetica Neue"/>
@@ -1566,15 +1662,15 @@
               </a:defRPr>
             </a:pPr>
             <a:r>
-              <a:rPr sz="7050" b="1">
-                <a:solidFill>
-                  <a:srgbClr val="FFFFFF"/>
+              <a:rPr sz="1275">
+                <a:solidFill>
+                  <a:srgbClr val="94AFA7"/>
                 </a:solidFill>
                 <a:latin typeface="Helvetica Neue"/>
                 <a:ea typeface="Helvetica Neue"/>
                 <a:cs typeface="Helvetica Neue"/>
               </a:rPr>
-              <a:t>TapeDeck</a:t>
+              <a:t>1 / 6</a:t>
             </a:r>
           </a:p>
         </p:txBody>
@@ -1584,7 +1680,7 @@
           <p:cNvPr id="3" name="text-2">
             <a:extLst xmlns:a="http://schemas.openxmlformats.org/drawingml/2006/main">
               <a:ext uri="{FF2B5EF4-FFF2-40B4-BE49-F238E27FC236}">
-                <a16:creationId xmlns:a16="http://schemas.microsoft.com/office/drawing/2014/main" id="{C7AED863-AEA3-4F97-AB54-FF9BAD143CD4}"/>
+                <a16:creationId xmlns:a16="http://schemas.microsoft.com/office/drawing/2014/main" id="{6A280EE0-933D-4236-B66F-C03245BD5EEF}"/>
               </a:ext>
             </a:extLst>
           </p:cNvPr>
@@ -1595,8 +1691,8 @@
         </p:nvSpPr>
         <p:spPr>
           <a:xfrm xmlns:a="http://schemas.openxmlformats.org/drawingml/2006/main">
-            <a:off x="638175" y="2790825"/>
-            <a:ext cx="7239000" cy="1285875"/>
+            <a:off x="600075" y="1514475"/>
+            <a:ext cx="7210425" cy="1123950"/>
           </a:xfrm>
           <a:prstGeom xmlns:a="http://schemas.openxmlformats.org/drawingml/2006/main" prst="rect">
             <a:avLst/>
@@ -1613,7 +1709,7 @@
           <a:lstStyle xmlns:a="http://schemas.openxmlformats.org/drawingml/2006/main"/>
           <a:p xmlns:a="http://schemas.openxmlformats.org/drawingml/2006/main">
             <a:pPr>
-              <a:defRPr sz="3450">
+              <a:defRPr sz="7050" b="1">
                 <a:solidFill>
                   <a:srgbClr val="FFFFFF"/>
                 </a:solidFill>
@@ -1623,7 +1719,7 @@
               </a:defRPr>
             </a:pPr>
             <a:r>
-              <a:rPr sz="3450">
+              <a:rPr sz="7050" b="1">
                 <a:solidFill>
                   <a:srgbClr val="FFFFFF"/>
                 </a:solidFill>
@@ -1631,7 +1727,7 @@
                 <a:ea typeface="Helvetica Neue"/>
                 <a:cs typeface="Helvetica Neue"/>
               </a:rPr>
-              <a:t>Agent runs you can reopen</a:t>
+              <a:t>TapeDeck</a:t>
             </a:r>
           </a:p>
         </p:txBody>
@@ -1641,7 +1737,7 @@
           <p:cNvPr id="4" name="text-3">
             <a:extLst xmlns:a="http://schemas.openxmlformats.org/drawingml/2006/main">
               <a:ext uri="{FF2B5EF4-FFF2-40B4-BE49-F238E27FC236}">
-                <a16:creationId xmlns:a16="http://schemas.microsoft.com/office/drawing/2014/main" id="{2CE03C58-8B79-4BCC-ADFC-190517F86D67}"/>
+                <a16:creationId xmlns:a16="http://schemas.microsoft.com/office/drawing/2014/main" id="{E5B4FF14-80B9-4F7C-9342-56D97BEBEBBF}"/>
               </a:ext>
             </a:extLst>
           </p:cNvPr>
@@ -1652,8 +1748,8 @@
         </p:nvSpPr>
         <p:spPr>
           <a:xfrm xmlns:a="http://schemas.openxmlformats.org/drawingml/2006/main">
-            <a:off x="657225" y="5029200"/>
-            <a:ext cx="7143750" cy="457200"/>
+            <a:off x="628650" y="2943225"/>
+            <a:ext cx="7191375" cy="1390650"/>
           </a:xfrm>
           <a:prstGeom xmlns:a="http://schemas.openxmlformats.org/drawingml/2006/main" prst="rect">
             <a:avLst/>
@@ -1670,9 +1766,9 @@
           <a:lstStyle xmlns:a="http://schemas.openxmlformats.org/drawingml/2006/main"/>
           <a:p xmlns:a="http://schemas.openxmlformats.org/drawingml/2006/main">
             <a:pPr>
-              <a:defRPr sz="2100">
-                <a:solidFill>
-                  <a:srgbClr val="00ED64"/>
+              <a:defRPr sz="3300">
+                <a:solidFill>
+                  <a:srgbClr val="FFFFFF"/>
                 </a:solidFill>
                 <a:latin typeface="Helvetica Neue"/>
                 <a:ea typeface="Helvetica Neue"/>
@@ -1680,15 +1776,38 @@
               </a:defRPr>
             </a:pPr>
             <a:r>
-              <a:rPr sz="2100">
-                <a:solidFill>
-                  <a:srgbClr val="00ED64"/>
+              <a:rPr sz="3300">
+                <a:solidFill>
+                  <a:srgbClr val="FFFFFF"/>
                 </a:solidFill>
                 <a:latin typeface="Helvetica Neue"/>
                 <a:ea typeface="Helvetica Neue"/>
                 <a:cs typeface="Helvetica Neue"/>
               </a:rPr>
-              <a:t>Local Qwen3.5 2B + MongoDB Atlas</a:t>
+              <a:t>A failed agent run needs</a:t>
+            </a:r>
+          </a:p>
+          <a:p xmlns:a="http://schemas.openxmlformats.org/drawingml/2006/main">
+            <a:pPr>
+              <a:defRPr sz="3300">
+                <a:solidFill>
+                  <a:srgbClr val="FFFFFF"/>
+                </a:solidFill>
+                <a:latin typeface="Helvetica Neue"/>
+                <a:ea typeface="Helvetica Neue"/>
+                <a:cs typeface="Helvetica Neue"/>
+              </a:defRPr>
+            </a:pPr>
+            <a:r>
+              <a:rPr sz="3300">
+                <a:solidFill>
+                  <a:srgbClr val="FFFFFF"/>
+                </a:solidFill>
+                <a:latin typeface="Helvetica Neue"/>
+                <a:ea typeface="Helvetica Neue"/>
+                <a:cs typeface="Helvetica Neue"/>
+              </a:rPr>
+              <a:t>more than a chat log</a:t>
             </a:r>
           </a:p>
         </p:txBody>
@@ -1698,7 +1817,7 @@
           <p:cNvPr id="5" name="text-4">
             <a:extLst xmlns:a="http://schemas.openxmlformats.org/drawingml/2006/main">
               <a:ext uri="{FF2B5EF4-FFF2-40B4-BE49-F238E27FC236}">
-                <a16:creationId xmlns:a16="http://schemas.microsoft.com/office/drawing/2014/main" id="{1843482A-BFBB-4E49-AEF6-FC5C0E2F5821}"/>
+                <a16:creationId xmlns:a16="http://schemas.microsoft.com/office/drawing/2014/main" id="{760C168B-7977-44F2-BC07-40FDEB9B71C7}"/>
               </a:ext>
             </a:extLst>
           </p:cNvPr>
@@ -1709,8 +1828,8 @@
         </p:nvSpPr>
         <p:spPr>
           <a:xfrm xmlns:a="http://schemas.openxmlformats.org/drawingml/2006/main">
-            <a:off x="657225" y="5743575"/>
-            <a:ext cx="7143750" cy="361950"/>
+            <a:off x="638175" y="5048250"/>
+            <a:ext cx="10572750" cy="590550"/>
           </a:xfrm>
           <a:prstGeom xmlns:a="http://schemas.openxmlformats.org/drawingml/2006/main" prst="rect">
             <a:avLst/>
@@ -1727,9 +1846,9 @@
           <a:lstStyle xmlns:a="http://schemas.openxmlformats.org/drawingml/2006/main"/>
           <a:p xmlns:a="http://schemas.openxmlformats.org/drawingml/2006/main">
             <a:pPr>
-              <a:defRPr sz="1650">
-                <a:solidFill>
-                  <a:srgbClr val="A5BEB5"/>
+              <a:defRPr sz="2250">
+                <a:solidFill>
+                  <a:srgbClr val="00ED64"/>
                 </a:solidFill>
                 <a:latin typeface="Helvetica Neue"/>
                 <a:ea typeface="Helvetica Neue"/>
@@ -1737,25 +1856,25 @@
               </a:defRPr>
             </a:pPr>
             <a:r>
-              <a:rPr sz="1650">
-                <a:solidFill>
-                  <a:srgbClr val="A5BEB5"/>
+              <a:rPr sz="2250">
+                <a:solidFill>
+                  <a:srgbClr val="00ED64"/>
                 </a:solidFill>
                 <a:latin typeface="Helvetica Neue"/>
                 <a:ea typeface="Helvetica Neue"/>
                 <a:cs typeface="Helvetica Neue"/>
               </a:rPr>
-              <a:t>MongoDB Hackathon  /  60-second pitch</a:t>
-            </a:r>
-          </a:p>
-        </p:txBody>
-      </p:sp>
-      <p:sp>
-        <p:nvSpPr>
-          <p:cNvPr id="6" name="">
+              <a:t>Save the experiment as an executable image</a:t>
+            </a:r>
+          </a:p>
+        </p:txBody>
+      </p:sp>
+      <p:sp>
+        <p:nvSpPr>
+          <p:cNvPr id="6" name="text-5">
             <a:extLst xmlns:a="http://schemas.openxmlformats.org/drawingml/2006/main">
               <a:ext uri="{FF2B5EF4-FFF2-40B4-BE49-F238E27FC236}">
-                <a16:creationId xmlns:a16="http://schemas.microsoft.com/office/drawing/2014/main" id="{C994976B-29C3-4E32-90D8-4DCD40F351A2}"/>
+                <a16:creationId xmlns:a16="http://schemas.microsoft.com/office/drawing/2014/main" id="{30493E03-36E1-4015-A03C-E9E17B676767}"/>
               </a:ext>
             </a:extLst>
           </p:cNvPr>
@@ -1766,8 +1885,65 @@
         </p:nvSpPr>
         <p:spPr>
           <a:xfrm xmlns:a="http://schemas.openxmlformats.org/drawingml/2006/main">
-            <a:off x="8239125" y="2266950"/>
-            <a:ext cx="3000375" cy="1981200"/>
+            <a:off x="647700" y="5905500"/>
+            <a:ext cx="10372725" cy="400050"/>
+          </a:xfrm>
+          <a:prstGeom xmlns:a="http://schemas.openxmlformats.org/drawingml/2006/main" prst="rect">
+            <a:avLst/>
+          </a:prstGeom>
+          <a:noFill xmlns:a="http://schemas.openxmlformats.org/drawingml/2006/main"/>
+          <a:ln xmlns:a="http://schemas.openxmlformats.org/drawingml/2006/main" w="0">
+            <a:noFill/>
+          </a:ln>
+        </p:spPr>
+        <p:txBody>
+          <a:bodyPr xmlns:a="http://schemas.openxmlformats.org/drawingml/2006/main">
+            <a:noAutofit/>
+          </a:bodyPr>
+          <a:lstStyle xmlns:a="http://schemas.openxmlformats.org/drawingml/2006/main"/>
+          <a:p xmlns:a="http://schemas.openxmlformats.org/drawingml/2006/main">
+            <a:pPr>
+              <a:defRPr sz="1875">
+                <a:solidFill>
+                  <a:srgbClr val="AEC6BC"/>
+                </a:solidFill>
+                <a:latin typeface="Helvetica Neue"/>
+                <a:ea typeface="Helvetica Neue"/>
+                <a:cs typeface="Helvetica Neue"/>
+              </a:defRPr>
+            </a:pPr>
+            <a:r>
+              <a:rPr sz="1875">
+                <a:solidFill>
+                  <a:srgbClr val="AEC6BC"/>
+                </a:solidFill>
+                <a:latin typeface="Helvetica Neue"/>
+                <a:ea typeface="Helvetica Neue"/>
+                <a:cs typeface="Helvetica Neue"/>
+              </a:rPr>
+              <a:t>Local Qwen3.5 2B + Pharo + MongoDB Atlas</a:t>
+            </a:r>
+          </a:p>
+        </p:txBody>
+      </p:sp>
+      <p:sp>
+        <p:nvSpPr>
+          <p:cNvPr id="7" name="">
+            <a:extLst xmlns:a="http://schemas.openxmlformats.org/drawingml/2006/main">
+              <a:ext uri="{FF2B5EF4-FFF2-40B4-BE49-F238E27FC236}">
+                <a16:creationId xmlns:a16="http://schemas.microsoft.com/office/drawing/2014/main" id="{61F227C6-13F5-4A50-AB5C-479A64B523A6}"/>
+              </a:ext>
+            </a:extLst>
+          </p:cNvPr>
+          <p:cNvSpPr>
+            <a:spLocks xmlns:a="http://schemas.openxmlformats.org/drawingml/2006/main" noGrp="1"/>
+          </p:cNvSpPr>
+          <p:nvPr/>
+        </p:nvSpPr>
+        <p:spPr>
+          <a:xfrm xmlns:a="http://schemas.openxmlformats.org/drawingml/2006/main">
+            <a:off x="8448675" y="2581275"/>
+            <a:ext cx="2714625" cy="1704975"/>
           </a:xfrm>
           <a:prstGeom xmlns:a="http://schemas.openxmlformats.org/drawingml/2006/main" prst="rect">
             <a:avLst/>
@@ -1782,10 +1958,10 @@
       </p:sp>
       <p:sp>
         <p:nvSpPr>
-          <p:cNvPr id="7" name="">
+          <p:cNvPr id="8" name="">
             <a:extLst xmlns:a="http://schemas.openxmlformats.org/drawingml/2006/main">
               <a:ext uri="{FF2B5EF4-FFF2-40B4-BE49-F238E27FC236}">
-                <a16:creationId xmlns:a16="http://schemas.microsoft.com/office/drawing/2014/main" id="{7AD06EF2-2682-4147-B989-1B8BC12EF132}"/>
+                <a16:creationId xmlns:a16="http://schemas.microsoft.com/office/drawing/2014/main" id="{F736CC6F-A25D-4405-B4F0-45FDCA9587F6}"/>
               </a:ext>
             </a:extLst>
           </p:cNvPr>
@@ -1796,8 +1972,8 @@
         </p:nvSpPr>
         <p:spPr>
           <a:xfrm xmlns:a="http://schemas.openxmlformats.org/drawingml/2006/main">
-            <a:off x="8467725" y="2486025"/>
-            <a:ext cx="2543175" cy="1390650"/>
+            <a:off x="8658225" y="2781300"/>
+            <a:ext cx="2295525" cy="1057275"/>
           </a:xfrm>
           <a:prstGeom xmlns:a="http://schemas.openxmlformats.org/drawingml/2006/main" prst="rect">
             <a:avLst/>
@@ -1812,10 +1988,10 @@
       </p:sp>
       <p:sp>
         <p:nvSpPr>
-          <p:cNvPr id="8" name="">
+          <p:cNvPr id="9" name="">
             <a:extLst xmlns:a="http://schemas.openxmlformats.org/drawingml/2006/main">
               <a:ext uri="{FF2B5EF4-FFF2-40B4-BE49-F238E27FC236}">
-                <a16:creationId xmlns:a16="http://schemas.microsoft.com/office/drawing/2014/main" id="{6166133E-C71E-4920-B147-159354889E5E}"/>
+                <a16:creationId xmlns:a16="http://schemas.microsoft.com/office/drawing/2014/main" id="{6146156A-A517-45C6-BC64-2D53DBC3AA35}"/>
               </a:ext>
             </a:extLst>
           </p:cNvPr>
@@ -1826,8 +2002,8 @@
         </p:nvSpPr>
         <p:spPr>
           <a:xfrm xmlns:a="http://schemas.openxmlformats.org/drawingml/2006/main">
-            <a:off x="8801100" y="2886075"/>
-            <a:ext cx="533400" cy="533400"/>
+            <a:off x="8953500" y="3038475"/>
+            <a:ext cx="485775" cy="485775"/>
           </a:xfrm>
           <a:prstGeom xmlns:a="http://schemas.openxmlformats.org/drawingml/2006/main" prst="ellipse">
             <a:avLst/>
@@ -1842,10 +2018,10 @@
       </p:sp>
       <p:sp>
         <p:nvSpPr>
-          <p:cNvPr id="9" name="">
+          <p:cNvPr id="10" name="">
             <a:extLst xmlns:a="http://schemas.openxmlformats.org/drawingml/2006/main">
               <a:ext uri="{FF2B5EF4-FFF2-40B4-BE49-F238E27FC236}">
-                <a16:creationId xmlns:a16="http://schemas.microsoft.com/office/drawing/2014/main" id="{152A235D-ACF5-4F69-BA20-B99BA3204F9F}"/>
+                <a16:creationId xmlns:a16="http://schemas.microsoft.com/office/drawing/2014/main" id="{88D03414-3798-4224-88A4-587A8ACD080C}"/>
               </a:ext>
             </a:extLst>
           </p:cNvPr>
@@ -1856,8 +2032,8 @@
         </p:nvSpPr>
         <p:spPr>
           <a:xfrm xmlns:a="http://schemas.openxmlformats.org/drawingml/2006/main">
-            <a:off x="10144125" y="2886075"/>
-            <a:ext cx="533400" cy="533400"/>
+            <a:off x="10182225" y="3038475"/>
+            <a:ext cx="485775" cy="485775"/>
           </a:xfrm>
           <a:prstGeom xmlns:a="http://schemas.openxmlformats.org/drawingml/2006/main" prst="ellipse">
             <a:avLst/>
@@ -1872,10 +2048,10 @@
       </p:sp>
       <p:sp>
         <p:nvSpPr>
-          <p:cNvPr id="10" name="">
+          <p:cNvPr id="11" name="">
             <a:extLst xmlns:a="http://schemas.openxmlformats.org/drawingml/2006/main">
               <a:ext uri="{FF2B5EF4-FFF2-40B4-BE49-F238E27FC236}">
-                <a16:creationId xmlns:a16="http://schemas.microsoft.com/office/drawing/2014/main" id="{1B4755B0-C1D7-422C-95BB-EA971C3F1EBC}"/>
+                <a16:creationId xmlns:a16="http://schemas.microsoft.com/office/drawing/2014/main" id="{947248ED-C409-4DF7-89CA-041FAFBBD724}"/>
               </a:ext>
             </a:extLst>
           </p:cNvPr>
@@ -1886,8 +2062,8 @@
         </p:nvSpPr>
         <p:spPr>
           <a:xfrm xmlns:a="http://schemas.openxmlformats.org/drawingml/2006/main">
-            <a:off x="9344025" y="3143250"/>
-            <a:ext cx="800100" cy="19050"/>
+            <a:off x="9439275" y="3276600"/>
+            <a:ext cx="742950" cy="19050"/>
           </a:xfrm>
           <a:prstGeom xmlns:a="http://schemas.openxmlformats.org/drawingml/2006/main" prst="rect">
             <a:avLst/>
@@ -1902,10 +2078,10 @@
       </p:sp>
       <p:sp>
         <p:nvSpPr>
-          <p:cNvPr id="11" name="text-10">
+          <p:cNvPr id="12" name="text-11">
             <a:extLst xmlns:a="http://schemas.openxmlformats.org/drawingml/2006/main">
               <a:ext uri="{FF2B5EF4-FFF2-40B4-BE49-F238E27FC236}">
-                <a16:creationId xmlns:a16="http://schemas.microsoft.com/office/drawing/2014/main" id="{E966B53E-F804-4FDD-B250-6B968FEFA98A}"/>
+                <a16:creationId xmlns:a16="http://schemas.microsoft.com/office/drawing/2014/main" id="{0B21F99C-4BD0-4283-87EA-F362BC83E807}"/>
               </a:ext>
             </a:extLst>
           </p:cNvPr>
@@ -1916,8 +2092,8 @@
         </p:nvSpPr>
         <p:spPr>
           <a:xfrm xmlns:a="http://schemas.openxmlformats.org/drawingml/2006/main">
-            <a:off x="8639175" y="4400550"/>
-            <a:ext cx="2667000" cy="457200"/>
+            <a:off x="8743950" y="4448175"/>
+            <a:ext cx="2638425" cy="409575"/>
           </a:xfrm>
           <a:prstGeom xmlns:a="http://schemas.openxmlformats.org/drawingml/2006/main" prst="rect">
             <a:avLst/>
@@ -1934,7 +2110,7 @@
           <a:lstStyle xmlns:a="http://schemas.openxmlformats.org/drawingml/2006/main"/>
           <a:p xmlns:a="http://schemas.openxmlformats.org/drawingml/2006/main">
             <a:pPr>
-              <a:defRPr sz="2175">
+              <a:defRPr sz="2100">
                 <a:solidFill>
                   <a:srgbClr val="00ED64"/>
                 </a:solidFill>
@@ -1944,7 +2120,7 @@
               </a:defRPr>
             </a:pPr>
             <a:r>
-              <a:rPr sz="2175">
+              <a:rPr sz="2100">
                 <a:solidFill>
                   <a:srgbClr val="00ED64"/>
                 </a:solidFill>
@@ -1960,7 +2136,7 @@
     </p:spTree>
     <p:extLst>
       <p:ext uri="{BB962C8B-B14F-4D97-AF65-F5344CB8AC3E}">
-        <p14:creationId xmlns:p14="http://schemas.microsoft.com/office/powerpoint/2010/main" val="2042016801"/>
+        <p14:creationId xmlns:p14="http://schemas.microsoft.com/office/powerpoint/2010/main" val="907326849"/>
       </p:ext>
     </p:extLst>
   </p:cSld>
@@ -1988,10 +2164,10 @@
       </p:grpSpPr>
       <p:sp>
         <p:nvSpPr>
-          <p:cNvPr id="6" name="text-0">
+          <p:cNvPr id="11" name="text-0">
             <a:extLst xmlns:a="http://schemas.openxmlformats.org/drawingml/2006/main">
               <a:ext uri="{FF2B5EF4-FFF2-40B4-BE49-F238E27FC236}">
-                <a16:creationId xmlns:a16="http://schemas.microsoft.com/office/drawing/2014/main" id="{6F0A6619-47B1-4561-95F2-F8814EA942DA}"/>
+                <a16:creationId xmlns:a16="http://schemas.microsoft.com/office/drawing/2014/main" id="{553F0426-9867-41F9-A678-850A92B7C664}"/>
               </a:ext>
             </a:extLst>
           </p:cNvPr>
@@ -2002,8 +2178,8 @@
         </p:nvSpPr>
         <p:spPr>
           <a:xfrm xmlns:a="http://schemas.openxmlformats.org/drawingml/2006/main">
-            <a:off x="609600" y="457200"/>
-            <a:ext cx="10972800" cy="1000125"/>
+            <a:off x="619125" y="314325"/>
+            <a:ext cx="10934700" cy="304800"/>
           </a:xfrm>
           <a:prstGeom xmlns:a="http://schemas.openxmlformats.org/drawingml/2006/main" prst="rect">
             <a:avLst/>
@@ -2020,9 +2196,9 @@
           <a:lstStyle xmlns:a="http://schemas.openxmlformats.org/drawingml/2006/main"/>
           <a:p xmlns:a="http://schemas.openxmlformats.org/drawingml/2006/main">
             <a:pPr>
-              <a:defRPr sz="3450" b="1">
-                <a:solidFill>
-                  <a:srgbClr val="001E2B"/>
+              <a:defRPr sz="1575" b="1">
+                <a:solidFill>
+                  <a:srgbClr val="007E54"/>
                 </a:solidFill>
                 <a:latin typeface="Helvetica Neue"/>
                 <a:ea typeface="Helvetica Neue"/>
@@ -2030,15 +2206,15 @@
               </a:defRPr>
             </a:pPr>
             <a:r>
-              <a:rPr sz="3450" b="1">
-                <a:solidFill>
-                  <a:srgbClr val="001E2B"/>
+              <a:rPr sz="1575" b="1">
+                <a:solidFill>
+                  <a:srgbClr val="007E54"/>
                 </a:solidFill>
                 <a:latin typeface="Helvetica Neue"/>
                 <a:ea typeface="Helvetica Neue"/>
                 <a:cs typeface="Helvetica Neue"/>
               </a:rPr>
-              <a:t>Real Qwen3.5 2B, zero-call replay</a:t>
+              <a:t>TECHNICAL DEMO 35%</a:t>
             </a:r>
           </a:p>
         </p:txBody>
@@ -2048,7 +2224,7 @@
           <p:cNvPr id="2" name="text-1">
             <a:extLst xmlns:a="http://schemas.openxmlformats.org/drawingml/2006/main">
               <a:ext uri="{FF2B5EF4-FFF2-40B4-BE49-F238E27FC236}">
-                <a16:creationId xmlns:a16="http://schemas.microsoft.com/office/drawing/2014/main" id="{BE95DBBB-794E-4B8F-AD5C-0BEB12F44E93}"/>
+                <a16:creationId xmlns:a16="http://schemas.microsoft.com/office/drawing/2014/main" id="{D077CCC7-76E8-4E7C-8A63-434D839D3DBB}"/>
               </a:ext>
             </a:extLst>
           </p:cNvPr>
@@ -2059,8 +2235,8 @@
         </p:nvSpPr>
         <p:spPr>
           <a:xfrm xmlns:a="http://schemas.openxmlformats.org/drawingml/2006/main">
-            <a:off x="10953750" y="6362700"/>
-            <a:ext cx="762000" cy="266700"/>
+            <a:off x="609600" y="885825"/>
+            <a:ext cx="10991850" cy="1047750"/>
           </a:xfrm>
           <a:prstGeom xmlns:a="http://schemas.openxmlformats.org/drawingml/2006/main" prst="rect">
             <a:avLst/>
@@ -2077,9 +2253,9 @@
           <a:lstStyle xmlns:a="http://schemas.openxmlformats.org/drawingml/2006/main"/>
           <a:p xmlns:a="http://schemas.openxmlformats.org/drawingml/2006/main">
             <a:pPr>
-              <a:defRPr sz="1275">
-                <a:solidFill>
-                  <a:srgbClr val="52666C"/>
+              <a:defRPr sz="3525" b="1">
+                <a:solidFill>
+                  <a:srgbClr val="001E2B"/>
                 </a:solidFill>
                 <a:latin typeface="Helvetica Neue"/>
                 <a:ea typeface="Helvetica Neue"/>
@@ -2087,15 +2263,15 @@
               </a:defRPr>
             </a:pPr>
             <a:r>
-              <a:rPr sz="1275">
-                <a:solidFill>
-                  <a:srgbClr val="52666C"/>
+              <a:rPr sz="3525" b="1">
+                <a:solidFill>
+                  <a:srgbClr val="001E2B"/>
                 </a:solidFill>
                 <a:latin typeface="Helvetica Neue"/>
                 <a:ea typeface="Helvetica Neue"/>
                 <a:cs typeface="Helvetica Neue"/>
               </a:rPr>
-              <a:t>2 / 5</a:t>
+              <a:t>Real Qwen3.5 2B fixes the bug</a:t>
             </a:r>
           </a:p>
         </p:txBody>
@@ -2105,7 +2281,7 @@
           <p:cNvPr id="3" name="text-2">
             <a:extLst xmlns:a="http://schemas.openxmlformats.org/drawingml/2006/main">
               <a:ext uri="{FF2B5EF4-FFF2-40B4-BE49-F238E27FC236}">
-                <a16:creationId xmlns:a16="http://schemas.microsoft.com/office/drawing/2014/main" id="{B9FE2EB2-AE53-42A5-AA7E-007C1B05193F}"/>
+                <a16:creationId xmlns:a16="http://schemas.microsoft.com/office/drawing/2014/main" id="{19E288B0-B158-4BFA-8DF7-618206054DF4}"/>
               </a:ext>
             </a:extLst>
           </p:cNvPr>
@@ -2116,8 +2292,8 @@
         </p:nvSpPr>
         <p:spPr>
           <a:xfrm xmlns:a="http://schemas.openxmlformats.org/drawingml/2006/main">
-            <a:off x="628650" y="1571625"/>
-            <a:ext cx="10934700" cy="504825"/>
+            <a:off x="10972800" y="6372225"/>
+            <a:ext cx="742950" cy="266700"/>
           </a:xfrm>
           <a:prstGeom xmlns:a="http://schemas.openxmlformats.org/drawingml/2006/main" prst="rect">
             <a:avLst/>
@@ -2134,7 +2310,7 @@
           <a:lstStyle xmlns:a="http://schemas.openxmlformats.org/drawingml/2006/main"/>
           <a:p xmlns:a="http://schemas.openxmlformats.org/drawingml/2006/main">
             <a:pPr>
-              <a:defRPr sz="2175">
+              <a:defRPr sz="1275">
                 <a:solidFill>
                   <a:srgbClr val="52666C"/>
                 </a:solidFill>
@@ -2144,7 +2320,7 @@
               </a:defRPr>
             </a:pPr>
             <a:r>
-              <a:rPr sz="2175">
+              <a:rPr sz="1275">
                 <a:solidFill>
                   <a:srgbClr val="52666C"/>
                 </a:solidFill>
@@ -2152,31 +2328,31 @@
                 <a:ea typeface="Helvetica Neue"/>
                 <a:cs typeface="Helvetica Neue"/>
               </a:rPr>
-              <a:t>Task: repair a JavaScript sum function</a:t>
+              <a:t>2 / 6</a:t>
             </a:r>
           </a:p>
         </p:txBody>
       </p:sp>
       <p:graphicFrame>
         <p:nvGraphicFramePr>
-          <p:cNvPr id="9" name=""/>
+          <p:cNvPr id="14" name=""/>
           <p:cNvGraphicFramePr/>
           <p:nvPr/>
         </p:nvGraphicFramePr>
         <p:xfrm>
-          <a:off xmlns:a="http://schemas.openxmlformats.org/drawingml/2006/main" x="628650" y="2305050"/>
-          <a:ext xmlns:a="http://schemas.openxmlformats.org/drawingml/2006/main" cx="10934700" cy="3105150"/>
+          <a:off xmlns:a="http://schemas.openxmlformats.org/drawingml/2006/main" x="619125" y="2247900"/>
+          <a:ext xmlns:a="http://schemas.openxmlformats.org/drawingml/2006/main" cx="6962775" cy="3095625"/>
         </p:xfrm>
         <a:graphic xmlns:a="http://schemas.openxmlformats.org/drawingml/2006/main">
           <a:graphicData uri="http://schemas.openxmlformats.org/drawingml/2006/table">
             <a:tbl>
               <a:tblPr/>
               <a:tblGrid>
-                <a:gridCol w="4419600"/>
-                <a:gridCol w="3295650"/>
-                <a:gridCol w="3219450"/>
+                <a:gridCol w="2971800"/>
+                <a:gridCol w="1657350"/>
+                <a:gridCol w="2333625"/>
               </a:tblGrid>
-              <a:tr h="628650">
+              <a:tr h="619125">
                 <a:tc>
                   <a:txBody>
                     <a:bodyPr/>
@@ -2215,7 +2391,7 @@
                           <a:ea typeface="Helvetica Neue"/>
                           <a:cs typeface="Helvetica Neue"/>
                         </a:rPr>
-                        <a:t>Live model calls</a:t>
+                        <a:t>Calls</a:t>
                       </a:r>
                     </a:p>
                   </a:txBody>
@@ -2239,7 +2415,7 @@
                           <a:ea typeface="Helvetica Neue"/>
                           <a:cs typeface="Helvetica Neue"/>
                         </a:rPr>
-                        <a:t>Task verifier</a:t>
+                        <a:t>Verifier</a:t>
                       </a:r>
                     </a:p>
                   </a:txBody>
@@ -2265,7 +2441,7 @@
                           <a:ea typeface="Helvetica Neue"/>
                           <a:cs typeface="Helvetica Neue"/>
                         </a:rPr>
-                        <a:t>Original run</a:t>
+                        <a:t>Record</a:t>
                       </a:r>
                     </a:p>
                   </a:txBody>
@@ -2339,7 +2515,7 @@
                           <a:ea typeface="Helvetica Neue"/>
                           <a:cs typeface="Helvetica Neue"/>
                         </a:rPr>
-                        <a:t>Strict replay</a:t>
+                        <a:t>Replay</a:t>
                       </a:r>
                     </a:p>
                   </a:txBody>
@@ -2511,7 +2687,7 @@
                           <a:ea typeface="Helvetica Neue"/>
                           <a:cs typeface="Helvetica Neue"/>
                         </a:rPr>
-                        <a:t>6</a:t>
+                        <a:t>4</a:t>
                       </a:r>
                     </a:p>
                   </a:txBody>
@@ -2555,7 +2731,7 @@
           <p:cNvPr id="5" name="text-3">
             <a:extLst xmlns:a="http://schemas.openxmlformats.org/drawingml/2006/main">
               <a:ext uri="{FF2B5EF4-FFF2-40B4-BE49-F238E27FC236}">
-                <a16:creationId xmlns:a16="http://schemas.microsoft.com/office/drawing/2014/main" id="{1E891629-8F84-4C01-8EC4-5AE5F37FA192}"/>
+                <a16:creationId xmlns:a16="http://schemas.microsoft.com/office/drawing/2014/main" id="{596DCD28-A37D-4A2E-B943-7AD282868164}"/>
               </a:ext>
             </a:extLst>
           </p:cNvPr>
@@ -2566,8 +2742,8 @@
         </p:nvSpPr>
         <p:spPr>
           <a:xfrm xmlns:a="http://schemas.openxmlformats.org/drawingml/2006/main">
-            <a:off x="628650" y="5810250"/>
-            <a:ext cx="10915650" cy="419100"/>
+            <a:off x="8134350" y="2200275"/>
+            <a:ext cx="3438525" cy="533400"/>
           </a:xfrm>
           <a:prstGeom xmlns:a="http://schemas.openxmlformats.org/drawingml/2006/main" prst="rect">
             <a:avLst/>
@@ -2584,9 +2760,9 @@
           <a:lstStyle xmlns:a="http://schemas.openxmlformats.org/drawingml/2006/main"/>
           <a:p xmlns:a="http://schemas.openxmlformats.org/drawingml/2006/main">
             <a:pPr>
-              <a:defRPr sz="1800">
-                <a:solidFill>
-                  <a:srgbClr val="52666C"/>
+              <a:defRPr sz="2250" b="1">
+                <a:solidFill>
+                  <a:srgbClr val="001E2B"/>
                 </a:solidFill>
                 <a:latin typeface="Helvetica Neue"/>
                 <a:ea typeface="Helvetica Neue"/>
@@ -2594,15 +2770,300 @@
               </a:defRPr>
             </a:pPr>
             <a:r>
-              <a:rPr sz="1800">
+              <a:rPr sz="2250" b="1">
+                <a:solidFill>
+                  <a:srgbClr val="001E2B"/>
+                </a:solidFill>
+                <a:latin typeface="Helvetica Neue"/>
+                <a:ea typeface="Helvetica Neue"/>
+                <a:cs typeface="Helvetica Neue"/>
+              </a:rPr>
+              <a:t>Actual code change</a:t>
+            </a:r>
+          </a:p>
+        </p:txBody>
+      </p:sp>
+      <p:sp>
+        <p:nvSpPr>
+          <p:cNvPr id="6" name="text-4">
+            <a:extLst xmlns:a="http://schemas.openxmlformats.org/drawingml/2006/main">
+              <a:ext uri="{FF2B5EF4-FFF2-40B4-BE49-F238E27FC236}">
+                <a16:creationId xmlns:a16="http://schemas.microsoft.com/office/drawing/2014/main" id="{E925C2AB-E44B-48CB-8C32-3FC5151F19BA}"/>
+              </a:ext>
+            </a:extLst>
+          </p:cNvPr>
+          <p:cNvSpPr>
+            <a:spLocks xmlns:a="http://schemas.openxmlformats.org/drawingml/2006/main" noGrp="1"/>
+          </p:cNvSpPr>
+          <p:nvPr/>
+        </p:nvSpPr>
+        <p:spPr>
+          <a:xfrm xmlns:a="http://schemas.openxmlformats.org/drawingml/2006/main">
+            <a:off x="8134350" y="2952750"/>
+            <a:ext cx="3448050" cy="400050"/>
+          </a:xfrm>
+          <a:prstGeom xmlns:a="http://schemas.openxmlformats.org/drawingml/2006/main" prst="rect">
+            <a:avLst/>
+          </a:prstGeom>
+          <a:noFill xmlns:a="http://schemas.openxmlformats.org/drawingml/2006/main"/>
+          <a:ln xmlns:a="http://schemas.openxmlformats.org/drawingml/2006/main" w="0">
+            <a:noFill/>
+          </a:ln>
+        </p:spPr>
+        <p:txBody>
+          <a:bodyPr xmlns:a="http://schemas.openxmlformats.org/drawingml/2006/main">
+            <a:noAutofit/>
+          </a:bodyPr>
+          <a:lstStyle xmlns:a="http://schemas.openxmlformats.org/drawingml/2006/main"/>
+          <a:p xmlns:a="http://schemas.openxmlformats.org/drawingml/2006/main">
+            <a:pPr>
+              <a:defRPr sz="1875">
                 <a:solidFill>
                   <a:srgbClr val="52666C"/>
                 </a:solidFill>
                 <a:latin typeface="Helvetica Neue"/>
                 <a:ea typeface="Helvetica Neue"/>
                 <a:cs typeface="Helvetica Neue"/>
+              </a:defRPr>
+            </a:pPr>
+            <a:r>
+              <a:rPr sz="1875">
+                <a:solidFill>
+                  <a:srgbClr val="52666C"/>
+                </a:solidFill>
+                <a:latin typeface="Helvetica Neue"/>
+                <a:ea typeface="Helvetica Neue"/>
+                <a:cs typeface="Helvetica Neue"/>
               </a:rPr>
-              <a:t>One fixture, not a model benchmark. Replay has no new test verdict.</a:t>
+              <a:t>src/sum.js</a:t>
+            </a:r>
+          </a:p>
+        </p:txBody>
+      </p:sp>
+      <p:sp>
+        <p:nvSpPr>
+          <p:cNvPr id="7" name="text-5">
+            <a:extLst xmlns:a="http://schemas.openxmlformats.org/drawingml/2006/main">
+              <a:ext uri="{FF2B5EF4-FFF2-40B4-BE49-F238E27FC236}">
+                <a16:creationId xmlns:a16="http://schemas.microsoft.com/office/drawing/2014/main" id="{2E44DBAA-3664-48B5-88AB-A4EC4D5D90C0}"/>
+              </a:ext>
+            </a:extLst>
+          </p:cNvPr>
+          <p:cNvSpPr>
+            <a:spLocks xmlns:a="http://schemas.openxmlformats.org/drawingml/2006/main" noGrp="1"/>
+          </p:cNvSpPr>
+          <p:nvPr/>
+        </p:nvSpPr>
+        <p:spPr>
+          <a:xfrm xmlns:a="http://schemas.openxmlformats.org/drawingml/2006/main">
+            <a:off x="8134350" y="3667125"/>
+            <a:ext cx="3524250" cy="533400"/>
+          </a:xfrm>
+          <a:prstGeom xmlns:a="http://schemas.openxmlformats.org/drawingml/2006/main" prst="rect">
+            <a:avLst/>
+          </a:prstGeom>
+          <a:noFill xmlns:a="http://schemas.openxmlformats.org/drawingml/2006/main"/>
+          <a:ln xmlns:a="http://schemas.openxmlformats.org/drawingml/2006/main" w="0">
+            <a:noFill/>
+          </a:ln>
+        </p:spPr>
+        <p:txBody>
+          <a:bodyPr xmlns:a="http://schemas.openxmlformats.org/drawingml/2006/main">
+            <a:noAutofit/>
+          </a:bodyPr>
+          <a:lstStyle xmlns:a="http://schemas.openxmlformats.org/drawingml/2006/main"/>
+          <a:p xmlns:a="http://schemas.openxmlformats.org/drawingml/2006/main">
+            <a:pPr>
+              <a:defRPr sz="2175">
+                <a:solidFill>
+                  <a:srgbClr val="A03838"/>
+                </a:solidFill>
+                <a:latin typeface="Helvetica Neue"/>
+                <a:ea typeface="Helvetica Neue"/>
+                <a:cs typeface="Helvetica Neue"/>
+              </a:defRPr>
+            </a:pPr>
+            <a:r>
+              <a:rPr sz="2175">
+                <a:solidFill>
+                  <a:srgbClr val="A03838"/>
+                </a:solidFill>
+                <a:latin typeface="Helvetica Neue"/>
+                <a:ea typeface="Helvetica Neue"/>
+                <a:cs typeface="Helvetica Neue"/>
+              </a:rPr>
+              <a:t>− return a − b;</a:t>
+            </a:r>
+          </a:p>
+        </p:txBody>
+      </p:sp>
+      <p:sp>
+        <p:nvSpPr>
+          <p:cNvPr id="8" name="text-6">
+            <a:extLst xmlns:a="http://schemas.openxmlformats.org/drawingml/2006/main">
+              <a:ext uri="{FF2B5EF4-FFF2-40B4-BE49-F238E27FC236}">
+                <a16:creationId xmlns:a16="http://schemas.microsoft.com/office/drawing/2014/main" id="{DA2B4649-DB31-41C2-9104-BD863BB7875E}"/>
+              </a:ext>
+            </a:extLst>
+          </p:cNvPr>
+          <p:cNvSpPr>
+            <a:spLocks xmlns:a="http://schemas.openxmlformats.org/drawingml/2006/main" noGrp="1"/>
+          </p:cNvSpPr>
+          <p:nvPr/>
+        </p:nvSpPr>
+        <p:spPr>
+          <a:xfrm xmlns:a="http://schemas.openxmlformats.org/drawingml/2006/main">
+            <a:off x="8134350" y="4305300"/>
+            <a:ext cx="3524250" cy="533400"/>
+          </a:xfrm>
+          <a:prstGeom xmlns:a="http://schemas.openxmlformats.org/drawingml/2006/main" prst="rect">
+            <a:avLst/>
+          </a:prstGeom>
+          <a:noFill xmlns:a="http://schemas.openxmlformats.org/drawingml/2006/main"/>
+          <a:ln xmlns:a="http://schemas.openxmlformats.org/drawingml/2006/main" w="0">
+            <a:noFill/>
+          </a:ln>
+        </p:spPr>
+        <p:txBody>
+          <a:bodyPr xmlns:a="http://schemas.openxmlformats.org/drawingml/2006/main">
+            <a:noAutofit/>
+          </a:bodyPr>
+          <a:lstStyle xmlns:a="http://schemas.openxmlformats.org/drawingml/2006/main"/>
+          <a:p xmlns:a="http://schemas.openxmlformats.org/drawingml/2006/main">
+            <a:pPr>
+              <a:defRPr sz="2175" b="1">
+                <a:solidFill>
+                  <a:srgbClr val="007E54"/>
+                </a:solidFill>
+                <a:latin typeface="Helvetica Neue"/>
+                <a:ea typeface="Helvetica Neue"/>
+                <a:cs typeface="Helvetica Neue"/>
+              </a:defRPr>
+            </a:pPr>
+            <a:r>
+              <a:rPr sz="2175" b="1">
+                <a:solidFill>
+                  <a:srgbClr val="007E54"/>
+                </a:solidFill>
+                <a:latin typeface="Helvetica Neue"/>
+                <a:ea typeface="Helvetica Neue"/>
+                <a:cs typeface="Helvetica Neue"/>
+              </a:rPr>
+              <a:t>+ return a + b;</a:t>
+            </a:r>
+          </a:p>
+        </p:txBody>
+      </p:sp>
+      <p:sp>
+        <p:nvSpPr>
+          <p:cNvPr id="9" name="text-7">
+            <a:extLst xmlns:a="http://schemas.openxmlformats.org/drawingml/2006/main">
+              <a:ext uri="{FF2B5EF4-FFF2-40B4-BE49-F238E27FC236}">
+                <a16:creationId xmlns:a16="http://schemas.microsoft.com/office/drawing/2014/main" id="{5C9BD2D0-637C-4417-9F29-D28B67E8AAF8}"/>
+              </a:ext>
+            </a:extLst>
+          </p:cNvPr>
+          <p:cNvSpPr>
+            <a:spLocks xmlns:a="http://schemas.openxmlformats.org/drawingml/2006/main" noGrp="1"/>
+          </p:cNvSpPr>
+          <p:nvPr/>
+        </p:nvSpPr>
+        <p:spPr>
+          <a:xfrm xmlns:a="http://schemas.openxmlformats.org/drawingml/2006/main">
+            <a:off x="619125" y="5667375"/>
+            <a:ext cx="10953750" cy="438150"/>
+          </a:xfrm>
+          <a:prstGeom xmlns:a="http://schemas.openxmlformats.org/drawingml/2006/main" prst="rect">
+            <a:avLst/>
+          </a:prstGeom>
+          <a:noFill xmlns:a="http://schemas.openxmlformats.org/drawingml/2006/main"/>
+          <a:ln xmlns:a="http://schemas.openxmlformats.org/drawingml/2006/main" w="0">
+            <a:noFill/>
+          </a:ln>
+        </p:spPr>
+        <p:txBody>
+          <a:bodyPr xmlns:a="http://schemas.openxmlformats.org/drawingml/2006/main">
+            <a:noAutofit/>
+          </a:bodyPr>
+          <a:lstStyle xmlns:a="http://schemas.openxmlformats.org/drawingml/2006/main"/>
+          <a:p xmlns:a="http://schemas.openxmlformats.org/drawingml/2006/main">
+            <a:pPr>
+              <a:defRPr sz="2025" b="1">
+                <a:solidFill>
+                  <a:srgbClr val="001E2B"/>
+                </a:solidFill>
+                <a:latin typeface="Helvetica Neue"/>
+                <a:ea typeface="Helvetica Neue"/>
+                <a:cs typeface="Helvetica Neue"/>
+              </a:defRPr>
+            </a:pPr>
+            <a:r>
+              <a:rPr sz="2025" b="1">
+                <a:solidFill>
+                  <a:srgbClr val="001E2B"/>
+                </a:solidFill>
+                <a:latin typeface="Helvetica Neue"/>
+                <a:ea typeface="Helvetica Neue"/>
+                <a:cs typeface="Helvetica Neue"/>
+              </a:rPr>
+              <a:t>Independent request counter. All three live verifiers pass.</a:t>
+            </a:r>
+          </a:p>
+        </p:txBody>
+      </p:sp>
+      <p:sp>
+        <p:nvSpPr>
+          <p:cNvPr id="10" name="text-8">
+            <a:extLst xmlns:a="http://schemas.openxmlformats.org/drawingml/2006/main">
+              <a:ext uri="{FF2B5EF4-FFF2-40B4-BE49-F238E27FC236}">
+                <a16:creationId xmlns:a16="http://schemas.microsoft.com/office/drawing/2014/main" id="{2A7C900E-770D-4AE7-B4C7-5DBF46FBE4D2}"/>
+              </a:ext>
+            </a:extLst>
+          </p:cNvPr>
+          <p:cNvSpPr>
+            <a:spLocks xmlns:a="http://schemas.openxmlformats.org/drawingml/2006/main" noGrp="1"/>
+          </p:cNvSpPr>
+          <p:nvPr/>
+        </p:nvSpPr>
+        <p:spPr>
+          <a:xfrm xmlns:a="http://schemas.openxmlformats.org/drawingml/2006/main">
+            <a:off x="619125" y="6162675"/>
+            <a:ext cx="10287000" cy="314325"/>
+          </a:xfrm>
+          <a:prstGeom xmlns:a="http://schemas.openxmlformats.org/drawingml/2006/main" prst="rect">
+            <a:avLst/>
+          </a:prstGeom>
+          <a:noFill xmlns:a="http://schemas.openxmlformats.org/drawingml/2006/main"/>
+          <a:ln xmlns:a="http://schemas.openxmlformats.org/drawingml/2006/main" w="0">
+            <a:noFill/>
+          </a:ln>
+        </p:spPr>
+        <p:txBody>
+          <a:bodyPr xmlns:a="http://schemas.openxmlformats.org/drawingml/2006/main">
+            <a:noAutofit/>
+          </a:bodyPr>
+          <a:lstStyle xmlns:a="http://schemas.openxmlformats.org/drawingml/2006/main"/>
+          <a:p xmlns:a="http://schemas.openxmlformats.org/drawingml/2006/main">
+            <a:pPr>
+              <a:defRPr sz="1575">
+                <a:solidFill>
+                  <a:srgbClr val="52666C"/>
+                </a:solidFill>
+                <a:latin typeface="Helvetica Neue"/>
+                <a:ea typeface="Helvetica Neue"/>
+                <a:cs typeface="Helvetica Neue"/>
+              </a:defRPr>
+            </a:pPr>
+            <a:r>
+              <a:rPr sz="1575">
+                <a:solidFill>
+                  <a:srgbClr val="52666C"/>
+                </a:solidFill>
+                <a:latin typeface="Helvetica Neue"/>
+                <a:ea typeface="Helvetica Neue"/>
+                <a:cs typeface="Helvetica Neue"/>
+              </a:rPr>
+              <a:t>One fixture, not a benchmark. Replay does not rerun the verifier.</a:t>
             </a:r>
           </a:p>
         </p:txBody>
@@ -2610,7 +3071,7 @@
     </p:spTree>
     <p:extLst>
       <p:ext uri="{BB962C8B-B14F-4D97-AF65-F5344CB8AC3E}">
-        <p14:creationId xmlns:p14="http://schemas.microsoft.com/office/powerpoint/2010/main" val="1220625369"/>
+        <p14:creationId xmlns:p14="http://schemas.microsoft.com/office/powerpoint/2010/main" val="403221168"/>
       </p:ext>
     </p:extLst>
   </p:cSld>
@@ -2638,10 +3099,10 @@
       </p:grpSpPr>
       <p:sp>
         <p:nvSpPr>
-          <p:cNvPr id="14" name="text-0">
+          <p:cNvPr id="15" name="text-0">
             <a:extLst xmlns:a="http://schemas.openxmlformats.org/drawingml/2006/main">
               <a:ext uri="{FF2B5EF4-FFF2-40B4-BE49-F238E27FC236}">
-                <a16:creationId xmlns:a16="http://schemas.microsoft.com/office/drawing/2014/main" id="{1BA321E7-0D99-4DA0-86DD-B4C56563F73C}"/>
+                <a16:creationId xmlns:a16="http://schemas.microsoft.com/office/drawing/2014/main" id="{7D8B7D47-7962-44EE-81A5-391A1F8F63AD}"/>
               </a:ext>
             </a:extLst>
           </p:cNvPr>
@@ -2652,8 +3113,8 @@
         </p:nvSpPr>
         <p:spPr>
           <a:xfrm xmlns:a="http://schemas.openxmlformats.org/drawingml/2006/main">
-            <a:off x="609600" y="457200"/>
-            <a:ext cx="10972800" cy="1000125"/>
+            <a:off x="619125" y="314325"/>
+            <a:ext cx="10934700" cy="304800"/>
           </a:xfrm>
           <a:prstGeom xmlns:a="http://schemas.openxmlformats.org/drawingml/2006/main" prst="rect">
             <a:avLst/>
@@ -2670,9 +3131,9 @@
           <a:lstStyle xmlns:a="http://schemas.openxmlformats.org/drawingml/2006/main"/>
           <a:p xmlns:a="http://schemas.openxmlformats.org/drawingml/2006/main">
             <a:pPr>
-              <a:defRPr sz="3450" b="1">
-                <a:solidFill>
-                  <a:srgbClr val="001E2B"/>
+              <a:defRPr sz="1575" b="1">
+                <a:solidFill>
+                  <a:srgbClr val="007E54"/>
                 </a:solidFill>
                 <a:latin typeface="Helvetica Neue"/>
                 <a:ea typeface="Helvetica Neue"/>
@@ -2680,15 +3141,15 @@
               </a:defRPr>
             </a:pPr>
             <a:r>
-              <a:rPr sz="3450" b="1">
-                <a:solidFill>
-                  <a:srgbClr val="001E2B"/>
+              <a:rPr sz="1575" b="1">
+                <a:solidFill>
+                  <a:srgbClr val="007E54"/>
                 </a:solidFill>
                 <a:latin typeface="Helvetica Neue"/>
                 <a:ea typeface="Helvetica Neue"/>
                 <a:cs typeface="Helvetica Neue"/>
               </a:rPr>
-              <a:t>MongoDB Atlas keeps the experiment</a:t>
+              <a:t>IMPLEMENTATION DIFFICULTY 30%</a:t>
             </a:r>
           </a:p>
         </p:txBody>
@@ -2698,7 +3159,7 @@
           <p:cNvPr id="2" name="text-1">
             <a:extLst xmlns:a="http://schemas.openxmlformats.org/drawingml/2006/main">
               <a:ext uri="{FF2B5EF4-FFF2-40B4-BE49-F238E27FC236}">
-                <a16:creationId xmlns:a16="http://schemas.microsoft.com/office/drawing/2014/main" id="{4ACC6B3E-464C-4FBA-B769-B0FAE156BA99}"/>
+                <a16:creationId xmlns:a16="http://schemas.microsoft.com/office/drawing/2014/main" id="{7508BA03-16CD-4350-9A37-4DD6BB3A308C}"/>
               </a:ext>
             </a:extLst>
           </p:cNvPr>
@@ -2709,8 +3170,8 @@
         </p:nvSpPr>
         <p:spPr>
           <a:xfrm xmlns:a="http://schemas.openxmlformats.org/drawingml/2006/main">
-            <a:off x="10953750" y="6362700"/>
-            <a:ext cx="762000" cy="266700"/>
+            <a:off x="609600" y="885825"/>
+            <a:ext cx="10991850" cy="1047750"/>
           </a:xfrm>
           <a:prstGeom xmlns:a="http://schemas.openxmlformats.org/drawingml/2006/main" prst="rect">
             <a:avLst/>
@@ -2727,9 +3188,9 @@
           <a:lstStyle xmlns:a="http://schemas.openxmlformats.org/drawingml/2006/main"/>
           <a:p xmlns:a="http://schemas.openxmlformats.org/drawingml/2006/main">
             <a:pPr>
-              <a:defRPr sz="1275">
-                <a:solidFill>
-                  <a:srgbClr val="52666C"/>
+              <a:defRPr sz="3525" b="1">
+                <a:solidFill>
+                  <a:srgbClr val="001E2B"/>
                 </a:solidFill>
                 <a:latin typeface="Helvetica Neue"/>
                 <a:ea typeface="Helvetica Neue"/>
@@ -2737,15 +3198,15 @@
               </a:defRPr>
             </a:pPr>
             <a:r>
-              <a:rPr sz="1275">
-                <a:solidFill>
-                  <a:srgbClr val="52666C"/>
+              <a:rPr sz="3525" b="1">
+                <a:solidFill>
+                  <a:srgbClr val="001E2B"/>
                 </a:solidFill>
                 <a:latin typeface="Helvetica Neue"/>
                 <a:ea typeface="Helvetica Neue"/>
                 <a:cs typeface="Helvetica Neue"/>
               </a:rPr>
-              <a:t>3 / 5</a:t>
+              <a:t>Replay has to preserve state</a:t>
             </a:r>
           </a:p>
         </p:txBody>
@@ -2755,7 +3216,7 @@
           <p:cNvPr id="3" name="text-2">
             <a:extLst xmlns:a="http://schemas.openxmlformats.org/drawingml/2006/main">
               <a:ext uri="{FF2B5EF4-FFF2-40B4-BE49-F238E27FC236}">
-                <a16:creationId xmlns:a16="http://schemas.microsoft.com/office/drawing/2014/main" id="{E4CF7D25-17D2-4869-B6A4-3105E509AB4B}"/>
+                <a16:creationId xmlns:a16="http://schemas.microsoft.com/office/drawing/2014/main" id="{A3B08D4B-88A5-40E1-8F3F-2CF0F5E2DEA3}"/>
               </a:ext>
             </a:extLst>
           </p:cNvPr>
@@ -2766,8 +3227,8 @@
         </p:nvSpPr>
         <p:spPr>
           <a:xfrm xmlns:a="http://schemas.openxmlformats.org/drawingml/2006/main">
-            <a:off x="628650" y="1933575"/>
-            <a:ext cx="2857500" cy="476250"/>
+            <a:off x="10972800" y="6372225"/>
+            <a:ext cx="742950" cy="266700"/>
           </a:xfrm>
           <a:prstGeom xmlns:a="http://schemas.openxmlformats.org/drawingml/2006/main" prst="rect">
             <a:avLst/>
@@ -2784,9 +3245,9 @@
           <a:lstStyle xmlns:a="http://schemas.openxmlformats.org/drawingml/2006/main"/>
           <a:p xmlns:a="http://schemas.openxmlformats.org/drawingml/2006/main">
             <a:pPr>
-              <a:defRPr sz="2550" b="1">
-                <a:solidFill>
-                  <a:srgbClr val="001E2B"/>
+              <a:defRPr sz="1275">
+                <a:solidFill>
+                  <a:srgbClr val="52666C"/>
                 </a:solidFill>
                 <a:latin typeface="Helvetica Neue"/>
                 <a:ea typeface="Helvetica Neue"/>
@@ -2794,15 +3255,15 @@
               </a:defRPr>
             </a:pPr>
             <a:r>
-              <a:rPr sz="2550" b="1">
-                <a:solidFill>
-                  <a:srgbClr val="001E2B"/>
+              <a:rPr sz="1275">
+                <a:solidFill>
+                  <a:srgbClr val="52666C"/>
                 </a:solidFill>
                 <a:latin typeface="Helvetica Neue"/>
                 <a:ea typeface="Helvetica Neue"/>
                 <a:cs typeface="Helvetica Neue"/>
               </a:rPr>
-              <a:t>Save</a:t>
+              <a:t>3 / 6</a:t>
             </a:r>
           </a:p>
         </p:txBody>
@@ -2812,7 +3273,7 @@
           <p:cNvPr id="4" name="text-3">
             <a:extLst xmlns:a="http://schemas.openxmlformats.org/drawingml/2006/main">
               <a:ext uri="{FF2B5EF4-FFF2-40B4-BE49-F238E27FC236}">
-                <a16:creationId xmlns:a16="http://schemas.microsoft.com/office/drawing/2014/main" id="{38C51ADD-9B48-4EC2-90D0-48D6876EAB54}"/>
+                <a16:creationId xmlns:a16="http://schemas.microsoft.com/office/drawing/2014/main" id="{7693D6CE-25F0-4C63-B2A8-493C7F3C6AC4}"/>
               </a:ext>
             </a:extLst>
           </p:cNvPr>
@@ -2823,8 +3284,8 @@
         </p:nvSpPr>
         <p:spPr>
           <a:xfrm xmlns:a="http://schemas.openxmlformats.org/drawingml/2006/main">
-            <a:off x="628650" y="2752725"/>
-            <a:ext cx="2981325" cy="1714500"/>
+            <a:off x="628650" y="2143125"/>
+            <a:ext cx="742950" cy="609600"/>
           </a:xfrm>
           <a:prstGeom xmlns:a="http://schemas.openxmlformats.org/drawingml/2006/main" prst="rect">
             <a:avLst/>
@@ -2841,9 +3302,9 @@
           <a:lstStyle xmlns:a="http://schemas.openxmlformats.org/drawingml/2006/main"/>
           <a:p xmlns:a="http://schemas.openxmlformats.org/drawingml/2006/main">
             <a:pPr>
-              <a:defRPr sz="2100">
-                <a:solidFill>
-                  <a:srgbClr val="001E2B"/>
+              <a:defRPr sz="3300" b="1">
+                <a:solidFill>
+                  <a:srgbClr val="007E54"/>
                 </a:solidFill>
                 <a:latin typeface="Helvetica Neue"/>
                 <a:ea typeface="Helvetica Neue"/>
@@ -2851,71 +3312,25 @@
               </a:defRPr>
             </a:pPr>
             <a:r>
-              <a:rPr sz="2100">
-                <a:solidFill>
-                  <a:srgbClr val="001E2B"/>
+              <a:rPr sz="3300" b="1">
+                <a:solidFill>
+                  <a:srgbClr val="007E54"/>
                 </a:solidFill>
                 <a:latin typeface="Helvetica Neue"/>
                 <a:ea typeface="Helvetica Neue"/>
                 <a:cs typeface="Helvetica Neue"/>
               </a:rPr>
-              <a:t>Agent.image</a:t>
-            </a:r>
-          </a:p>
-          <a:p xmlns:a="http://schemas.openxmlformats.org/drawingml/2006/main">
-            <a:pPr>
-              <a:defRPr sz="2100">
-                <a:solidFill>
-                  <a:srgbClr val="001E2B"/>
-                </a:solidFill>
-                <a:latin typeface="Helvetica Neue"/>
-                <a:ea typeface="Helvetica Neue"/>
-                <a:cs typeface="Helvetica Neue"/>
-              </a:defRPr>
-            </a:pPr>
-            <a:r>
-              <a:rPr sz="2100">
-                <a:solidFill>
-                  <a:srgbClr val="001E2B"/>
-                </a:solidFill>
-                <a:latin typeface="Helvetica Neue"/>
-                <a:ea typeface="Helvetica Neue"/>
-                <a:cs typeface="Helvetica Neue"/>
-              </a:rPr>
-              <a:t>Trace objects</a:t>
-            </a:r>
-          </a:p>
-          <a:p xmlns:a="http://schemas.openxmlformats.org/drawingml/2006/main">
-            <a:pPr>
-              <a:defRPr sz="2100">
-                <a:solidFill>
-                  <a:srgbClr val="001E2B"/>
-                </a:solidFill>
-                <a:latin typeface="Helvetica Neue"/>
-                <a:ea typeface="Helvetica Neue"/>
-                <a:cs typeface="Helvetica Neue"/>
-              </a:defRPr>
-            </a:pPr>
-            <a:r>
-              <a:rPr sz="2100">
-                <a:solidFill>
-                  <a:srgbClr val="001E2B"/>
-                </a:solidFill>
-                <a:latin typeface="Helvetica Neue"/>
-                <a:ea typeface="Helvetica Neue"/>
-                <a:cs typeface="Helvetica Neue"/>
-              </a:rPr>
-              <a:t>Files and Git history</a:t>
-            </a:r>
-          </a:p>
-        </p:txBody>
-      </p:sp>
-      <p:sp>
-        <p:nvSpPr>
-          <p:cNvPr id="5" name="">
+              <a:t>01</a:t>
+            </a:r>
+          </a:p>
+        </p:txBody>
+      </p:sp>
+      <p:sp>
+        <p:nvSpPr>
+          <p:cNvPr id="5" name="text-4">
             <a:extLst xmlns:a="http://schemas.openxmlformats.org/drawingml/2006/main">
               <a:ext uri="{FF2B5EF4-FFF2-40B4-BE49-F238E27FC236}">
-                <a16:creationId xmlns:a16="http://schemas.microsoft.com/office/drawing/2014/main" id="{FE3D228D-DCB3-4103-99F6-9B1B68A3F7AD}"/>
+                <a16:creationId xmlns:a16="http://schemas.microsoft.com/office/drawing/2014/main" id="{302238A9-0802-4805-8698-A893A76D3C81}"/>
               </a:ext>
             </a:extLst>
           </p:cNvPr>
@@ -2926,40 +3341,8 @@
         </p:nvSpPr>
         <p:spPr>
           <a:xfrm xmlns:a="http://schemas.openxmlformats.org/drawingml/2006/main">
-            <a:off x="4086225" y="2438400"/>
-            <a:ext cx="3362325" cy="2457450"/>
-          </a:xfrm>
-          <a:prstGeom xmlns:a="http://schemas.openxmlformats.org/drawingml/2006/main" prst="rect">
-            <a:avLst/>
-          </a:prstGeom>
-          <a:solidFill xmlns:a="http://schemas.openxmlformats.org/drawingml/2006/main">
-            <a:srgbClr val="E3F3E9"/>
-          </a:solidFill>
-          <a:ln xmlns:a="http://schemas.openxmlformats.org/drawingml/2006/main" w="19050">
-            <a:solidFill>
-              <a:srgbClr val="8CAD9C"/>
-            </a:solidFill>
-          </a:ln>
-        </p:spPr>
-      </p:sp>
-      <p:sp>
-        <p:nvSpPr>
-          <p:cNvPr id="6" name="text-5">
-            <a:extLst xmlns:a="http://schemas.openxmlformats.org/drawingml/2006/main">
-              <a:ext uri="{FF2B5EF4-FFF2-40B4-BE49-F238E27FC236}">
-                <a16:creationId xmlns:a16="http://schemas.microsoft.com/office/drawing/2014/main" id="{82EAE834-BC1E-41E5-B464-B335ABA70929}"/>
-              </a:ext>
-            </a:extLst>
-          </p:cNvPr>
-          <p:cNvSpPr>
-            <a:spLocks xmlns:a="http://schemas.openxmlformats.org/drawingml/2006/main" noGrp="1"/>
-          </p:cNvSpPr>
-          <p:nvPr/>
-        </p:nvSpPr>
-        <p:spPr>
-          <a:xfrm xmlns:a="http://schemas.openxmlformats.org/drawingml/2006/main">
-            <a:off x="4295775" y="2714625"/>
-            <a:ext cx="3000375" cy="581025"/>
+            <a:off x="1657350" y="2143125"/>
+            <a:ext cx="9696450" cy="514350"/>
           </a:xfrm>
           <a:prstGeom xmlns:a="http://schemas.openxmlformats.org/drawingml/2006/main" prst="rect">
             <a:avLst/>
@@ -2976,7 +3359,7 @@
           <a:lstStyle xmlns:a="http://schemas.openxmlformats.org/drawingml/2006/main"/>
           <a:p xmlns:a="http://schemas.openxmlformats.org/drawingml/2006/main">
             <a:pPr>
-              <a:defRPr sz="2550" b="1">
+              <a:defRPr sz="2400" b="1">
                 <a:solidFill>
                   <a:srgbClr val="001E2B"/>
                 </a:solidFill>
@@ -2986,7 +3369,7 @@
               </a:defRPr>
             </a:pPr>
             <a:r>
-              <a:rPr sz="2550" b="1">
+              <a:rPr sz="2400" b="1">
                 <a:solidFill>
                   <a:srgbClr val="001E2B"/>
                 </a:solidFill>
@@ -2994,17 +3377,17 @@
                 <a:ea typeface="Helvetica Neue"/>
                 <a:cs typeface="Helvetica Neue"/>
               </a:rPr>
-              <a:t>MongoDB Atlas</a:t>
-            </a:r>
-          </a:p>
-        </p:txBody>
-      </p:sp>
-      <p:sp>
-        <p:nvSpPr>
-          <p:cNvPr id="7" name="text-6">
+              <a:t>Request interception</a:t>
+            </a:r>
+          </a:p>
+        </p:txBody>
+      </p:sp>
+      <p:sp>
+        <p:nvSpPr>
+          <p:cNvPr id="6" name="text-5">
             <a:extLst xmlns:a="http://schemas.openxmlformats.org/drawingml/2006/main">
               <a:ext uri="{FF2B5EF4-FFF2-40B4-BE49-F238E27FC236}">
-                <a16:creationId xmlns:a16="http://schemas.microsoft.com/office/drawing/2014/main" id="{28D94990-CA29-4DD8-9FD6-5258AAF52E06}"/>
+                <a16:creationId xmlns:a16="http://schemas.microsoft.com/office/drawing/2014/main" id="{92EDE090-8B3A-4574-899F-387ECB569B9E}"/>
               </a:ext>
             </a:extLst>
           </p:cNvPr>
@@ -3015,8 +3398,8 @@
         </p:nvSpPr>
         <p:spPr>
           <a:xfrm xmlns:a="http://schemas.openxmlformats.org/drawingml/2006/main">
-            <a:off x="4295775" y="3495675"/>
-            <a:ext cx="2971800" cy="1057275"/>
+            <a:off x="1657350" y="2676525"/>
+            <a:ext cx="9696450" cy="457200"/>
           </a:xfrm>
           <a:prstGeom xmlns:a="http://schemas.openxmlformats.org/drawingml/2006/main" prst="rect">
             <a:avLst/>
@@ -3033,9 +3416,9 @@
           <a:lstStyle xmlns:a="http://schemas.openxmlformats.org/drawingml/2006/main"/>
           <a:p xmlns:a="http://schemas.openxmlformats.org/drawingml/2006/main">
             <a:pPr>
-              <a:defRPr sz="2100">
-                <a:solidFill>
-                  <a:srgbClr val="001E2B"/>
+              <a:defRPr sz="2025">
+                <a:solidFill>
+                  <a:srgbClr val="52666C"/>
                 </a:solidFill>
                 <a:latin typeface="Helvetica Neue"/>
                 <a:ea typeface="Helvetica Neue"/>
@@ -3043,48 +3426,25 @@
               </a:defRPr>
             </a:pPr>
             <a:r>
-              <a:rPr sz="2100">
-                <a:solidFill>
-                  <a:srgbClr val="001E2B"/>
+              <a:rPr sz="2025">
+                <a:solidFill>
+                  <a:srgbClr val="52666C"/>
                 </a:solidFill>
                 <a:latin typeface="Helvetica Neue"/>
                 <a:ea typeface="Helvetica Neue"/>
                 <a:cs typeface="Helvetica Neue"/>
               </a:rPr>
-              <a:t>GridFS payloads</a:t>
-            </a:r>
-          </a:p>
-          <a:p xmlns:a="http://schemas.openxmlformats.org/drawingml/2006/main">
-            <a:pPr>
-              <a:defRPr sz="2100">
-                <a:solidFill>
-                  <a:srgbClr val="001E2B"/>
-                </a:solidFill>
-                <a:latin typeface="Helvetica Neue"/>
-                <a:ea typeface="Helvetica Neue"/>
-                <a:cs typeface="Helvetica Neue"/>
-              </a:defRPr>
-            </a:pPr>
-            <a:r>
-              <a:rPr sz="2100">
-                <a:solidFill>
-                  <a:srgbClr val="001E2B"/>
-                </a:solidFill>
-                <a:latin typeface="Helvetica Neue"/>
-                <a:ea typeface="Helvetica Neue"/>
-                <a:cs typeface="Helvetica Neue"/>
-              </a:rPr>
-              <a:t>Checksummed manifest</a:t>
-            </a:r>
-          </a:p>
-        </p:txBody>
-      </p:sp>
-      <p:sp>
-        <p:nvSpPr>
-          <p:cNvPr id="8" name="">
+              <a:t>Normalize requests and detect divergence</a:t>
+            </a:r>
+          </a:p>
+        </p:txBody>
+      </p:sp>
+      <p:sp>
+        <p:nvSpPr>
+          <p:cNvPr id="7" name="text-6">
             <a:extLst xmlns:a="http://schemas.openxmlformats.org/drawingml/2006/main">
               <a:ext uri="{FF2B5EF4-FFF2-40B4-BE49-F238E27FC236}">
-                <a16:creationId xmlns:a16="http://schemas.microsoft.com/office/drawing/2014/main" id="{4E41AAE2-F665-48BB-91ED-D553F3ECD6D0}"/>
+                <a16:creationId xmlns:a16="http://schemas.microsoft.com/office/drawing/2014/main" id="{20F01599-D2AC-46A6-8B53-05864575D8D4}"/>
               </a:ext>
             </a:extLst>
           </p:cNvPr>
@@ -3095,68 +3455,8 @@
         </p:nvSpPr>
         <p:spPr>
           <a:xfrm xmlns:a="http://schemas.openxmlformats.org/drawingml/2006/main">
-            <a:off x="3476625" y="3581400"/>
-            <a:ext cx="609600" cy="19050"/>
-          </a:xfrm>
-          <a:prstGeom xmlns:a="http://schemas.openxmlformats.org/drawingml/2006/main" prst="rect">
-            <a:avLst/>
-          </a:prstGeom>
-          <a:solidFill xmlns:a="http://schemas.openxmlformats.org/drawingml/2006/main">
-            <a:srgbClr val="008F48"/>
-          </a:solidFill>
-          <a:ln xmlns:a="http://schemas.openxmlformats.org/drawingml/2006/main" w="0">
-            <a:noFill/>
-          </a:ln>
-        </p:spPr>
-      </p:sp>
-      <p:sp>
-        <p:nvSpPr>
-          <p:cNvPr id="9" name="">
-            <a:extLst xmlns:a="http://schemas.openxmlformats.org/drawingml/2006/main">
-              <a:ext uri="{FF2B5EF4-FFF2-40B4-BE49-F238E27FC236}">
-                <a16:creationId xmlns:a16="http://schemas.microsoft.com/office/drawing/2014/main" id="{7F1062E6-61CF-4F83-87CB-B5696A3AD16C}"/>
-              </a:ext>
-            </a:extLst>
-          </p:cNvPr>
-          <p:cNvSpPr>
-            <a:spLocks xmlns:a="http://schemas.openxmlformats.org/drawingml/2006/main" noGrp="1"/>
-          </p:cNvSpPr>
-          <p:nvPr/>
-        </p:nvSpPr>
-        <p:spPr>
-          <a:xfrm xmlns:a="http://schemas.openxmlformats.org/drawingml/2006/main">
-            <a:off x="7448550" y="3581400"/>
-            <a:ext cx="685800" cy="19050"/>
-          </a:xfrm>
-          <a:prstGeom xmlns:a="http://schemas.openxmlformats.org/drawingml/2006/main" prst="rect">
-            <a:avLst/>
-          </a:prstGeom>
-          <a:solidFill xmlns:a="http://schemas.openxmlformats.org/drawingml/2006/main">
-            <a:srgbClr val="008F48"/>
-          </a:solidFill>
-          <a:ln xmlns:a="http://schemas.openxmlformats.org/drawingml/2006/main" w="0">
-            <a:noFill/>
-          </a:ln>
-        </p:spPr>
-      </p:sp>
-      <p:sp>
-        <p:nvSpPr>
-          <p:cNvPr id="10" name="text-9">
-            <a:extLst xmlns:a="http://schemas.openxmlformats.org/drawingml/2006/main">
-              <a:ext uri="{FF2B5EF4-FFF2-40B4-BE49-F238E27FC236}">
-                <a16:creationId xmlns:a16="http://schemas.microsoft.com/office/drawing/2014/main" id="{A0C90728-2471-4DE2-B6C5-89517D01C7E5}"/>
-              </a:ext>
-            </a:extLst>
-          </p:cNvPr>
-          <p:cNvSpPr>
-            <a:spLocks xmlns:a="http://schemas.openxmlformats.org/drawingml/2006/main" noGrp="1"/>
-          </p:cNvSpPr>
-          <p:nvPr/>
-        </p:nvSpPr>
-        <p:spPr>
-          <a:xfrm xmlns:a="http://schemas.openxmlformats.org/drawingml/2006/main">
-            <a:off x="8277225" y="1933575"/>
-            <a:ext cx="3190875" cy="476250"/>
+            <a:off x="628650" y="3248025"/>
+            <a:ext cx="742950" cy="609600"/>
           </a:xfrm>
           <a:prstGeom xmlns:a="http://schemas.openxmlformats.org/drawingml/2006/main" prst="rect">
             <a:avLst/>
@@ -3173,9 +3473,9 @@
           <a:lstStyle xmlns:a="http://schemas.openxmlformats.org/drawingml/2006/main"/>
           <a:p xmlns:a="http://schemas.openxmlformats.org/drawingml/2006/main">
             <a:pPr>
-              <a:defRPr sz="2550" b="1">
-                <a:solidFill>
-                  <a:srgbClr val="001E2B"/>
+              <a:defRPr sz="3300" b="1">
+                <a:solidFill>
+                  <a:srgbClr val="007E54"/>
                 </a:solidFill>
                 <a:latin typeface="Helvetica Neue"/>
                 <a:ea typeface="Helvetica Neue"/>
@@ -3183,25 +3483,25 @@
               </a:defRPr>
             </a:pPr>
             <a:r>
-              <a:rPr sz="2550" b="1">
-                <a:solidFill>
-                  <a:srgbClr val="001E2B"/>
+              <a:rPr sz="3300" b="1">
+                <a:solidFill>
+                  <a:srgbClr val="007E54"/>
                 </a:solidFill>
                 <a:latin typeface="Helvetica Neue"/>
                 <a:ea typeface="Helvetica Neue"/>
                 <a:cs typeface="Helvetica Neue"/>
               </a:rPr>
-              <a:t>Recover</a:t>
-            </a:r>
-          </a:p>
-        </p:txBody>
-      </p:sp>
-      <p:sp>
-        <p:nvSpPr>
-          <p:cNvPr id="11" name="text-10">
+              <a:t>02</a:t>
+            </a:r>
+          </a:p>
+        </p:txBody>
+      </p:sp>
+      <p:sp>
+        <p:nvSpPr>
+          <p:cNvPr id="8" name="text-7">
             <a:extLst xmlns:a="http://schemas.openxmlformats.org/drawingml/2006/main">
               <a:ext uri="{FF2B5EF4-FFF2-40B4-BE49-F238E27FC236}">
-                <a16:creationId xmlns:a16="http://schemas.microsoft.com/office/drawing/2014/main" id="{B97F2D7A-E556-4872-87BB-280179FBD710}"/>
+                <a16:creationId xmlns:a16="http://schemas.microsoft.com/office/drawing/2014/main" id="{05E7C0CE-B150-4A5F-B7F2-53E3450847B9}"/>
               </a:ext>
             </a:extLst>
           </p:cNvPr>
@@ -3212,8 +3512,8 @@
         </p:nvSpPr>
         <p:spPr>
           <a:xfrm xmlns:a="http://schemas.openxmlformats.org/drawingml/2006/main">
-            <a:off x="8277225" y="2752725"/>
-            <a:ext cx="3238500" cy="1714500"/>
+            <a:off x="1657350" y="3248025"/>
+            <a:ext cx="9696450" cy="514350"/>
           </a:xfrm>
           <a:prstGeom xmlns:a="http://schemas.openxmlformats.org/drawingml/2006/main" prst="rect">
             <a:avLst/>
@@ -3230,7 +3530,7 @@
           <a:lstStyle xmlns:a="http://schemas.openxmlformats.org/drawingml/2006/main"/>
           <a:p xmlns:a="http://schemas.openxmlformats.org/drawingml/2006/main">
             <a:pPr>
-              <a:defRPr sz="2100">
+              <a:defRPr sz="2400" b="1">
                 <a:solidFill>
                   <a:srgbClr val="001E2B"/>
                 </a:solidFill>
@@ -3240,7 +3540,7 @@
               </a:defRPr>
             </a:pPr>
             <a:r>
-              <a:rPr sz="2100">
+              <a:rPr sz="2400" b="1">
                 <a:solidFill>
                   <a:srgbClr val="001E2B"/>
                 </a:solidFill>
@@ -3248,63 +3548,17 @@
                 <a:ea typeface="Helvetica Neue"/>
                 <a:cs typeface="Helvetica Neue"/>
               </a:rPr>
-              <a:t>Download</a:t>
-            </a:r>
-          </a:p>
-          <a:p xmlns:a="http://schemas.openxmlformats.org/drawingml/2006/main">
-            <a:pPr>
-              <a:defRPr sz="2100">
-                <a:solidFill>
-                  <a:srgbClr val="001E2B"/>
-                </a:solidFill>
-                <a:latin typeface="Helvetica Neue"/>
-                <a:ea typeface="Helvetica Neue"/>
-                <a:cs typeface="Helvetica Neue"/>
-              </a:defRPr>
-            </a:pPr>
-            <a:r>
-              <a:rPr sz="2100">
-                <a:solidFill>
-                  <a:srgbClr val="001E2B"/>
-                </a:solidFill>
-                <a:latin typeface="Helvetica Neue"/>
-                <a:ea typeface="Helvetica Neue"/>
-                <a:cs typeface="Helvetica Neue"/>
-              </a:rPr>
-              <a:t>Verify SHA-256</a:t>
-            </a:r>
-          </a:p>
-          <a:p xmlns:a="http://schemas.openxmlformats.org/drawingml/2006/main">
-            <a:pPr>
-              <a:defRPr sz="2100">
-                <a:solidFill>
-                  <a:srgbClr val="001E2B"/>
-                </a:solidFill>
-                <a:latin typeface="Helvetica Neue"/>
-                <a:ea typeface="Helvetica Neue"/>
-                <a:cs typeface="Helvetica Neue"/>
-              </a:defRPr>
-            </a:pPr>
-            <a:r>
-              <a:rPr sz="2100">
-                <a:solidFill>
-                  <a:srgbClr val="001E2B"/>
-                </a:solidFill>
-                <a:latin typeface="Helvetica Neue"/>
-                <a:ea typeface="Helvetica Neue"/>
-                <a:cs typeface="Helvetica Neue"/>
-              </a:rPr>
-              <a:t>Reopen and inspect</a:t>
-            </a:r>
-          </a:p>
-        </p:txBody>
-      </p:sp>
-      <p:sp>
-        <p:nvSpPr>
-          <p:cNvPr id="12" name="">
+              <a:t>Recorded tool outcomes</a:t>
+            </a:r>
+          </a:p>
+        </p:txBody>
+      </p:sp>
+      <p:sp>
+        <p:nvSpPr>
+          <p:cNvPr id="9" name="text-8">
             <a:extLst xmlns:a="http://schemas.openxmlformats.org/drawingml/2006/main">
               <a:ext uri="{FF2B5EF4-FFF2-40B4-BE49-F238E27FC236}">
-                <a16:creationId xmlns:a16="http://schemas.microsoft.com/office/drawing/2014/main" id="{6069B9AB-22D5-480E-923F-2F2013C7D722}"/>
+                <a16:creationId xmlns:a16="http://schemas.microsoft.com/office/drawing/2014/main" id="{EC68A6B1-CA4F-4560-AED4-333E528DDB8A}"/>
               </a:ext>
             </a:extLst>
           </p:cNvPr>
@@ -3315,8 +3569,236 @@
         </p:nvSpPr>
         <p:spPr>
           <a:xfrm xmlns:a="http://schemas.openxmlformats.org/drawingml/2006/main">
-            <a:off x="628650" y="5372100"/>
-            <a:ext cx="10925175" cy="19050"/>
+            <a:off x="1657350" y="3781425"/>
+            <a:ext cx="9696450" cy="457200"/>
+          </a:xfrm>
+          <a:prstGeom xmlns:a="http://schemas.openxmlformats.org/drawingml/2006/main" prst="rect">
+            <a:avLst/>
+          </a:prstGeom>
+          <a:noFill xmlns:a="http://schemas.openxmlformats.org/drawingml/2006/main"/>
+          <a:ln xmlns:a="http://schemas.openxmlformats.org/drawingml/2006/main" w="0">
+            <a:noFill/>
+          </a:ln>
+        </p:spPr>
+        <p:txBody>
+          <a:bodyPr xmlns:a="http://schemas.openxmlformats.org/drawingml/2006/main">
+            <a:noAutofit/>
+          </a:bodyPr>
+          <a:lstStyle xmlns:a="http://schemas.openxmlformats.org/drawingml/2006/main"/>
+          <a:p xmlns:a="http://schemas.openxmlformats.org/drawingml/2006/main">
+            <a:pPr>
+              <a:defRPr sz="2025">
+                <a:solidFill>
+                  <a:srgbClr val="52666C"/>
+                </a:solidFill>
+                <a:latin typeface="Helvetica Neue"/>
+                <a:ea typeface="Helvetica Neue"/>
+                <a:cs typeface="Helvetica Neue"/>
+              </a:defRPr>
+            </a:pPr>
+            <a:r>
+              <a:rPr sz="2025">
+                <a:solidFill>
+                  <a:srgbClr val="52666C"/>
+                </a:solidFill>
+                <a:latin typeface="Helvetica Neue"/>
+                <a:ea typeface="Helvetica Neue"/>
+                <a:cs typeface="Helvetica Neue"/>
+              </a:rPr>
+              <a:t>Replay behavior, not another model answer</a:t>
+            </a:r>
+          </a:p>
+        </p:txBody>
+      </p:sp>
+      <p:sp>
+        <p:nvSpPr>
+          <p:cNvPr id="10" name="text-9">
+            <a:extLst xmlns:a="http://schemas.openxmlformats.org/drawingml/2006/main">
+              <a:ext uri="{FF2B5EF4-FFF2-40B4-BE49-F238E27FC236}">
+                <a16:creationId xmlns:a16="http://schemas.microsoft.com/office/drawing/2014/main" id="{0D0E1136-26DD-41FA-88D1-EDB0DBE1601C}"/>
+              </a:ext>
+            </a:extLst>
+          </p:cNvPr>
+          <p:cNvSpPr>
+            <a:spLocks xmlns:a="http://schemas.openxmlformats.org/drawingml/2006/main" noGrp="1"/>
+          </p:cNvSpPr>
+          <p:nvPr/>
+        </p:nvSpPr>
+        <p:spPr>
+          <a:xfrm xmlns:a="http://schemas.openxmlformats.org/drawingml/2006/main">
+            <a:off x="628650" y="4352925"/>
+            <a:ext cx="742950" cy="609600"/>
+          </a:xfrm>
+          <a:prstGeom xmlns:a="http://schemas.openxmlformats.org/drawingml/2006/main" prst="rect">
+            <a:avLst/>
+          </a:prstGeom>
+          <a:noFill xmlns:a="http://schemas.openxmlformats.org/drawingml/2006/main"/>
+          <a:ln xmlns:a="http://schemas.openxmlformats.org/drawingml/2006/main" w="0">
+            <a:noFill/>
+          </a:ln>
+        </p:spPr>
+        <p:txBody>
+          <a:bodyPr xmlns:a="http://schemas.openxmlformats.org/drawingml/2006/main">
+            <a:noAutofit/>
+          </a:bodyPr>
+          <a:lstStyle xmlns:a="http://schemas.openxmlformats.org/drawingml/2006/main"/>
+          <a:p xmlns:a="http://schemas.openxmlformats.org/drawingml/2006/main">
+            <a:pPr>
+              <a:defRPr sz="3300" b="1">
+                <a:solidFill>
+                  <a:srgbClr val="007E54"/>
+                </a:solidFill>
+                <a:latin typeface="Helvetica Neue"/>
+                <a:ea typeface="Helvetica Neue"/>
+                <a:cs typeface="Helvetica Neue"/>
+              </a:defRPr>
+            </a:pPr>
+            <a:r>
+              <a:rPr sz="3300" b="1">
+                <a:solidFill>
+                  <a:srgbClr val="007E54"/>
+                </a:solidFill>
+                <a:latin typeface="Helvetica Neue"/>
+                <a:ea typeface="Helvetica Neue"/>
+                <a:cs typeface="Helvetica Neue"/>
+              </a:rPr>
+              <a:t>03</a:t>
+            </a:r>
+          </a:p>
+        </p:txBody>
+      </p:sp>
+      <p:sp>
+        <p:nvSpPr>
+          <p:cNvPr id="11" name="text-10">
+            <a:extLst xmlns:a="http://schemas.openxmlformats.org/drawingml/2006/main">
+              <a:ext uri="{FF2B5EF4-FFF2-40B4-BE49-F238E27FC236}">
+                <a16:creationId xmlns:a16="http://schemas.microsoft.com/office/drawing/2014/main" id="{B0048A8B-DD4F-47F6-865F-A4A9639C92DE}"/>
+              </a:ext>
+            </a:extLst>
+          </p:cNvPr>
+          <p:cNvSpPr>
+            <a:spLocks xmlns:a="http://schemas.openxmlformats.org/drawingml/2006/main" noGrp="1"/>
+          </p:cNvSpPr>
+          <p:nvPr/>
+        </p:nvSpPr>
+        <p:spPr>
+          <a:xfrm xmlns:a="http://schemas.openxmlformats.org/drawingml/2006/main">
+            <a:off x="1657350" y="4352925"/>
+            <a:ext cx="9696450" cy="514350"/>
+          </a:xfrm>
+          <a:prstGeom xmlns:a="http://schemas.openxmlformats.org/drawingml/2006/main" prst="rect">
+            <a:avLst/>
+          </a:prstGeom>
+          <a:noFill xmlns:a="http://schemas.openxmlformats.org/drawingml/2006/main"/>
+          <a:ln xmlns:a="http://schemas.openxmlformats.org/drawingml/2006/main" w="0">
+            <a:noFill/>
+          </a:ln>
+        </p:spPr>
+        <p:txBody>
+          <a:bodyPr xmlns:a="http://schemas.openxmlformats.org/drawingml/2006/main">
+            <a:noAutofit/>
+          </a:bodyPr>
+          <a:lstStyle xmlns:a="http://schemas.openxmlformats.org/drawingml/2006/main"/>
+          <a:p xmlns:a="http://schemas.openxmlformats.org/drawingml/2006/main">
+            <a:pPr>
+              <a:defRPr sz="2400" b="1">
+                <a:solidFill>
+                  <a:srgbClr val="001E2B"/>
+                </a:solidFill>
+                <a:latin typeface="Helvetica Neue"/>
+                <a:ea typeface="Helvetica Neue"/>
+                <a:cs typeface="Helvetica Neue"/>
+              </a:defRPr>
+            </a:pPr>
+            <a:r>
+              <a:rPr sz="2400" b="1">
+                <a:solidFill>
+                  <a:srgbClr val="001E2B"/>
+                </a:solidFill>
+                <a:latin typeface="Helvetica Neue"/>
+                <a:ea typeface="Helvetica Neue"/>
+                <a:cs typeface="Helvetica Neue"/>
+              </a:rPr>
+              <a:t>Git checkpoint recovery</a:t>
+            </a:r>
+          </a:p>
+        </p:txBody>
+      </p:sp>
+      <p:sp>
+        <p:nvSpPr>
+          <p:cNvPr id="12" name="text-11">
+            <a:extLst xmlns:a="http://schemas.openxmlformats.org/drawingml/2006/main">
+              <a:ext uri="{FF2B5EF4-FFF2-40B4-BE49-F238E27FC236}">
+                <a16:creationId xmlns:a16="http://schemas.microsoft.com/office/drawing/2014/main" id="{7E0995A9-C96B-432C-8B68-05397AC7B44F}"/>
+              </a:ext>
+            </a:extLst>
+          </p:cNvPr>
+          <p:cNvSpPr>
+            <a:spLocks xmlns:a="http://schemas.openxmlformats.org/drawingml/2006/main" noGrp="1"/>
+          </p:cNvSpPr>
+          <p:nvPr/>
+        </p:nvSpPr>
+        <p:spPr>
+          <a:xfrm xmlns:a="http://schemas.openxmlformats.org/drawingml/2006/main">
+            <a:off x="1657350" y="4886325"/>
+            <a:ext cx="9696450" cy="457200"/>
+          </a:xfrm>
+          <a:prstGeom xmlns:a="http://schemas.openxmlformats.org/drawingml/2006/main" prst="rect">
+            <a:avLst/>
+          </a:prstGeom>
+          <a:noFill xmlns:a="http://schemas.openxmlformats.org/drawingml/2006/main"/>
+          <a:ln xmlns:a="http://schemas.openxmlformats.org/drawingml/2006/main" w="0">
+            <a:noFill/>
+          </a:ln>
+        </p:spPr>
+        <p:txBody>
+          <a:bodyPr xmlns:a="http://schemas.openxmlformats.org/drawingml/2006/main">
+            <a:noAutofit/>
+          </a:bodyPr>
+          <a:lstStyle xmlns:a="http://schemas.openxmlformats.org/drawingml/2006/main"/>
+          <a:p xmlns:a="http://schemas.openxmlformats.org/drawingml/2006/main">
+            <a:pPr>
+              <a:defRPr sz="2025">
+                <a:solidFill>
+                  <a:srgbClr val="52666C"/>
+                </a:solidFill>
+                <a:latin typeface="Helvetica Neue"/>
+                <a:ea typeface="Helvetica Neue"/>
+                <a:cs typeface="Helvetica Neue"/>
+              </a:defRPr>
+            </a:pPr>
+            <a:r>
+              <a:rPr sz="2025">
+                <a:solidFill>
+                  <a:srgbClr val="52666C"/>
+                </a:solidFill>
+                <a:latin typeface="Helvetica Neue"/>
+                <a:ea typeface="Helvetica Neue"/>
+                <a:cs typeface="Helvetica Neue"/>
+              </a:rPr>
+              <a:t>Restore files before the live continuation</a:t>
+            </a:r>
+          </a:p>
+        </p:txBody>
+      </p:sp>
+      <p:sp>
+        <p:nvSpPr>
+          <p:cNvPr id="13" name="">
+            <a:extLst xmlns:a="http://schemas.openxmlformats.org/drawingml/2006/main">
+              <a:ext uri="{FF2B5EF4-FFF2-40B4-BE49-F238E27FC236}">
+                <a16:creationId xmlns:a16="http://schemas.microsoft.com/office/drawing/2014/main" id="{16CF55D0-DD8D-4C9E-96E4-7DD04E4268D1}"/>
+              </a:ext>
+            </a:extLst>
+          </p:cNvPr>
+          <p:cNvSpPr>
+            <a:spLocks xmlns:a="http://schemas.openxmlformats.org/drawingml/2006/main" noGrp="1"/>
+          </p:cNvSpPr>
+          <p:nvPr/>
+        </p:nvSpPr>
+        <p:spPr>
+          <a:xfrm xmlns:a="http://schemas.openxmlformats.org/drawingml/2006/main">
+            <a:off x="628650" y="5629275"/>
+            <a:ext cx="10906125" cy="19050"/>
           </a:xfrm>
           <a:prstGeom xmlns:a="http://schemas.openxmlformats.org/drawingml/2006/main" prst="rect">
             <a:avLst/>
@@ -3331,10 +3813,10 @@
       </p:sp>
       <p:sp>
         <p:nvSpPr>
-          <p:cNvPr id="13" name="text-12">
+          <p:cNvPr id="14" name="text-13">
             <a:extLst xmlns:a="http://schemas.openxmlformats.org/drawingml/2006/main">
               <a:ext uri="{FF2B5EF4-FFF2-40B4-BE49-F238E27FC236}">
-                <a16:creationId xmlns:a16="http://schemas.microsoft.com/office/drawing/2014/main" id="{6CE516B2-BFA6-41B4-8227-7355A48B858B}"/>
+                <a16:creationId xmlns:a16="http://schemas.microsoft.com/office/drawing/2014/main" id="{8C66E490-3B08-4745-90E8-02909FCDBF08}"/>
               </a:ext>
             </a:extLst>
           </p:cNvPr>
@@ -3345,8 +3827,8 @@
         </p:nvSpPr>
         <p:spPr>
           <a:xfrm xmlns:a="http://schemas.openxmlformats.org/drawingml/2006/main">
-            <a:off x="628650" y="5743575"/>
-            <a:ext cx="10925175" cy="523875"/>
+            <a:off x="628650" y="5895975"/>
+            <a:ext cx="10572750" cy="504825"/>
           </a:xfrm>
           <a:prstGeom xmlns:a="http://schemas.openxmlformats.org/drawingml/2006/main" prst="rect">
             <a:avLst/>
@@ -3363,9 +3845,9 @@
           <a:lstStyle xmlns:a="http://schemas.openxmlformats.org/drawingml/2006/main"/>
           <a:p xmlns:a="http://schemas.openxmlformats.org/drawingml/2006/main">
             <a:pPr>
-              <a:defRPr sz="1950">
-                <a:solidFill>
-                  <a:srgbClr val="52666C"/>
+              <a:defRPr sz="2250" b="1">
+                <a:solidFill>
+                  <a:srgbClr val="001E2B"/>
                 </a:solidFill>
                 <a:latin typeface="Helvetica Neue"/>
                 <a:ea typeface="Helvetica Neue"/>
@@ -3373,15 +3855,15 @@
               </a:defRPr>
             </a:pPr>
             <a:r>
-              <a:rPr sz="1950">
-                <a:solidFill>
-                  <a:srgbClr val="52666C"/>
+              <a:rPr sz="2250" b="1">
+                <a:solidFill>
+                  <a:srgbClr val="001E2B"/>
                 </a:solidFill>
                 <a:latin typeface="Helvetica Neue"/>
                 <a:ea typeface="Helvetica Neue"/>
                 <a:cs typeface="Helvetica Neue"/>
               </a:rPr>
-              <a:t>Live continuation is explicit. Weights and credentials stay external.</a:t>
+              <a:t>Observed fork: 1 replayed step + 3 live model calls</a:t>
             </a:r>
           </a:p>
         </p:txBody>
@@ -3389,7 +3871,7 @@
     </p:spTree>
     <p:extLst>
       <p:ext uri="{BB962C8B-B14F-4D97-AF65-F5344CB8AC3E}">
-        <p14:creationId xmlns:p14="http://schemas.microsoft.com/office/powerpoint/2010/main" val="356436296"/>
+        <p14:creationId xmlns:p14="http://schemas.microsoft.com/office/powerpoint/2010/main" val="1321069504"/>
       </p:ext>
     </p:extLst>
   </p:cSld>
@@ -3417,10 +3899,10 @@
       </p:grpSpPr>
       <p:sp>
         <p:nvSpPr>
-          <p:cNvPr id="17" name="text-0">
+          <p:cNvPr id="11" name="text-0">
             <a:extLst xmlns:a="http://schemas.openxmlformats.org/drawingml/2006/main">
               <a:ext uri="{FF2B5EF4-FFF2-40B4-BE49-F238E27FC236}">
-                <a16:creationId xmlns:a16="http://schemas.microsoft.com/office/drawing/2014/main" id="{1B621CE3-B2A7-4D3D-9B3D-06E23E07E1B3}"/>
+                <a16:creationId xmlns:a16="http://schemas.microsoft.com/office/drawing/2014/main" id="{696B47DB-5048-490B-934C-CD7B5265C3EF}"/>
               </a:ext>
             </a:extLst>
           </p:cNvPr>
@@ -3431,8 +3913,8 @@
         </p:nvSpPr>
         <p:spPr>
           <a:xfrm xmlns:a="http://schemas.openxmlformats.org/drawingml/2006/main">
-            <a:off x="609600" y="457200"/>
-            <a:ext cx="10972800" cy="1000125"/>
+            <a:off x="619125" y="314325"/>
+            <a:ext cx="10934700" cy="304800"/>
           </a:xfrm>
           <a:prstGeom xmlns:a="http://schemas.openxmlformats.org/drawingml/2006/main" prst="rect">
             <a:avLst/>
@@ -3449,9 +3931,9 @@
           <a:lstStyle xmlns:a="http://schemas.openxmlformats.org/drawingml/2006/main"/>
           <a:p xmlns:a="http://schemas.openxmlformats.org/drawingml/2006/main">
             <a:pPr>
-              <a:defRPr sz="3450" b="1">
-                <a:solidFill>
-                  <a:srgbClr val="001E2B"/>
+              <a:defRPr sz="1575" b="1">
+                <a:solidFill>
+                  <a:srgbClr val="007E54"/>
                 </a:solidFill>
                 <a:latin typeface="Helvetica Neue"/>
                 <a:ea typeface="Helvetica Neue"/>
@@ -3459,15 +3941,15 @@
               </a:defRPr>
             </a:pPr>
             <a:r>
-              <a:rPr sz="3450" b="1">
-                <a:solidFill>
-                  <a:srgbClr val="001E2B"/>
+              <a:rPr sz="1575" b="1">
+                <a:solidFill>
+                  <a:srgbClr val="007E54"/>
                 </a:solidFill>
                 <a:latin typeface="Helvetica Neue"/>
                 <a:ea typeface="Helvetica Neue"/>
                 <a:cs typeface="Helvetica Neue"/>
               </a:rPr>
-              <a:t>Downloaded, reopened, checksum-verified</a:t>
+              <a:t>IMPLEMENTATION DIFFICULTY 30%  /  MONGODB</a:t>
             </a:r>
           </a:p>
         </p:txBody>
@@ -3477,7 +3959,7 @@
           <p:cNvPr id="2" name="text-1">
             <a:extLst xmlns:a="http://schemas.openxmlformats.org/drawingml/2006/main">
               <a:ext uri="{FF2B5EF4-FFF2-40B4-BE49-F238E27FC236}">
-                <a16:creationId xmlns:a16="http://schemas.microsoft.com/office/drawing/2014/main" id="{9FCA388A-816D-47B8-83AF-781C1388B0F2}"/>
+                <a16:creationId xmlns:a16="http://schemas.microsoft.com/office/drawing/2014/main" id="{B3FCD8C7-502F-4634-AE77-DE7FB37178F4}"/>
               </a:ext>
             </a:extLst>
           </p:cNvPr>
@@ -3488,8 +3970,8 @@
         </p:nvSpPr>
         <p:spPr>
           <a:xfrm xmlns:a="http://schemas.openxmlformats.org/drawingml/2006/main">
-            <a:off x="10953750" y="6362700"/>
-            <a:ext cx="762000" cy="266700"/>
+            <a:off x="609600" y="885825"/>
+            <a:ext cx="10991850" cy="1047750"/>
           </a:xfrm>
           <a:prstGeom xmlns:a="http://schemas.openxmlformats.org/drawingml/2006/main" prst="rect">
             <a:avLst/>
@@ -3506,9 +3988,9 @@
           <a:lstStyle xmlns:a="http://schemas.openxmlformats.org/drawingml/2006/main"/>
           <a:p xmlns:a="http://schemas.openxmlformats.org/drawingml/2006/main">
             <a:pPr>
-              <a:defRPr sz="1275">
-                <a:solidFill>
-                  <a:srgbClr val="52666C"/>
+              <a:defRPr sz="3525" b="1">
+                <a:solidFill>
+                  <a:srgbClr val="001E2B"/>
                 </a:solidFill>
                 <a:latin typeface="Helvetica Neue"/>
                 <a:ea typeface="Helvetica Neue"/>
@@ -3516,15 +3998,15 @@
               </a:defRPr>
             </a:pPr>
             <a:r>
-              <a:rPr sz="1275">
-                <a:solidFill>
-                  <a:srgbClr val="52666C"/>
+              <a:rPr sz="3525" b="1">
+                <a:solidFill>
+                  <a:srgbClr val="001E2B"/>
                 </a:solidFill>
                 <a:latin typeface="Helvetica Neue"/>
                 <a:ea typeface="Helvetica Neue"/>
                 <a:cs typeface="Helvetica Neue"/>
               </a:rPr>
-              <a:t>4 / 5</a:t>
+              <a:t>MongoDB is the recovery store</a:t>
             </a:r>
           </a:p>
         </p:txBody>
@@ -3534,7 +4016,7 @@
           <p:cNvPr id="3" name="text-2">
             <a:extLst xmlns:a="http://schemas.openxmlformats.org/drawingml/2006/main">
               <a:ext uri="{FF2B5EF4-FFF2-40B4-BE49-F238E27FC236}">
-                <a16:creationId xmlns:a16="http://schemas.microsoft.com/office/drawing/2014/main" id="{42F28F25-5767-47E3-8676-D3C407E79858}"/>
+                <a16:creationId xmlns:a16="http://schemas.microsoft.com/office/drawing/2014/main" id="{48FF2A44-EAB3-4D14-97EE-0CF77036CF0F}"/>
               </a:ext>
             </a:extLst>
           </p:cNvPr>
@@ -3545,8 +4027,8 @@
         </p:nvSpPr>
         <p:spPr>
           <a:xfrm xmlns:a="http://schemas.openxmlformats.org/drawingml/2006/main">
-            <a:off x="628650" y="2209800"/>
-            <a:ext cx="2628900" cy="1314450"/>
+            <a:off x="10972800" y="6372225"/>
+            <a:ext cx="742950" cy="266700"/>
           </a:xfrm>
           <a:prstGeom xmlns:a="http://schemas.openxmlformats.org/drawingml/2006/main" prst="rect">
             <a:avLst/>
@@ -3563,9 +4045,9 @@
           <a:lstStyle xmlns:a="http://schemas.openxmlformats.org/drawingml/2006/main"/>
           <a:p xmlns:a="http://schemas.openxmlformats.org/drawingml/2006/main">
             <a:pPr>
-              <a:defRPr sz="7200" b="1">
-                <a:solidFill>
-                  <a:srgbClr val="007E54"/>
+              <a:defRPr sz="1275">
+                <a:solidFill>
+                  <a:srgbClr val="52666C"/>
                 </a:solidFill>
                 <a:latin typeface="Helvetica Neue"/>
                 <a:ea typeface="Helvetica Neue"/>
@@ -3573,25 +4055,418 @@
               </a:defRPr>
             </a:pPr>
             <a:r>
-              <a:rPr sz="7200" b="1">
-                <a:solidFill>
-                  <a:srgbClr val="007E54"/>
+              <a:rPr sz="1275">
+                <a:solidFill>
+                  <a:srgbClr val="52666C"/>
                 </a:solidFill>
                 <a:latin typeface="Helvetica Neue"/>
                 <a:ea typeface="Helvetica Neue"/>
                 <a:cs typeface="Helvetica Neue"/>
               </a:rPr>
-              <a:t>32</a:t>
-            </a:r>
-          </a:p>
-        </p:txBody>
-      </p:sp>
-      <p:sp>
-        <p:nvSpPr>
-          <p:cNvPr id="4" name="text-3">
+              <a:t>4 / 6</a:t>
+            </a:r>
+          </a:p>
+        </p:txBody>
+      </p:sp>
+      <p:graphicFrame>
+        <p:nvGraphicFramePr>
+          <p:cNvPr id="14" name=""/>
+          <p:cNvGraphicFramePr/>
+          <p:nvPr/>
+        </p:nvGraphicFramePr>
+        <p:xfrm>
+          <a:off xmlns:a="http://schemas.openxmlformats.org/drawingml/2006/main" x="628650" y="2276475"/>
+          <a:ext xmlns:a="http://schemas.openxmlformats.org/drawingml/2006/main" cx="7581900" cy="2886075"/>
+        </p:xfrm>
+        <a:graphic xmlns:a="http://schemas.openxmlformats.org/drawingml/2006/main">
+          <a:graphicData uri="http://schemas.openxmlformats.org/drawingml/2006/table">
+            <a:tbl>
+              <a:tblPr/>
+              <a:tblGrid>
+                <a:gridCol w="2952750"/>
+                <a:gridCol w="1809750"/>
+                <a:gridCol w="2819400"/>
+              </a:tblGrid>
+              <a:tr h="577215">
+                <a:tc>
+                  <a:txBody>
+                    <a:bodyPr/>
+                    <a:lstStyle/>
+                    <a:p>
+                      <a:r>
+                        <a:rPr sz="1875" b="1">
+                          <a:solidFill>
+                            <a:srgbClr val="FFFFFF"/>
+                          </a:solidFill>
+                          <a:latin typeface="Helvetica Neue"/>
+                          <a:ea typeface="Helvetica Neue"/>
+                          <a:cs typeface="Helvetica Neue"/>
+                        </a:rPr>
+                        <a:t>Companion</a:t>
+                      </a:r>
+                    </a:p>
+                  </a:txBody>
+                  <a:tcPr marL="91440" marR="91440" marT="45720" marB="45720">
+                    <a:solidFill>
+                      <a:srgbClr val="001E2B"/>
+                    </a:solidFill>
+                  </a:tcPr>
+                </a:tc>
+                <a:tc>
+                  <a:txBody>
+                    <a:bodyPr/>
+                    <a:lstStyle/>
+                    <a:p>
+                      <a:r>
+                        <a:rPr sz="1875" b="1">
+                          <a:solidFill>
+                            <a:srgbClr val="FFFFFF"/>
+                          </a:solidFill>
+                          <a:latin typeface="Helvetica Neue"/>
+                          <a:ea typeface="Helvetica Neue"/>
+                          <a:cs typeface="Helvetica Neue"/>
+                        </a:rPr>
+                        <a:t>Size</a:t>
+                      </a:r>
+                    </a:p>
+                  </a:txBody>
+                  <a:tcPr marL="91440" marR="91440" marT="45720" marB="45720">
+                    <a:solidFill>
+                      <a:srgbClr val="001E2B"/>
+                    </a:solidFill>
+                  </a:tcPr>
+                </a:tc>
+                <a:tc>
+                  <a:txBody>
+                    <a:bodyPr/>
+                    <a:lstStyle/>
+                    <a:p>
+                      <a:r>
+                        <a:rPr sz="1875" b="1">
+                          <a:solidFill>
+                            <a:srgbClr val="FFFFFF"/>
+                          </a:solidFill>
+                          <a:latin typeface="Helvetica Neue"/>
+                          <a:ea typeface="Helvetica Neue"/>
+                          <a:cs typeface="Helvetica Neue"/>
+                        </a:rPr>
+                        <a:t>SHA-256 prefix</a:t>
+                      </a:r>
+                    </a:p>
+                  </a:txBody>
+                  <a:tcPr marL="91440" marR="91440" marT="45720" marB="45720">
+                    <a:solidFill>
+                      <a:srgbClr val="001E2B"/>
+                    </a:solidFill>
+                  </a:tcPr>
+                </a:tc>
+              </a:tr>
+              <a:tr h="577215">
+                <a:tc>
+                  <a:txBody>
+                    <a:bodyPr/>
+                    <a:lstStyle/>
+                    <a:p>
+                      <a:r>
+                        <a:rPr sz="1875" b="1">
+                          <a:solidFill>
+                            <a:srgbClr val="001E2B"/>
+                          </a:solidFill>
+                          <a:latin typeface="Helvetica Neue"/>
+                          <a:ea typeface="Helvetica Neue"/>
+                          <a:cs typeface="Helvetica Neue"/>
+                        </a:rPr>
+                        <a:t>Agent.image</a:t>
+                      </a:r>
+                    </a:p>
+                  </a:txBody>
+                  <a:tcPr marL="91440" marR="91440" marT="45720" marB="45720">
+                    <a:solidFill>
+                      <a:srgbClr val="FFFFFF"/>
+                    </a:solidFill>
+                  </a:tcPr>
+                </a:tc>
+                <a:tc>
+                  <a:txBody>
+                    <a:bodyPr/>
+                    <a:lstStyle/>
+                    <a:p>
+                      <a:r>
+                        <a:rPr sz="1875" b="0">
+                          <a:solidFill>
+                            <a:srgbClr val="001E2B"/>
+                          </a:solidFill>
+                          <a:latin typeface="Helvetica Neue"/>
+                          <a:ea typeface="Helvetica Neue"/>
+                          <a:cs typeface="Helvetica Neue"/>
+                        </a:rPr>
+                        <a:t>70.40 MB</a:t>
+                      </a:r>
+                    </a:p>
+                  </a:txBody>
+                  <a:tcPr marL="91440" marR="91440" marT="45720" marB="45720">
+                    <a:solidFill>
+                      <a:srgbClr val="FFFFFF"/>
+                    </a:solidFill>
+                  </a:tcPr>
+                </a:tc>
+                <a:tc>
+                  <a:txBody>
+                    <a:bodyPr/>
+                    <a:lstStyle/>
+                    <a:p>
+                      <a:r>
+                        <a:rPr sz="1875" b="0">
+                          <a:solidFill>
+                            <a:srgbClr val="001E2B"/>
+                          </a:solidFill>
+                          <a:latin typeface="Helvetica Neue"/>
+                          <a:ea typeface="Helvetica Neue"/>
+                          <a:cs typeface="Helvetica Neue"/>
+                        </a:rPr>
+                        <a:t>4ed9a1c282</a:t>
+                      </a:r>
+                    </a:p>
+                  </a:txBody>
+                  <a:tcPr marL="91440" marR="91440" marT="45720" marB="45720">
+                    <a:solidFill>
+                      <a:srgbClr val="FFFFFF"/>
+                    </a:solidFill>
+                  </a:tcPr>
+                </a:tc>
+              </a:tr>
+              <a:tr h="577215">
+                <a:tc>
+                  <a:txBody>
+                    <a:bodyPr/>
+                    <a:lstStyle/>
+                    <a:p>
+                      <a:r>
+                        <a:rPr sz="1875" b="1">
+                          <a:solidFill>
+                            <a:srgbClr val="001E2B"/>
+                          </a:solidFill>
+                          <a:latin typeface="Helvetica Neue"/>
+                          <a:ea typeface="Helvetica Neue"/>
+                          <a:cs typeface="Helvetica Neue"/>
+                        </a:rPr>
+                        <a:t>archive.json</a:t>
+                      </a:r>
+                    </a:p>
+                  </a:txBody>
+                  <a:tcPr marL="91440" marR="91440" marT="45720" marB="45720">
+                    <a:solidFill>
+                      <a:srgbClr val="FFFFFF"/>
+                    </a:solidFill>
+                  </a:tcPr>
+                </a:tc>
+                <a:tc>
+                  <a:txBody>
+                    <a:bodyPr/>
+                    <a:lstStyle/>
+                    <a:p>
+                      <a:r>
+                        <a:rPr sz="1875" b="0">
+                          <a:solidFill>
+                            <a:srgbClr val="001E2B"/>
+                          </a:solidFill>
+                          <a:latin typeface="Helvetica Neue"/>
+                          <a:ea typeface="Helvetica Neue"/>
+                          <a:cs typeface="Helvetica Neue"/>
+                        </a:rPr>
+                        <a:t>4.28 MB</a:t>
+                      </a:r>
+                    </a:p>
+                  </a:txBody>
+                  <a:tcPr marL="91440" marR="91440" marT="45720" marB="45720">
+                    <a:solidFill>
+                      <a:srgbClr val="FFFFFF"/>
+                    </a:solidFill>
+                  </a:tcPr>
+                </a:tc>
+                <a:tc>
+                  <a:txBody>
+                    <a:bodyPr/>
+                    <a:lstStyle/>
+                    <a:p>
+                      <a:r>
+                        <a:rPr sz="1875" b="0">
+                          <a:solidFill>
+                            <a:srgbClr val="001E2B"/>
+                          </a:solidFill>
+                          <a:latin typeface="Helvetica Neue"/>
+                          <a:ea typeface="Helvetica Neue"/>
+                          <a:cs typeface="Helvetica Neue"/>
+                        </a:rPr>
+                        <a:t>110e2f979e</a:t>
+                      </a:r>
+                    </a:p>
+                  </a:txBody>
+                  <a:tcPr marL="91440" marR="91440" marT="45720" marB="45720">
+                    <a:solidFill>
+                      <a:srgbClr val="FFFFFF"/>
+                    </a:solidFill>
+                  </a:tcPr>
+                </a:tc>
+              </a:tr>
+              <a:tr h="577215">
+                <a:tc>
+                  <a:txBody>
+                    <a:bodyPr/>
+                    <a:lstStyle/>
+                    <a:p>
+                      <a:r>
+                        <a:rPr sz="1875" b="1">
+                          <a:solidFill>
+                            <a:srgbClr val="001E2B"/>
+                          </a:solidFill>
+                          <a:latin typeface="Helvetica Neue"/>
+                          <a:ea typeface="Helvetica Neue"/>
+                          <a:cs typeface="Helvetica Neue"/>
+                        </a:rPr>
+                        <a:t>Agent.changes</a:t>
+                      </a:r>
+                    </a:p>
+                  </a:txBody>
+                  <a:tcPr marL="91440" marR="91440" marT="45720" marB="45720">
+                    <a:solidFill>
+                      <a:srgbClr val="FFFFFF"/>
+                    </a:solidFill>
+                  </a:tcPr>
+                </a:tc>
+                <a:tc>
+                  <a:txBody>
+                    <a:bodyPr/>
+                    <a:lstStyle/>
+                    <a:p>
+                      <a:r>
+                        <a:rPr sz="1875" b="0">
+                          <a:solidFill>
+                            <a:srgbClr val="001E2B"/>
+                          </a:solidFill>
+                          <a:latin typeface="Helvetica Neue"/>
+                          <a:ea typeface="Helvetica Neue"/>
+                          <a:cs typeface="Helvetica Neue"/>
+                        </a:rPr>
+                        <a:t>0.32 MB</a:t>
+                      </a:r>
+                    </a:p>
+                  </a:txBody>
+                  <a:tcPr marL="91440" marR="91440" marT="45720" marB="45720">
+                    <a:solidFill>
+                      <a:srgbClr val="FFFFFF"/>
+                    </a:solidFill>
+                  </a:tcPr>
+                </a:tc>
+                <a:tc>
+                  <a:txBody>
+                    <a:bodyPr/>
+                    <a:lstStyle/>
+                    <a:p>
+                      <a:r>
+                        <a:rPr sz="1875" b="0">
+                          <a:solidFill>
+                            <a:srgbClr val="001E2B"/>
+                          </a:solidFill>
+                          <a:latin typeface="Helvetica Neue"/>
+                          <a:ea typeface="Helvetica Neue"/>
+                          <a:cs typeface="Helvetica Neue"/>
+                        </a:rPr>
+                        <a:t>2bda01df7b</a:t>
+                      </a:r>
+                    </a:p>
+                  </a:txBody>
+                  <a:tcPr marL="91440" marR="91440" marT="45720" marB="45720">
+                    <a:solidFill>
+                      <a:srgbClr val="FFFFFF"/>
+                    </a:solidFill>
+                  </a:tcPr>
+                </a:tc>
+              </a:tr>
+              <a:tr h="577215">
+                <a:tc>
+                  <a:txBody>
+                    <a:bodyPr/>
+                    <a:lstStyle/>
+                    <a:p>
+                      <a:r>
+                        <a:rPr sz="1875" b="1">
+                          <a:solidFill>
+                            <a:srgbClr val="001E2B"/>
+                          </a:solidFill>
+                          <a:latin typeface="Helvetica Neue"/>
+                          <a:ea typeface="Helvetica Neue"/>
+                          <a:cs typeface="Helvetica Neue"/>
+                        </a:rPr>
+                        <a:t>Pharo .sources</a:t>
+                      </a:r>
+                    </a:p>
+                  </a:txBody>
+                  <a:tcPr marL="91440" marR="91440" marT="45720" marB="45720">
+                    <a:solidFill>
+                      <a:srgbClr val="FFFFFF"/>
+                    </a:solidFill>
+                  </a:tcPr>
+                </a:tc>
+                <a:tc>
+                  <a:txBody>
+                    <a:bodyPr/>
+                    <a:lstStyle/>
+                    <a:p>
+                      <a:r>
+                        <a:rPr sz="1875" b="0">
+                          <a:solidFill>
+                            <a:srgbClr val="001E2B"/>
+                          </a:solidFill>
+                          <a:latin typeface="Helvetica Neue"/>
+                          <a:ea typeface="Helvetica Neue"/>
+                          <a:cs typeface="Helvetica Neue"/>
+                        </a:rPr>
+                        <a:t>45.28 MB</a:t>
+                      </a:r>
+                    </a:p>
+                  </a:txBody>
+                  <a:tcPr marL="91440" marR="91440" marT="45720" marB="45720">
+                    <a:solidFill>
+                      <a:srgbClr val="FFFFFF"/>
+                    </a:solidFill>
+                  </a:tcPr>
+                </a:tc>
+                <a:tc>
+                  <a:txBody>
+                    <a:bodyPr/>
+                    <a:lstStyle/>
+                    <a:p>
+                      <a:r>
+                        <a:rPr sz="1875" b="0">
+                          <a:solidFill>
+                            <a:srgbClr val="001E2B"/>
+                          </a:solidFill>
+                          <a:latin typeface="Helvetica Neue"/>
+                          <a:ea typeface="Helvetica Neue"/>
+                          <a:cs typeface="Helvetica Neue"/>
+                        </a:rPr>
+                        <a:t>4f93dab730</a:t>
+                      </a:r>
+                    </a:p>
+                  </a:txBody>
+                  <a:tcPr marL="91440" marR="91440" marT="45720" marB="45720">
+                    <a:solidFill>
+                      <a:srgbClr val="FFFFFF"/>
+                    </a:solidFill>
+                  </a:tcPr>
+                </a:tc>
+              </a:tr>
+            </a:tbl>
+          </a:graphicData>
+        </a:graphic>
+      </p:graphicFrame>
+      <p:sp>
+        <p:nvSpPr>
+          <p:cNvPr id="5" name="text-3">
             <a:extLst xmlns:a="http://schemas.openxmlformats.org/drawingml/2006/main">
               <a:ext uri="{FF2B5EF4-FFF2-40B4-BE49-F238E27FC236}">
-                <a16:creationId xmlns:a16="http://schemas.microsoft.com/office/drawing/2014/main" id="{0AF9632E-31DB-4E64-AAF8-30EC91CDBD5F}"/>
+                <a16:creationId xmlns:a16="http://schemas.microsoft.com/office/drawing/2014/main" id="{0323F4A6-25BC-4D09-B420-27DF1B72AFE1}"/>
               </a:ext>
             </a:extLst>
           </p:cNvPr>
@@ -3602,8 +4477,8 @@
         </p:nvSpPr>
         <p:spPr>
           <a:xfrm xmlns:a="http://schemas.openxmlformats.org/drawingml/2006/main">
-            <a:off x="628650" y="3752850"/>
-            <a:ext cx="2667000" cy="523875"/>
+            <a:off x="8639175" y="2219325"/>
+            <a:ext cx="3009900" cy="600075"/>
           </a:xfrm>
           <a:prstGeom xmlns:a="http://schemas.openxmlformats.org/drawingml/2006/main" prst="rect">
             <a:avLst/>
@@ -3620,7 +4495,7 @@
           <a:lstStyle xmlns:a="http://schemas.openxmlformats.org/drawingml/2006/main"/>
           <a:p xmlns:a="http://schemas.openxmlformats.org/drawingml/2006/main">
             <a:pPr>
-              <a:defRPr sz="2100" b="1">
+              <a:defRPr sz="2775" b="1">
                 <a:solidFill>
                   <a:srgbClr val="001E2B"/>
                 </a:solidFill>
@@ -3630,7 +4505,7 @@
               </a:defRPr>
             </a:pPr>
             <a:r>
-              <a:rPr sz="2100" b="1">
+              <a:rPr sz="2775" b="1">
                 <a:solidFill>
                   <a:srgbClr val="001E2B"/>
                 </a:solidFill>
@@ -3638,17 +4513,17 @@
                 <a:ea typeface="Helvetica Neue"/>
                 <a:cs typeface="Helvetica Neue"/>
               </a:rPr>
-              <a:t>Restored runs</a:t>
-            </a:r>
-          </a:p>
-        </p:txBody>
-      </p:sp>
-      <p:sp>
-        <p:nvSpPr>
-          <p:cNvPr id="5" name="">
+              <a:t>GridFS</a:t>
+            </a:r>
+          </a:p>
+        </p:txBody>
+      </p:sp>
+      <p:sp>
+        <p:nvSpPr>
+          <p:cNvPr id="6" name="text-4">
             <a:extLst xmlns:a="http://schemas.openxmlformats.org/drawingml/2006/main">
               <a:ext uri="{FF2B5EF4-FFF2-40B4-BE49-F238E27FC236}">
-                <a16:creationId xmlns:a16="http://schemas.microsoft.com/office/drawing/2014/main" id="{F88BCE1E-6C44-4487-9224-B7BBE8D39E44}"/>
+                <a16:creationId xmlns:a16="http://schemas.microsoft.com/office/drawing/2014/main" id="{B7A6916F-47C9-4E4C-9E5D-6AACDC92ED39}"/>
               </a:ext>
             </a:extLst>
           </p:cNvPr>
@@ -3659,38 +4534,8 @@
         </p:nvSpPr>
         <p:spPr>
           <a:xfrm xmlns:a="http://schemas.openxmlformats.org/drawingml/2006/main">
-            <a:off x="628650" y="4514850"/>
-            <a:ext cx="2333625" cy="19050"/>
-          </a:xfrm>
-          <a:prstGeom xmlns:a="http://schemas.openxmlformats.org/drawingml/2006/main" prst="rect">
-            <a:avLst/>
-          </a:prstGeom>
-          <a:solidFill xmlns:a="http://schemas.openxmlformats.org/drawingml/2006/main">
-            <a:srgbClr val="C8D7D1"/>
-          </a:solidFill>
-          <a:ln xmlns:a="http://schemas.openxmlformats.org/drawingml/2006/main" w="0">
-            <a:noFill/>
-          </a:ln>
-        </p:spPr>
-      </p:sp>
-      <p:sp>
-        <p:nvSpPr>
-          <p:cNvPr id="6" name="text-5">
-            <a:extLst xmlns:a="http://schemas.openxmlformats.org/drawingml/2006/main">
-              <a:ext uri="{FF2B5EF4-FFF2-40B4-BE49-F238E27FC236}">
-                <a16:creationId xmlns:a16="http://schemas.microsoft.com/office/drawing/2014/main" id="{97602A33-1A46-4D23-B814-5986A4629E1F}"/>
-              </a:ext>
-            </a:extLst>
-          </p:cNvPr>
-          <p:cNvSpPr>
-            <a:spLocks xmlns:a="http://schemas.openxmlformats.org/drawingml/2006/main" noGrp="1"/>
-          </p:cNvSpPr>
-          <p:nvPr/>
-        </p:nvSpPr>
-        <p:spPr>
-          <a:xfrm xmlns:a="http://schemas.openxmlformats.org/drawingml/2006/main">
-            <a:off x="3419475" y="2209800"/>
-            <a:ext cx="2628900" cy="1314450"/>
+            <a:off x="8639175" y="2971800"/>
+            <a:ext cx="2933700" cy="981075"/>
           </a:xfrm>
           <a:prstGeom xmlns:a="http://schemas.openxmlformats.org/drawingml/2006/main" prst="rect">
             <a:avLst/>
@@ -3707,7 +4552,7 @@
           <a:lstStyle xmlns:a="http://schemas.openxmlformats.org/drawingml/2006/main"/>
           <a:p xmlns:a="http://schemas.openxmlformats.org/drawingml/2006/main">
             <a:pPr>
-              <a:defRPr sz="7200" b="1">
+              <a:defRPr sz="2400">
                 <a:solidFill>
                   <a:srgbClr val="007E54"/>
                 </a:solidFill>
@@ -3717,7 +4562,7 @@
               </a:defRPr>
             </a:pPr>
             <a:r>
-              <a:rPr sz="7200" b="1">
+              <a:rPr sz="2400">
                 <a:solidFill>
                   <a:srgbClr val="007E54"/>
                 </a:solidFill>
@@ -3725,17 +4570,40 @@
                 <a:ea typeface="Helvetica Neue"/>
                 <a:cs typeface="Helvetica Neue"/>
               </a:rPr>
-              <a:t>491</a:t>
-            </a:r>
-          </a:p>
-        </p:txBody>
-      </p:sp>
-      <p:sp>
-        <p:nvSpPr>
-          <p:cNvPr id="7" name="text-6">
+              <a:t>.files</a:t>
+            </a:r>
+          </a:p>
+          <a:p xmlns:a="http://schemas.openxmlformats.org/drawingml/2006/main">
+            <a:pPr>
+              <a:defRPr sz="2400">
+                <a:solidFill>
+                  <a:srgbClr val="007E54"/>
+                </a:solidFill>
+                <a:latin typeface="Helvetica Neue"/>
+                <a:ea typeface="Helvetica Neue"/>
+                <a:cs typeface="Helvetica Neue"/>
+              </a:defRPr>
+            </a:pPr>
+            <a:r>
+              <a:rPr sz="2400">
+                <a:solidFill>
+                  <a:srgbClr val="007E54"/>
+                </a:solidFill>
+                <a:latin typeface="Helvetica Neue"/>
+                <a:ea typeface="Helvetica Neue"/>
+                <a:cs typeface="Helvetica Neue"/>
+              </a:rPr>
+              <a:t>.chunks</a:t>
+            </a:r>
+          </a:p>
+        </p:txBody>
+      </p:sp>
+      <p:sp>
+        <p:nvSpPr>
+          <p:cNvPr id="7" name="text-5">
             <a:extLst xmlns:a="http://schemas.openxmlformats.org/drawingml/2006/main">
               <a:ext uri="{FF2B5EF4-FFF2-40B4-BE49-F238E27FC236}">
-                <a16:creationId xmlns:a16="http://schemas.microsoft.com/office/drawing/2014/main" id="{80A6AC11-1205-4795-87CD-B6C36870CBC9}"/>
+                <a16:creationId xmlns:a16="http://schemas.microsoft.com/office/drawing/2014/main" id="{EDB4A33F-1501-45DE-ACA9-2103E74E5291}"/>
               </a:ext>
             </a:extLst>
           </p:cNvPr>
@@ -3746,8 +4614,8 @@
         </p:nvSpPr>
         <p:spPr>
           <a:xfrm xmlns:a="http://schemas.openxmlformats.org/drawingml/2006/main">
-            <a:off x="3419475" y="3752850"/>
-            <a:ext cx="2667000" cy="523875"/>
+            <a:off x="8639175" y="4143375"/>
+            <a:ext cx="2943225" cy="723900"/>
           </a:xfrm>
           <a:prstGeom xmlns:a="http://schemas.openxmlformats.org/drawingml/2006/main" prst="rect">
             <a:avLst/>
@@ -3782,17 +4650,17 @@
                 <a:ea typeface="Helvetica Neue"/>
                 <a:cs typeface="Helvetica Neue"/>
               </a:rPr>
-              <a:t>Embedded files</a:t>
-            </a:r>
-          </a:p>
-        </p:txBody>
-      </p:sp>
-      <p:sp>
-        <p:nvSpPr>
-          <p:cNvPr id="8" name="">
+              <a:t>Snapshot manifest</a:t>
+            </a:r>
+          </a:p>
+        </p:txBody>
+      </p:sp>
+      <p:sp>
+        <p:nvSpPr>
+          <p:cNvPr id="8" name="text-6">
             <a:extLst xmlns:a="http://schemas.openxmlformats.org/drawingml/2006/main">
               <a:ext uri="{FF2B5EF4-FFF2-40B4-BE49-F238E27FC236}">
-                <a16:creationId xmlns:a16="http://schemas.microsoft.com/office/drawing/2014/main" id="{3F5AD8BE-2C8D-4C64-BF41-66447BD86E1C}"/>
+                <a16:creationId xmlns:a16="http://schemas.microsoft.com/office/drawing/2014/main" id="{27058912-6DC5-49E6-B0C4-C5338743CCA7}"/>
               </a:ext>
             </a:extLst>
           </p:cNvPr>
@@ -3803,38 +4671,8 @@
         </p:nvSpPr>
         <p:spPr>
           <a:xfrm xmlns:a="http://schemas.openxmlformats.org/drawingml/2006/main">
-            <a:off x="3419475" y="4514850"/>
-            <a:ext cx="2333625" cy="19050"/>
-          </a:xfrm>
-          <a:prstGeom xmlns:a="http://schemas.openxmlformats.org/drawingml/2006/main" prst="rect">
-            <a:avLst/>
-          </a:prstGeom>
-          <a:solidFill xmlns:a="http://schemas.openxmlformats.org/drawingml/2006/main">
-            <a:srgbClr val="C8D7D1"/>
-          </a:solidFill>
-          <a:ln xmlns:a="http://schemas.openxmlformats.org/drawingml/2006/main" w="0">
-            <a:noFill/>
-          </a:ln>
-        </p:spPr>
-      </p:sp>
-      <p:sp>
-        <p:nvSpPr>
-          <p:cNvPr id="9" name="text-8">
-            <a:extLst xmlns:a="http://schemas.openxmlformats.org/drawingml/2006/main">
-              <a:ext uri="{FF2B5EF4-FFF2-40B4-BE49-F238E27FC236}">
-                <a16:creationId xmlns:a16="http://schemas.microsoft.com/office/drawing/2014/main" id="{40DBEC24-FB1E-4722-A929-222FE1BDFF67}"/>
-              </a:ext>
-            </a:extLst>
-          </p:cNvPr>
-          <p:cNvSpPr>
-            <a:spLocks xmlns:a="http://schemas.openxmlformats.org/drawingml/2006/main" noGrp="1"/>
-          </p:cNvSpPr>
-          <p:nvPr/>
-        </p:nvSpPr>
-        <p:spPr>
-          <a:xfrm xmlns:a="http://schemas.openxmlformats.org/drawingml/2006/main">
-            <a:off x="6210300" y="2209800"/>
-            <a:ext cx="2628900" cy="1314450"/>
+            <a:off x="8639175" y="4981575"/>
+            <a:ext cx="2952750" cy="476250"/>
           </a:xfrm>
           <a:prstGeom xmlns:a="http://schemas.openxmlformats.org/drawingml/2006/main" prst="rect">
             <a:avLst/>
@@ -3851,9 +4689,9 @@
           <a:lstStyle xmlns:a="http://schemas.openxmlformats.org/drawingml/2006/main"/>
           <a:p xmlns:a="http://schemas.openxmlformats.org/drawingml/2006/main">
             <a:pPr>
-              <a:defRPr sz="7200" b="1">
-                <a:solidFill>
-                  <a:srgbClr val="007E54"/>
+              <a:defRPr sz="1800">
+                <a:solidFill>
+                  <a:srgbClr val="52666C"/>
                 </a:solidFill>
                 <a:latin typeface="Helvetica Neue"/>
                 <a:ea typeface="Helvetica Neue"/>
@@ -3861,25 +4699,25 @@
               </a:defRPr>
             </a:pPr>
             <a:r>
-              <a:rPr sz="7200" b="1">
-                <a:solidFill>
-                  <a:srgbClr val="007E54"/>
+              <a:rPr sz="1800">
+                <a:solidFill>
+                  <a:srgbClr val="52666C"/>
                 </a:solidFill>
                 <a:latin typeface="Helvetica Neue"/>
                 <a:ea typeface="Helvetica Neue"/>
                 <a:cs typeface="Helvetica Neue"/>
               </a:rPr>
-              <a:t>6</a:t>
-            </a:r>
-          </a:p>
-        </p:txBody>
-      </p:sp>
-      <p:sp>
-        <p:nvSpPr>
-          <p:cNvPr id="10" name="text-9">
+              <a:t>IDs, sizes, hashes</a:t>
+            </a:r>
+          </a:p>
+        </p:txBody>
+      </p:sp>
+      <p:sp>
+        <p:nvSpPr>
+          <p:cNvPr id="9" name="text-7">
             <a:extLst xmlns:a="http://schemas.openxmlformats.org/drawingml/2006/main">
               <a:ext uri="{FF2B5EF4-FFF2-40B4-BE49-F238E27FC236}">
-                <a16:creationId xmlns:a16="http://schemas.microsoft.com/office/drawing/2014/main" id="{D7B685F9-3882-4B43-B2B7-D6850D6A1CC6}"/>
+                <a16:creationId xmlns:a16="http://schemas.microsoft.com/office/drawing/2014/main" id="{462D690F-2244-4CDA-A5E5-1242F9A7C28B}"/>
               </a:ext>
             </a:extLst>
           </p:cNvPr>
@@ -3890,8 +4728,8 @@
         </p:nvSpPr>
         <p:spPr>
           <a:xfrm xmlns:a="http://schemas.openxmlformats.org/drawingml/2006/main">
-            <a:off x="6210300" y="3752850"/>
-            <a:ext cx="2667000" cy="523875"/>
+            <a:off x="628650" y="5734050"/>
+            <a:ext cx="10915650" cy="571500"/>
           </a:xfrm>
           <a:prstGeom xmlns:a="http://schemas.openxmlformats.org/drawingml/2006/main" prst="rect">
             <a:avLst/>
@@ -3926,17 +4764,17 @@
                 <a:ea typeface="Helvetica Neue"/>
                 <a:cs typeface="Helvetica Neue"/>
               </a:rPr>
-              <a:t>Git bundles</a:t>
-            </a:r>
-          </a:p>
-        </p:txBody>
-      </p:sp>
-      <p:sp>
-        <p:nvSpPr>
-          <p:cNvPr id="11" name="">
+              <a:t>Publish the manifest last. Verify every download before restoring.</a:t>
+            </a:r>
+          </a:p>
+        </p:txBody>
+      </p:sp>
+      <p:sp>
+        <p:nvSpPr>
+          <p:cNvPr id="10" name="text-8">
             <a:extLst xmlns:a="http://schemas.openxmlformats.org/drawingml/2006/main">
               <a:ext uri="{FF2B5EF4-FFF2-40B4-BE49-F238E27FC236}">
-                <a16:creationId xmlns:a16="http://schemas.microsoft.com/office/drawing/2014/main" id="{046CCF67-D9F1-48F3-9967-68CB1808C5AA}"/>
+                <a16:creationId xmlns:a16="http://schemas.microsoft.com/office/drawing/2014/main" id="{A834DBD9-0A00-4D9A-93FF-19872201AAD1}"/>
               </a:ext>
             </a:extLst>
           </p:cNvPr>
@@ -3947,38 +4785,8 @@
         </p:nvSpPr>
         <p:spPr>
           <a:xfrm xmlns:a="http://schemas.openxmlformats.org/drawingml/2006/main">
-            <a:off x="6210300" y="4514850"/>
-            <a:ext cx="2333625" cy="19050"/>
-          </a:xfrm>
-          <a:prstGeom xmlns:a="http://schemas.openxmlformats.org/drawingml/2006/main" prst="rect">
-            <a:avLst/>
-          </a:prstGeom>
-          <a:solidFill xmlns:a="http://schemas.openxmlformats.org/drawingml/2006/main">
-            <a:srgbClr val="C8D7D1"/>
-          </a:solidFill>
-          <a:ln xmlns:a="http://schemas.openxmlformats.org/drawingml/2006/main" w="0">
-            <a:noFill/>
-          </a:ln>
-        </p:spPr>
-      </p:sp>
-      <p:sp>
-        <p:nvSpPr>
-          <p:cNvPr id="12" name="text-11">
-            <a:extLst xmlns:a="http://schemas.openxmlformats.org/drawingml/2006/main">
-              <a:ext uri="{FF2B5EF4-FFF2-40B4-BE49-F238E27FC236}">
-                <a16:creationId xmlns:a16="http://schemas.microsoft.com/office/drawing/2014/main" id="{AD3D3EF7-C607-4F58-8632-F635CF4F29A6}"/>
-              </a:ext>
-            </a:extLst>
-          </p:cNvPr>
-          <p:cNvSpPr>
-            <a:spLocks xmlns:a="http://schemas.openxmlformats.org/drawingml/2006/main" noGrp="1"/>
-          </p:cNvSpPr>
-          <p:nvPr/>
-        </p:nvSpPr>
-        <p:spPr>
-          <a:xfrm xmlns:a="http://schemas.openxmlformats.org/drawingml/2006/main">
-            <a:off x="9001125" y="2209800"/>
-            <a:ext cx="2628900" cy="1314450"/>
+            <a:off x="628650" y="6286500"/>
+            <a:ext cx="10267950" cy="276225"/>
           </a:xfrm>
           <a:prstGeom xmlns:a="http://schemas.openxmlformats.org/drawingml/2006/main" prst="rect">
             <a:avLst/>
@@ -3995,9 +4803,9 @@
           <a:lstStyle xmlns:a="http://schemas.openxmlformats.org/drawingml/2006/main"/>
           <a:p xmlns:a="http://schemas.openxmlformats.org/drawingml/2006/main">
             <a:pPr>
-              <a:defRPr sz="7200" b="1">
-                <a:solidFill>
-                  <a:srgbClr val="007E54"/>
+              <a:defRPr sz="1500">
+                <a:solidFill>
+                  <a:srgbClr val="52666C"/>
                 </a:solidFill>
                 <a:latin typeface="Helvetica Neue"/>
                 <a:ea typeface="Helvetica Neue"/>
@@ -4005,216 +4813,15 @@
               </a:defRPr>
             </a:pPr>
             <a:r>
-              <a:rPr sz="7200" b="1">
-                <a:solidFill>
-                  <a:srgbClr val="007E54"/>
+              <a:rPr sz="1500">
+                <a:solidFill>
+                  <a:srgbClr val="52666C"/>
                 </a:solidFill>
                 <a:latin typeface="Helvetica Neue"/>
                 <a:ea typeface="Helvetica Neue"/>
                 <a:cs typeface="Helvetica Neue"/>
               </a:rPr>
-              <a:t>4</a:t>
-            </a:r>
-          </a:p>
-        </p:txBody>
-      </p:sp>
-      <p:sp>
-        <p:nvSpPr>
-          <p:cNvPr id="13" name="text-12">
-            <a:extLst xmlns:a="http://schemas.openxmlformats.org/drawingml/2006/main">
-              <a:ext uri="{FF2B5EF4-FFF2-40B4-BE49-F238E27FC236}">
-                <a16:creationId xmlns:a16="http://schemas.microsoft.com/office/drawing/2014/main" id="{ED18E1F2-8879-4CEA-9925-DBCBF4C2A918}"/>
-              </a:ext>
-            </a:extLst>
-          </p:cNvPr>
-          <p:cNvSpPr>
-            <a:spLocks xmlns:a="http://schemas.openxmlformats.org/drawingml/2006/main" noGrp="1"/>
-          </p:cNvSpPr>
-          <p:nvPr/>
-        </p:nvSpPr>
-        <p:spPr>
-          <a:xfrm xmlns:a="http://schemas.openxmlformats.org/drawingml/2006/main">
-            <a:off x="9001125" y="3752850"/>
-            <a:ext cx="2667000" cy="523875"/>
-          </a:xfrm>
-          <a:prstGeom xmlns:a="http://schemas.openxmlformats.org/drawingml/2006/main" prst="rect">
-            <a:avLst/>
-          </a:prstGeom>
-          <a:noFill xmlns:a="http://schemas.openxmlformats.org/drawingml/2006/main"/>
-          <a:ln xmlns:a="http://schemas.openxmlformats.org/drawingml/2006/main" w="0">
-            <a:noFill/>
-          </a:ln>
-        </p:spPr>
-        <p:txBody>
-          <a:bodyPr xmlns:a="http://schemas.openxmlformats.org/drawingml/2006/main">
-            <a:noAutofit/>
-          </a:bodyPr>
-          <a:lstStyle xmlns:a="http://schemas.openxmlformats.org/drawingml/2006/main"/>
-          <a:p xmlns:a="http://schemas.openxmlformats.org/drawingml/2006/main">
-            <a:pPr>
-              <a:defRPr sz="2100" b="1">
-                <a:solidFill>
-                  <a:srgbClr val="001E2B"/>
-                </a:solidFill>
-                <a:latin typeface="Helvetica Neue"/>
-                <a:ea typeface="Helvetica Neue"/>
-                <a:cs typeface="Helvetica Neue"/>
-              </a:defRPr>
-            </a:pPr>
-            <a:r>
-              <a:rPr sz="2100" b="1">
-                <a:solidFill>
-                  <a:srgbClr val="001E2B"/>
-                </a:solidFill>
-                <a:latin typeface="Helvetica Neue"/>
-                <a:ea typeface="Helvetica Neue"/>
-                <a:cs typeface="Helvetica Neue"/>
-              </a:rPr>
-              <a:t>Companion hashes</a:t>
-            </a:r>
-          </a:p>
-        </p:txBody>
-      </p:sp>
-      <p:sp>
-        <p:nvSpPr>
-          <p:cNvPr id="14" name="">
-            <a:extLst xmlns:a="http://schemas.openxmlformats.org/drawingml/2006/main">
-              <a:ext uri="{FF2B5EF4-FFF2-40B4-BE49-F238E27FC236}">
-                <a16:creationId xmlns:a16="http://schemas.microsoft.com/office/drawing/2014/main" id="{5AEAB234-EF41-4C18-AA68-2A6AAC7A60FE}"/>
-              </a:ext>
-            </a:extLst>
-          </p:cNvPr>
-          <p:cNvSpPr>
-            <a:spLocks xmlns:a="http://schemas.openxmlformats.org/drawingml/2006/main" noGrp="1"/>
-          </p:cNvSpPr>
-          <p:nvPr/>
-        </p:nvSpPr>
-        <p:spPr>
-          <a:xfrm xmlns:a="http://schemas.openxmlformats.org/drawingml/2006/main">
-            <a:off x="9001125" y="4514850"/>
-            <a:ext cx="2333625" cy="19050"/>
-          </a:xfrm>
-          <a:prstGeom xmlns:a="http://schemas.openxmlformats.org/drawingml/2006/main" prst="rect">
-            <a:avLst/>
-          </a:prstGeom>
-          <a:solidFill xmlns:a="http://schemas.openxmlformats.org/drawingml/2006/main">
-            <a:srgbClr val="C8D7D1"/>
-          </a:solidFill>
-          <a:ln xmlns:a="http://schemas.openxmlformats.org/drawingml/2006/main" w="0">
-            <a:noFill/>
-          </a:ln>
-        </p:spPr>
-      </p:sp>
-      <p:sp>
-        <p:nvSpPr>
-          <p:cNvPr id="15" name="text-14">
-            <a:extLst xmlns:a="http://schemas.openxmlformats.org/drawingml/2006/main">
-              <a:ext uri="{FF2B5EF4-FFF2-40B4-BE49-F238E27FC236}">
-                <a16:creationId xmlns:a16="http://schemas.microsoft.com/office/drawing/2014/main" id="{D999CC00-6352-43A1-ADFD-8C3D15EB1FB0}"/>
-              </a:ext>
-            </a:extLst>
-          </p:cNvPr>
-          <p:cNvSpPr>
-            <a:spLocks xmlns:a="http://schemas.openxmlformats.org/drawingml/2006/main" noGrp="1"/>
-          </p:cNvSpPr>
-          <p:nvPr/>
-        </p:nvSpPr>
-        <p:spPr>
-          <a:xfrm xmlns:a="http://schemas.openxmlformats.org/drawingml/2006/main">
-            <a:off x="628650" y="5143500"/>
-            <a:ext cx="10953750" cy="523875"/>
-          </a:xfrm>
-          <a:prstGeom xmlns:a="http://schemas.openxmlformats.org/drawingml/2006/main" prst="rect">
-            <a:avLst/>
-          </a:prstGeom>
-          <a:noFill xmlns:a="http://schemas.openxmlformats.org/drawingml/2006/main"/>
-          <a:ln xmlns:a="http://schemas.openxmlformats.org/drawingml/2006/main" w="0">
-            <a:noFill/>
-          </a:ln>
-        </p:spPr>
-        <p:txBody>
-          <a:bodyPr xmlns:a="http://schemas.openxmlformats.org/drawingml/2006/main">
-            <a:noAutofit/>
-          </a:bodyPr>
-          <a:lstStyle xmlns:a="http://schemas.openxmlformats.org/drawingml/2006/main"/>
-          <a:p xmlns:a="http://schemas.openxmlformats.org/drawingml/2006/main">
-            <a:pPr>
-              <a:defRPr sz="2325" b="1">
-                <a:solidFill>
-                  <a:srgbClr val="001E2B"/>
-                </a:solidFill>
-                <a:latin typeface="Helvetica Neue"/>
-                <a:ea typeface="Helvetica Neue"/>
-                <a:cs typeface="Helvetica Neue"/>
-              </a:defRPr>
-            </a:pPr>
-            <a:r>
-              <a:rPr sz="2325" b="1">
-                <a:solidFill>
-                  <a:srgbClr val="001E2B"/>
-                </a:solidFill>
-                <a:latin typeface="Helvetica Neue"/>
-                <a:ea typeface="Helvetica Neue"/>
-                <a:cs typeface="Helvetica Neue"/>
-              </a:rPr>
-              <a:t>Prior Atlas snapshot, separate from the Qwen experiment</a:t>
-            </a:r>
-          </a:p>
-        </p:txBody>
-      </p:sp>
-      <p:sp>
-        <p:nvSpPr>
-          <p:cNvPr id="16" name="text-15">
-            <a:extLst xmlns:a="http://schemas.openxmlformats.org/drawingml/2006/main">
-              <a:ext uri="{FF2B5EF4-FFF2-40B4-BE49-F238E27FC236}">
-                <a16:creationId xmlns:a16="http://schemas.microsoft.com/office/drawing/2014/main" id="{40B79B4F-9D8B-46C4-AF6F-794DF48B07D3}"/>
-              </a:ext>
-            </a:extLst>
-          </p:cNvPr>
-          <p:cNvSpPr>
-            <a:spLocks xmlns:a="http://schemas.openxmlformats.org/drawingml/2006/main" noGrp="1"/>
-          </p:cNvSpPr>
-          <p:nvPr/>
-        </p:nvSpPr>
-        <p:spPr>
-          <a:xfrm xmlns:a="http://schemas.openxmlformats.org/drawingml/2006/main">
-            <a:off x="628650" y="5886450"/>
-            <a:ext cx="10934700" cy="352425"/>
-          </a:xfrm>
-          <a:prstGeom xmlns:a="http://schemas.openxmlformats.org/drawingml/2006/main" prst="rect">
-            <a:avLst/>
-          </a:prstGeom>
-          <a:noFill xmlns:a="http://schemas.openxmlformats.org/drawingml/2006/main"/>
-          <a:ln xmlns:a="http://schemas.openxmlformats.org/drawingml/2006/main" w="0">
-            <a:noFill/>
-          </a:ln>
-        </p:spPr>
-        <p:txBody>
-          <a:bodyPr xmlns:a="http://schemas.openxmlformats.org/drawingml/2006/main">
-            <a:noAutofit/>
-          </a:bodyPr>
-          <a:lstStyle xmlns:a="http://schemas.openxmlformats.org/drawingml/2006/main"/>
-          <a:p xmlns:a="http://schemas.openxmlformats.org/drawingml/2006/main">
-            <a:pPr>
-              <a:defRPr sz="1650">
-                <a:solidFill>
-                  <a:srgbClr val="52666C"/>
-                </a:solidFill>
-                <a:latin typeface="Helvetica Neue"/>
-                <a:ea typeface="Helvetica Neue"/>
-                <a:cs typeface="Helvetica Neue"/>
-              </a:defRPr>
-            </a:pPr>
-            <a:r>
-              <a:rPr sz="1650">
-                <a:solidFill>
-                  <a:srgbClr val="52666C"/>
-                </a:solidFill>
-                <a:latin typeface="Helvetica Neue"/>
-                <a:ea typeface="Helvetica Neue"/>
-                <a:cs typeface="Helvetica Neue"/>
-              </a:rPr>
-              <a:t>Snapshot b185069cbeefb5e464e4523d  /  September 26, 2026</a:t>
+              <a:t>Actual companion metadata from the prior verified Atlas snapshot</a:t>
             </a:r>
           </a:p>
         </p:txBody>
@@ -4222,7 +4829,7 @@
     </p:spTree>
     <p:extLst>
       <p:ext uri="{BB962C8B-B14F-4D97-AF65-F5344CB8AC3E}">
-        <p14:creationId xmlns:p14="http://schemas.microsoft.com/office/powerpoint/2010/main" val="636344815"/>
+        <p14:creationId xmlns:p14="http://schemas.microsoft.com/office/powerpoint/2010/main" val="1532337947"/>
       </p:ext>
     </p:extLst>
   </p:cSld>
@@ -4230,6 +4837,533 @@
 </file>
 
 <file path=ppt/slides/slide5.xml><?xml version="1.0" encoding="utf-8"?>
+<p:sld xmlns:p="http://schemas.openxmlformats.org/presentationml/2006/main">
+  <p:cSld>
+    <p:bg>
+      <p:bgPr>
+        <a:solidFill xmlns:a="http://schemas.openxmlformats.org/drawingml/2006/main">
+          <a:srgbClr val="F7FAF8"/>
+        </a:solidFill>
+      </p:bgPr>
+    </p:bg>
+    <p:spTree>
+      <p:nvGrpSpPr>
+        <p:cNvPr id="1" name=""/>
+        <p:cNvGrpSpPr/>
+        <p:nvPr/>
+      </p:nvGrpSpPr>
+      <p:grpSpPr>
+        <a:xfrm xmlns:a="http://schemas.openxmlformats.org/drawingml/2006/main"/>
+      </p:grpSpPr>
+      <p:sp>
+        <p:nvSpPr>
+          <p:cNvPr id="9" name="text-0">
+            <a:extLst xmlns:a="http://schemas.openxmlformats.org/drawingml/2006/main">
+              <a:ext uri="{FF2B5EF4-FFF2-40B4-BE49-F238E27FC236}">
+                <a16:creationId xmlns:a16="http://schemas.microsoft.com/office/drawing/2014/main" id="{1A664348-9F0D-496C-B6DF-BE64B3B52307}"/>
+              </a:ext>
+            </a:extLst>
+          </p:cNvPr>
+          <p:cNvSpPr>
+            <a:spLocks xmlns:a="http://schemas.openxmlformats.org/drawingml/2006/main" noGrp="1"/>
+          </p:cNvSpPr>
+          <p:nvPr/>
+        </p:nvSpPr>
+        <p:spPr>
+          <a:xfrm xmlns:a="http://schemas.openxmlformats.org/drawingml/2006/main">
+            <a:off x="619125" y="314325"/>
+            <a:ext cx="10934700" cy="304800"/>
+          </a:xfrm>
+          <a:prstGeom xmlns:a="http://schemas.openxmlformats.org/drawingml/2006/main" prst="rect">
+            <a:avLst/>
+          </a:prstGeom>
+          <a:noFill xmlns:a="http://schemas.openxmlformats.org/drawingml/2006/main"/>
+          <a:ln xmlns:a="http://schemas.openxmlformats.org/drawingml/2006/main" w="0">
+            <a:noFill/>
+          </a:ln>
+        </p:spPr>
+        <p:txBody>
+          <a:bodyPr xmlns:a="http://schemas.openxmlformats.org/drawingml/2006/main">
+            <a:noAutofit/>
+          </a:bodyPr>
+          <a:lstStyle xmlns:a="http://schemas.openxmlformats.org/drawingml/2006/main"/>
+          <a:p xmlns:a="http://schemas.openxmlformats.org/drawingml/2006/main">
+            <a:pPr>
+              <a:defRPr sz="1575" b="1">
+                <a:solidFill>
+                  <a:srgbClr val="007E54"/>
+                </a:solidFill>
+                <a:latin typeface="Helvetica Neue"/>
+                <a:ea typeface="Helvetica Neue"/>
+                <a:cs typeface="Helvetica Neue"/>
+              </a:defRPr>
+            </a:pPr>
+            <a:r>
+              <a:rPr sz="1575" b="1">
+                <a:solidFill>
+                  <a:srgbClr val="007E54"/>
+                </a:solidFill>
+                <a:latin typeface="Helvetica Neue"/>
+                <a:ea typeface="Helvetica Neue"/>
+                <a:cs typeface="Helvetica Neue"/>
+              </a:rPr>
+              <a:t>TECHNICAL DEMO 35%  /  CREATIVITY 15%</a:t>
+            </a:r>
+          </a:p>
+        </p:txBody>
+      </p:sp>
+      <p:sp>
+        <p:nvSpPr>
+          <p:cNvPr id="2" name="text-1">
+            <a:extLst xmlns:a="http://schemas.openxmlformats.org/drawingml/2006/main">
+              <a:ext uri="{FF2B5EF4-FFF2-40B4-BE49-F238E27FC236}">
+                <a16:creationId xmlns:a16="http://schemas.microsoft.com/office/drawing/2014/main" id="{8623D7F0-4081-455F-9316-335E754CFD12}"/>
+              </a:ext>
+            </a:extLst>
+          </p:cNvPr>
+          <p:cNvSpPr>
+            <a:spLocks xmlns:a="http://schemas.openxmlformats.org/drawingml/2006/main" noGrp="1"/>
+          </p:cNvSpPr>
+          <p:nvPr/>
+        </p:nvSpPr>
+        <p:spPr>
+          <a:xfrm xmlns:a="http://schemas.openxmlformats.org/drawingml/2006/main">
+            <a:off x="609600" y="885825"/>
+            <a:ext cx="10991850" cy="1047750"/>
+          </a:xfrm>
+          <a:prstGeom xmlns:a="http://schemas.openxmlformats.org/drawingml/2006/main" prst="rect">
+            <a:avLst/>
+          </a:prstGeom>
+          <a:noFill xmlns:a="http://schemas.openxmlformats.org/drawingml/2006/main"/>
+          <a:ln xmlns:a="http://schemas.openxmlformats.org/drawingml/2006/main" w="0">
+            <a:noFill/>
+          </a:ln>
+        </p:spPr>
+        <p:txBody>
+          <a:bodyPr xmlns:a="http://schemas.openxmlformats.org/drawingml/2006/main">
+            <a:noAutofit/>
+          </a:bodyPr>
+          <a:lstStyle xmlns:a="http://schemas.openxmlformats.org/drawingml/2006/main"/>
+          <a:p xmlns:a="http://schemas.openxmlformats.org/drawingml/2006/main">
+            <a:pPr>
+              <a:defRPr sz="3525" b="1">
+                <a:solidFill>
+                  <a:srgbClr val="001E2B"/>
+                </a:solidFill>
+                <a:latin typeface="Helvetica Neue"/>
+                <a:ea typeface="Helvetica Neue"/>
+                <a:cs typeface="Helvetica Neue"/>
+              </a:defRPr>
+            </a:pPr>
+            <a:r>
+              <a:rPr sz="3525" b="1">
+                <a:solidFill>
+                  <a:srgbClr val="001E2B"/>
+                </a:solidFill>
+                <a:latin typeface="Helvetica Neue"/>
+                <a:ea typeface="Helvetica Neue"/>
+                <a:cs typeface="Helvetica Neue"/>
+              </a:rPr>
+              <a:t>The downloaded image reopens</a:t>
+            </a:r>
+          </a:p>
+        </p:txBody>
+      </p:sp>
+      <p:sp>
+        <p:nvSpPr>
+          <p:cNvPr id="3" name="text-2">
+            <a:extLst xmlns:a="http://schemas.openxmlformats.org/drawingml/2006/main">
+              <a:ext uri="{FF2B5EF4-FFF2-40B4-BE49-F238E27FC236}">
+                <a16:creationId xmlns:a16="http://schemas.microsoft.com/office/drawing/2014/main" id="{9F2D30CF-BFC9-4D78-8355-27A852C06546}"/>
+              </a:ext>
+            </a:extLst>
+          </p:cNvPr>
+          <p:cNvSpPr>
+            <a:spLocks xmlns:a="http://schemas.openxmlformats.org/drawingml/2006/main" noGrp="1"/>
+          </p:cNvSpPr>
+          <p:nvPr/>
+        </p:nvSpPr>
+        <p:spPr>
+          <a:xfrm xmlns:a="http://schemas.openxmlformats.org/drawingml/2006/main">
+            <a:off x="10972800" y="6372225"/>
+            <a:ext cx="742950" cy="266700"/>
+          </a:xfrm>
+          <a:prstGeom xmlns:a="http://schemas.openxmlformats.org/drawingml/2006/main" prst="rect">
+            <a:avLst/>
+          </a:prstGeom>
+          <a:noFill xmlns:a="http://schemas.openxmlformats.org/drawingml/2006/main"/>
+          <a:ln xmlns:a="http://schemas.openxmlformats.org/drawingml/2006/main" w="0">
+            <a:noFill/>
+          </a:ln>
+        </p:spPr>
+        <p:txBody>
+          <a:bodyPr xmlns:a="http://schemas.openxmlformats.org/drawingml/2006/main">
+            <a:noAutofit/>
+          </a:bodyPr>
+          <a:lstStyle xmlns:a="http://schemas.openxmlformats.org/drawingml/2006/main"/>
+          <a:p xmlns:a="http://schemas.openxmlformats.org/drawingml/2006/main">
+            <a:pPr>
+              <a:defRPr sz="1275">
+                <a:solidFill>
+                  <a:srgbClr val="52666C"/>
+                </a:solidFill>
+                <a:latin typeface="Helvetica Neue"/>
+                <a:ea typeface="Helvetica Neue"/>
+                <a:cs typeface="Helvetica Neue"/>
+              </a:defRPr>
+            </a:pPr>
+            <a:r>
+              <a:rPr sz="1275">
+                <a:solidFill>
+                  <a:srgbClr val="52666C"/>
+                </a:solidFill>
+                <a:latin typeface="Helvetica Neue"/>
+                <a:ea typeface="Helvetica Neue"/>
+                <a:cs typeface="Helvetica Neue"/>
+              </a:rPr>
+              <a:t>5 / 6</a:t>
+            </a:r>
+          </a:p>
+        </p:txBody>
+      </p:sp>
+      <p:sp>
+        <p:nvSpPr>
+          <p:cNvPr id="4" name="text-3">
+            <a:extLst xmlns:a="http://schemas.openxmlformats.org/drawingml/2006/main">
+              <a:ext uri="{FF2B5EF4-FFF2-40B4-BE49-F238E27FC236}">
+                <a16:creationId xmlns:a16="http://schemas.microsoft.com/office/drawing/2014/main" id="{A5693323-4222-4525-A985-1F3700981B7F}"/>
+              </a:ext>
+            </a:extLst>
+          </p:cNvPr>
+          <p:cNvSpPr>
+            <a:spLocks xmlns:a="http://schemas.openxmlformats.org/drawingml/2006/main" noGrp="1"/>
+          </p:cNvSpPr>
+          <p:nvPr/>
+        </p:nvSpPr>
+        <p:spPr>
+          <a:xfrm xmlns:a="http://schemas.openxmlformats.org/drawingml/2006/main">
+            <a:off x="628650" y="2038350"/>
+            <a:ext cx="10648950" cy="485775"/>
+          </a:xfrm>
+          <a:prstGeom xmlns:a="http://schemas.openxmlformats.org/drawingml/2006/main" prst="rect">
+            <a:avLst/>
+          </a:prstGeom>
+          <a:noFill xmlns:a="http://schemas.openxmlformats.org/drawingml/2006/main"/>
+          <a:ln xmlns:a="http://schemas.openxmlformats.org/drawingml/2006/main" w="0">
+            <a:noFill/>
+          </a:ln>
+        </p:spPr>
+        <p:txBody>
+          <a:bodyPr xmlns:a="http://schemas.openxmlformats.org/drawingml/2006/main">
+            <a:noAutofit/>
+          </a:bodyPr>
+          <a:lstStyle xmlns:a="http://schemas.openxmlformats.org/drawingml/2006/main"/>
+          <a:p xmlns:a="http://schemas.openxmlformats.org/drawingml/2006/main">
+            <a:pPr>
+              <a:defRPr sz="2100">
+                <a:solidFill>
+                  <a:srgbClr val="52666C"/>
+                </a:solidFill>
+                <a:latin typeface="Helvetica Neue"/>
+                <a:ea typeface="Helvetica Neue"/>
+                <a:cs typeface="Helvetica Neue"/>
+              </a:defRPr>
+            </a:pPr>
+            <a:r>
+              <a:rPr sz="2100">
+                <a:solidFill>
+                  <a:srgbClr val="52666C"/>
+                </a:solidFill>
+                <a:latin typeface="Helvetica Neue"/>
+                <a:ea typeface="Helvetica Neue"/>
+                <a:cs typeface="Helvetica Neue"/>
+              </a:rPr>
+              <a:t>Actual re-verification output</a:t>
+            </a:r>
+          </a:p>
+        </p:txBody>
+      </p:sp>
+      <p:sp>
+        <p:nvSpPr>
+          <p:cNvPr id="5" name="">
+            <a:extLst xmlns:a="http://schemas.openxmlformats.org/drawingml/2006/main">
+              <a:ext uri="{FF2B5EF4-FFF2-40B4-BE49-F238E27FC236}">
+                <a16:creationId xmlns:a16="http://schemas.microsoft.com/office/drawing/2014/main" id="{1F1352E6-1553-41B2-93AF-6A7803417050}"/>
+              </a:ext>
+            </a:extLst>
+          </p:cNvPr>
+          <p:cNvSpPr>
+            <a:spLocks xmlns:a="http://schemas.openxmlformats.org/drawingml/2006/main" noGrp="1"/>
+          </p:cNvSpPr>
+          <p:nvPr/>
+        </p:nvSpPr>
+        <p:spPr>
+          <a:xfrm xmlns:a="http://schemas.openxmlformats.org/drawingml/2006/main">
+            <a:off x="628650" y="2781300"/>
+            <a:ext cx="10915650" cy="1762125"/>
+          </a:xfrm>
+          <a:prstGeom xmlns:a="http://schemas.openxmlformats.org/drawingml/2006/main" prst="rect">
+            <a:avLst/>
+          </a:prstGeom>
+          <a:solidFill xmlns:a="http://schemas.openxmlformats.org/drawingml/2006/main">
+            <a:srgbClr val="001E2B"/>
+          </a:solidFill>
+          <a:ln xmlns:a="http://schemas.openxmlformats.org/drawingml/2006/main" w="0">
+            <a:noFill/>
+          </a:ln>
+        </p:spPr>
+      </p:sp>
+      <p:sp>
+        <p:nvSpPr>
+          <p:cNvPr id="6" name="text-5">
+            <a:extLst xmlns:a="http://schemas.openxmlformats.org/drawingml/2006/main">
+              <a:ext uri="{FF2B5EF4-FFF2-40B4-BE49-F238E27FC236}">
+                <a16:creationId xmlns:a16="http://schemas.microsoft.com/office/drawing/2014/main" id="{925FCC91-CA11-4BBF-ACF0-49493BA157A5}"/>
+              </a:ext>
+            </a:extLst>
+          </p:cNvPr>
+          <p:cNvSpPr>
+            <a:spLocks xmlns:a="http://schemas.openxmlformats.org/drawingml/2006/main" noGrp="1"/>
+          </p:cNvSpPr>
+          <p:nvPr/>
+        </p:nvSpPr>
+        <p:spPr>
+          <a:xfrm xmlns:a="http://schemas.openxmlformats.org/drawingml/2006/main">
+            <a:off x="866775" y="3067050"/>
+            <a:ext cx="10382250" cy="1343025"/>
+          </a:xfrm>
+          <a:prstGeom xmlns:a="http://schemas.openxmlformats.org/drawingml/2006/main" prst="rect">
+            <a:avLst/>
+          </a:prstGeom>
+          <a:noFill xmlns:a="http://schemas.openxmlformats.org/drawingml/2006/main"/>
+          <a:ln xmlns:a="http://schemas.openxmlformats.org/drawingml/2006/main" w="0">
+            <a:noFill/>
+          </a:ln>
+        </p:spPr>
+        <p:txBody>
+          <a:bodyPr xmlns:a="http://schemas.openxmlformats.org/drawingml/2006/main">
+            <a:noAutofit/>
+          </a:bodyPr>
+          <a:lstStyle xmlns:a="http://schemas.openxmlformats.org/drawingml/2006/main"/>
+          <a:p xmlns:a="http://schemas.openxmlformats.org/drawingml/2006/main">
+            <a:pPr>
+              <a:defRPr sz="2250">
+                <a:solidFill>
+                  <a:srgbClr val="00ED64"/>
+                </a:solidFill>
+                <a:latin typeface="Helvetica Neue"/>
+                <a:ea typeface="Helvetica Neue"/>
+                <a:cs typeface="Helvetica Neue"/>
+              </a:defRPr>
+            </a:pPr>
+            <a:r>
+              <a:rPr sz="2250">
+                <a:solidFill>
+                  <a:srgbClr val="00ED64"/>
+                </a:solidFill>
+                <a:latin typeface="Helvetica Neue"/>
+                <a:ea typeface="Helvetica Neue"/>
+                <a:cs typeface="Helvetica Neue"/>
+              </a:rPr>
+              <a:t>IMAGE REOPENED   runs=32  files=491  gitBundles=6</a:t>
+            </a:r>
+          </a:p>
+          <a:p xmlns:a="http://schemas.openxmlformats.org/drawingml/2006/main">
+            <a:pPr>
+              <a:defRPr sz="2250">
+                <a:solidFill>
+                  <a:srgbClr val="00ED64"/>
+                </a:solidFill>
+                <a:latin typeface="Helvetica Neue"/>
+                <a:ea typeface="Helvetica Neue"/>
+                <a:cs typeface="Helvetica Neue"/>
+              </a:defRPr>
+            </a:pPr>
+            <a:r>
+              <a:rPr sz="2250">
+                <a:solidFill>
+                  <a:srgbClr val="00ED64"/>
+                </a:solidFill>
+                <a:latin typeface="Helvetica Neue"/>
+                <a:ea typeface="Helvetica Neue"/>
+                <a:cs typeface="Helvetica Neue"/>
+              </a:rPr>
+              <a:t>PAYLOADS VERIFIED   491 file hashes + 6 Git bundles</a:t>
+            </a:r>
+          </a:p>
+          <a:p xmlns:a="http://schemas.openxmlformats.org/drawingml/2006/main">
+            <a:pPr>
+              <a:defRPr sz="2250">
+                <a:solidFill>
+                  <a:srgbClr val="00ED64"/>
+                </a:solidFill>
+                <a:latin typeface="Helvetica Neue"/>
+                <a:ea typeface="Helvetica Neue"/>
+                <a:cs typeface="Helvetica Neue"/>
+              </a:defRPr>
+            </a:pPr>
+            <a:r>
+              <a:rPr sz="2250">
+                <a:solidFill>
+                  <a:srgbClr val="00ED64"/>
+                </a:solidFill>
+                <a:latin typeface="Helvetica Neue"/>
+                <a:ea typeface="Helvetica Neue"/>
+                <a:cs typeface="Helvetica Neue"/>
+              </a:rPr>
+              <a:t>RESULT   PASS</a:t>
+            </a:r>
+          </a:p>
+        </p:txBody>
+      </p:sp>
+      <p:sp>
+        <p:nvSpPr>
+          <p:cNvPr id="7" name="text-6">
+            <a:extLst xmlns:a="http://schemas.openxmlformats.org/drawingml/2006/main">
+              <a:ext uri="{FF2B5EF4-FFF2-40B4-BE49-F238E27FC236}">
+                <a16:creationId xmlns:a16="http://schemas.microsoft.com/office/drawing/2014/main" id="{A29B2D3D-010C-4EA2-B19D-FD3382776EB9}"/>
+              </a:ext>
+            </a:extLst>
+          </p:cNvPr>
+          <p:cNvSpPr>
+            <a:spLocks xmlns:a="http://schemas.openxmlformats.org/drawingml/2006/main" noGrp="1"/>
+          </p:cNvSpPr>
+          <p:nvPr/>
+        </p:nvSpPr>
+        <p:spPr>
+          <a:xfrm xmlns:a="http://schemas.openxmlformats.org/drawingml/2006/main">
+            <a:off x="628650" y="4962525"/>
+            <a:ext cx="10925175" cy="523875"/>
+          </a:xfrm>
+          <a:prstGeom xmlns:a="http://schemas.openxmlformats.org/drawingml/2006/main" prst="rect">
+            <a:avLst/>
+          </a:prstGeom>
+          <a:noFill xmlns:a="http://schemas.openxmlformats.org/drawingml/2006/main"/>
+          <a:ln xmlns:a="http://schemas.openxmlformats.org/drawingml/2006/main" w="0">
+            <a:noFill/>
+          </a:ln>
+        </p:spPr>
+        <p:txBody>
+          <a:bodyPr xmlns:a="http://schemas.openxmlformats.org/drawingml/2006/main">
+            <a:noAutofit/>
+          </a:bodyPr>
+          <a:lstStyle xmlns:a="http://schemas.openxmlformats.org/drawingml/2006/main"/>
+          <a:p xmlns:a="http://schemas.openxmlformats.org/drawingml/2006/main">
+            <a:pPr>
+              <a:defRPr sz="2475" b="1">
+                <a:solidFill>
+                  <a:srgbClr val="001E2B"/>
+                </a:solidFill>
+                <a:latin typeface="Helvetica Neue"/>
+                <a:ea typeface="Helvetica Neue"/>
+                <a:cs typeface="Helvetica Neue"/>
+              </a:defRPr>
+            </a:pPr>
+            <a:r>
+              <a:rPr sz="2475" b="1">
+                <a:solidFill>
+                  <a:srgbClr val="001E2B"/>
+                </a:solidFill>
+                <a:latin typeface="Helvetica Neue"/>
+                <a:ea typeface="Helvetica Neue"/>
+                <a:cs typeface="Helvetica Neue"/>
+              </a:rPr>
+              <a:t>4 / 4 companion hashes match the Atlas manifest</a:t>
+            </a:r>
+          </a:p>
+        </p:txBody>
+      </p:sp>
+      <p:sp>
+        <p:nvSpPr>
+          <p:cNvPr id="8" name="text-7">
+            <a:extLst xmlns:a="http://schemas.openxmlformats.org/drawingml/2006/main">
+              <a:ext uri="{FF2B5EF4-FFF2-40B4-BE49-F238E27FC236}">
+                <a16:creationId xmlns:a16="http://schemas.microsoft.com/office/drawing/2014/main" id="{57A584BD-6ABB-4C1C-8D2F-DE3A61C42167}"/>
+              </a:ext>
+            </a:extLst>
+          </p:cNvPr>
+          <p:cNvSpPr>
+            <a:spLocks xmlns:a="http://schemas.openxmlformats.org/drawingml/2006/main" noGrp="1"/>
+          </p:cNvSpPr>
+          <p:nvPr/>
+        </p:nvSpPr>
+        <p:spPr>
+          <a:xfrm xmlns:a="http://schemas.openxmlformats.org/drawingml/2006/main">
+            <a:off x="628650" y="5734050"/>
+            <a:ext cx="10839450" cy="619125"/>
+          </a:xfrm>
+          <a:prstGeom xmlns:a="http://schemas.openxmlformats.org/drawingml/2006/main" prst="rect">
+            <a:avLst/>
+          </a:prstGeom>
+          <a:noFill xmlns:a="http://schemas.openxmlformats.org/drawingml/2006/main"/>
+          <a:ln xmlns:a="http://schemas.openxmlformats.org/drawingml/2006/main" w="0">
+            <a:noFill/>
+          </a:ln>
+        </p:spPr>
+        <p:txBody>
+          <a:bodyPr xmlns:a="http://schemas.openxmlformats.org/drawingml/2006/main">
+            <a:noAutofit/>
+          </a:bodyPr>
+          <a:lstStyle xmlns:a="http://schemas.openxmlformats.org/drawingml/2006/main"/>
+          <a:p xmlns:a="http://schemas.openxmlformats.org/drawingml/2006/main">
+            <a:pPr>
+              <a:defRPr sz="1725">
+                <a:solidFill>
+                  <a:srgbClr val="52666C"/>
+                </a:solidFill>
+                <a:latin typeface="Helvetica Neue"/>
+                <a:ea typeface="Helvetica Neue"/>
+                <a:cs typeface="Helvetica Neue"/>
+              </a:defRPr>
+            </a:pPr>
+            <a:r>
+              <a:rPr sz="1725">
+                <a:solidFill>
+                  <a:srgbClr val="52666C"/>
+                </a:solidFill>
+                <a:latin typeface="Helvetica Neue"/>
+                <a:ea typeface="Helvetica Neue"/>
+                <a:cs typeface="Helvetica Neue"/>
+              </a:rPr>
+              <a:t>Prior Atlas snapshot, rechecked locally. New Qwen image: 4 runs, 76 files, 1 bundle.</a:t>
+            </a:r>
+          </a:p>
+          <a:p xmlns:a="http://schemas.openxmlformats.org/drawingml/2006/main">
+            <a:pPr>
+              <a:defRPr sz="1725">
+                <a:solidFill>
+                  <a:srgbClr val="52666C"/>
+                </a:solidFill>
+                <a:latin typeface="Helvetica Neue"/>
+                <a:ea typeface="Helvetica Neue"/>
+                <a:cs typeface="Helvetica Neue"/>
+              </a:defRPr>
+            </a:pPr>
+            <a:r>
+              <a:rPr sz="1725">
+                <a:solidFill>
+                  <a:srgbClr val="52666C"/>
+                </a:solidFill>
+                <a:latin typeface="Helvetica Neue"/>
+                <a:ea typeface="Helvetica Neue"/>
+                <a:cs typeface="Helvetica Neue"/>
+              </a:rPr>
+              <a:t>The new image is local; its Atlas upload remains blocked.</a:t>
+            </a:r>
+          </a:p>
+        </p:txBody>
+      </p:sp>
+    </p:spTree>
+    <p:extLst>
+      <p:ext uri="{BB962C8B-B14F-4D97-AF65-F5344CB8AC3E}">
+        <p14:creationId xmlns:p14="http://schemas.microsoft.com/office/powerpoint/2010/main" val="422008089"/>
+      </p:ext>
+    </p:extLst>
+  </p:cSld>
+</p:sld>
+</file>
+
+<file path=ppt/slides/slide6.xml><?xml version="1.0" encoding="utf-8"?>
 <p:sld xmlns:p="http://schemas.openxmlformats.org/presentationml/2006/main">
   <p:cSld>
     <p:bg>
@@ -4250,10 +5384,10 @@
       </p:grpSpPr>
       <p:sp>
         <p:nvSpPr>
-          <p:cNvPr id="6" name="text-0">
+          <p:cNvPr id="12" name="text-0">
             <a:extLst xmlns:a="http://schemas.openxmlformats.org/drawingml/2006/main">
               <a:ext uri="{FF2B5EF4-FFF2-40B4-BE49-F238E27FC236}">
-                <a16:creationId xmlns:a16="http://schemas.microsoft.com/office/drawing/2014/main" id="{94C3DE8A-744F-4CB7-BC8D-F40DAFB4DAC1}"/>
+                <a16:creationId xmlns:a16="http://schemas.microsoft.com/office/drawing/2014/main" id="{A1A00779-D6DE-43B8-9BC6-4457B95DC132}"/>
               </a:ext>
             </a:extLst>
           </p:cNvPr>
@@ -4264,8 +5398,8 @@
         </p:nvSpPr>
         <p:spPr>
           <a:xfrm xmlns:a="http://schemas.openxmlformats.org/drawingml/2006/main">
-            <a:off x="609600" y="457200"/>
-            <a:ext cx="10972800" cy="1000125"/>
+            <a:off x="619125" y="314325"/>
+            <a:ext cx="10934700" cy="304800"/>
           </a:xfrm>
           <a:prstGeom xmlns:a="http://schemas.openxmlformats.org/drawingml/2006/main" prst="rect">
             <a:avLst/>
@@ -4282,9 +5416,9 @@
           <a:lstStyle xmlns:a="http://schemas.openxmlformats.org/drawingml/2006/main"/>
           <a:p xmlns:a="http://schemas.openxmlformats.org/drawingml/2006/main">
             <a:pPr>
-              <a:defRPr sz="3450" b="1">
-                <a:solidFill>
-                  <a:srgbClr val="FFFFFF"/>
+              <a:defRPr sz="1575" b="1">
+                <a:solidFill>
+                  <a:srgbClr val="00ED64"/>
                 </a:solidFill>
                 <a:latin typeface="Helvetica Neue"/>
                 <a:ea typeface="Helvetica Neue"/>
@@ -4292,15 +5426,15 @@
               </a:defRPr>
             </a:pPr>
             <a:r>
-              <a:rPr sz="3450" b="1">
-                <a:solidFill>
-                  <a:srgbClr val="FFFFFF"/>
+              <a:rPr sz="1575" b="1">
+                <a:solidFill>
+                  <a:srgbClr val="00ED64"/>
                 </a:solidFill>
                 <a:latin typeface="Helvetica Neue"/>
                 <a:ea typeface="Helvetica Neue"/>
                 <a:cs typeface="Helvetica Neue"/>
               </a:rPr>
-              <a:t>Bring one failing agent run</a:t>
+              <a:t>IMPACT POTENTIAL 20%</a:t>
             </a:r>
           </a:p>
         </p:txBody>
@@ -4310,7 +5444,7 @@
           <p:cNvPr id="2" name="text-1">
             <a:extLst xmlns:a="http://schemas.openxmlformats.org/drawingml/2006/main">
               <a:ext uri="{FF2B5EF4-FFF2-40B4-BE49-F238E27FC236}">
-                <a16:creationId xmlns:a16="http://schemas.microsoft.com/office/drawing/2014/main" id="{6BC9F099-4E06-445C-8462-4D3CBF7C7C01}"/>
+                <a16:creationId xmlns:a16="http://schemas.microsoft.com/office/drawing/2014/main" id="{863FD5BA-4706-44DA-A72C-51FA41B19BF0}"/>
               </a:ext>
             </a:extLst>
           </p:cNvPr>
@@ -4321,8 +5455,8 @@
         </p:nvSpPr>
         <p:spPr>
           <a:xfrm xmlns:a="http://schemas.openxmlformats.org/drawingml/2006/main">
-            <a:off x="10953750" y="6362700"/>
-            <a:ext cx="762000" cy="266700"/>
+            <a:off x="609600" y="885825"/>
+            <a:ext cx="10991850" cy="1047750"/>
           </a:xfrm>
           <a:prstGeom xmlns:a="http://schemas.openxmlformats.org/drawingml/2006/main" prst="rect">
             <a:avLst/>
@@ -4339,9 +5473,9 @@
           <a:lstStyle xmlns:a="http://schemas.openxmlformats.org/drawingml/2006/main"/>
           <a:p xmlns:a="http://schemas.openxmlformats.org/drawingml/2006/main">
             <a:pPr>
-              <a:defRPr sz="1275">
-                <a:solidFill>
-                  <a:srgbClr val="94AFA7"/>
+              <a:defRPr sz="3525" b="1">
+                <a:solidFill>
+                  <a:srgbClr val="FFFFFF"/>
                 </a:solidFill>
                 <a:latin typeface="Helvetica Neue"/>
                 <a:ea typeface="Helvetica Neue"/>
@@ -4349,15 +5483,15 @@
               </a:defRPr>
             </a:pPr>
             <a:r>
-              <a:rPr sz="1275">
-                <a:solidFill>
-                  <a:srgbClr val="94AFA7"/>
+              <a:rPr sz="3525" b="1">
+                <a:solidFill>
+                  <a:srgbClr val="FFFFFF"/>
                 </a:solidFill>
                 <a:latin typeface="Helvetica Neue"/>
                 <a:ea typeface="Helvetica Neue"/>
                 <a:cs typeface="Helvetica Neue"/>
               </a:rPr>
-              <a:t>5 / 5</a:t>
+              <a:t>Debug the run, not just the log</a:t>
             </a:r>
           </a:p>
         </p:txBody>
@@ -4367,7 +5501,7 @@
           <p:cNvPr id="3" name="text-2">
             <a:extLst xmlns:a="http://schemas.openxmlformats.org/drawingml/2006/main">
               <a:ext uri="{FF2B5EF4-FFF2-40B4-BE49-F238E27FC236}">
-                <a16:creationId xmlns:a16="http://schemas.microsoft.com/office/drawing/2014/main" id="{E5A68932-9048-4B8E-8736-AC9DE05E52D0}"/>
+                <a16:creationId xmlns:a16="http://schemas.microsoft.com/office/drawing/2014/main" id="{13B06572-3415-4E73-B418-4A6DD72B6596}"/>
               </a:ext>
             </a:extLst>
           </p:cNvPr>
@@ -4378,8 +5512,8 @@
         </p:nvSpPr>
         <p:spPr>
           <a:xfrm xmlns:a="http://schemas.openxmlformats.org/drawingml/2006/main">
-            <a:off x="628650" y="2247900"/>
-            <a:ext cx="10934700" cy="1543050"/>
+            <a:off x="10972800" y="6372225"/>
+            <a:ext cx="742950" cy="266700"/>
           </a:xfrm>
           <a:prstGeom xmlns:a="http://schemas.openxmlformats.org/drawingml/2006/main" prst="rect">
             <a:avLst/>
@@ -4396,9 +5530,9 @@
           <a:lstStyle xmlns:a="http://schemas.openxmlformats.org/drawingml/2006/main"/>
           <a:p xmlns:a="http://schemas.openxmlformats.org/drawingml/2006/main">
             <a:pPr>
-              <a:defRPr sz="4350" b="1">
-                <a:solidFill>
-                  <a:srgbClr val="FFFFFF"/>
+              <a:defRPr sz="1275">
+                <a:solidFill>
+                  <a:srgbClr val="94AFA7"/>
                 </a:solidFill>
                 <a:latin typeface="Helvetica Neue"/>
                 <a:ea typeface="Helvetica Neue"/>
@@ -4406,38 +5540,15 @@
               </a:defRPr>
             </a:pPr>
             <a:r>
-              <a:rPr sz="4350" b="1">
-                <a:solidFill>
-                  <a:srgbClr val="FFFFFF"/>
+              <a:rPr sz="1275">
+                <a:solidFill>
+                  <a:srgbClr val="94AFA7"/>
                 </a:solidFill>
                 <a:latin typeface="Helvetica Neue"/>
                 <a:ea typeface="Helvetica Neue"/>
                 <a:cs typeface="Helvetica Neue"/>
               </a:rPr>
-              <a:t>Recover it. Inspect it.</a:t>
-            </a:r>
-          </a:p>
-          <a:p xmlns:a="http://schemas.openxmlformats.org/drawingml/2006/main">
-            <a:pPr>
-              <a:defRPr sz="4350" b="1">
-                <a:solidFill>
-                  <a:srgbClr val="FFFFFF"/>
-                </a:solidFill>
-                <a:latin typeface="Helvetica Neue"/>
-                <a:ea typeface="Helvetica Neue"/>
-                <a:cs typeface="Helvetica Neue"/>
-              </a:defRPr>
-            </a:pPr>
-            <a:r>
-              <a:rPr sz="4350" b="1">
-                <a:solidFill>
-                  <a:srgbClr val="FFFFFF"/>
-                </a:solidFill>
-                <a:latin typeface="Helvetica Neue"/>
-                <a:ea typeface="Helvetica Neue"/>
-                <a:cs typeface="Helvetica Neue"/>
-              </a:rPr>
-              <a:t>Try a live alternative.</a:t>
+              <a:t>6 / 6</a:t>
             </a:r>
           </a:p>
         </p:txBody>
@@ -4447,7 +5558,7 @@
           <p:cNvPr id="4" name="text-3">
             <a:extLst xmlns:a="http://schemas.openxmlformats.org/drawingml/2006/main">
               <a:ext uri="{FF2B5EF4-FFF2-40B4-BE49-F238E27FC236}">
-                <a16:creationId xmlns:a16="http://schemas.microsoft.com/office/drawing/2014/main" id="{4D0FFFB4-311F-4344-83DB-B3D1D81C1631}"/>
+                <a16:creationId xmlns:a16="http://schemas.microsoft.com/office/drawing/2014/main" id="{3BC1311D-7891-4D87-B216-1210631252C2}"/>
               </a:ext>
             </a:extLst>
           </p:cNvPr>
@@ -4458,8 +5569,8 @@
         </p:nvSpPr>
         <p:spPr>
           <a:xfrm xmlns:a="http://schemas.openxmlformats.org/drawingml/2006/main">
-            <a:off x="638175" y="4581525"/>
-            <a:ext cx="10810875" cy="619125"/>
+            <a:off x="638175" y="2390775"/>
+            <a:ext cx="4238625" cy="581025"/>
           </a:xfrm>
           <a:prstGeom xmlns:a="http://schemas.openxmlformats.org/drawingml/2006/main" prst="rect">
             <a:avLst/>
@@ -4476,7 +5587,7 @@
           <a:lstStyle xmlns:a="http://schemas.openxmlformats.org/drawingml/2006/main"/>
           <a:p xmlns:a="http://schemas.openxmlformats.org/drawingml/2006/main">
             <a:pPr>
-              <a:defRPr sz="3075" b="1">
+              <a:defRPr sz="2625" b="1">
                 <a:solidFill>
                   <a:srgbClr val="00ED64"/>
                 </a:solidFill>
@@ -4486,7 +5597,7 @@
               </a:defRPr>
             </a:pPr>
             <a:r>
-              <a:rPr sz="3075" b="1">
+              <a:rPr sz="2625" b="1">
                 <a:solidFill>
                   <a:srgbClr val="00ED64"/>
                 </a:solidFill>
@@ -4494,7 +5605,7 @@
                 <a:ea typeface="Helvetica Neue"/>
                 <a:cs typeface="Helvetica Neue"/>
               </a:rPr>
-              <a:t>TapeDeck</a:t>
+              <a:t>Agent developers</a:t>
             </a:r>
           </a:p>
         </p:txBody>
@@ -4504,7 +5615,7 @@
           <p:cNvPr id="5" name="text-4">
             <a:extLst xmlns:a="http://schemas.openxmlformats.org/drawingml/2006/main">
               <a:ext uri="{FF2B5EF4-FFF2-40B4-BE49-F238E27FC236}">
-                <a16:creationId xmlns:a16="http://schemas.microsoft.com/office/drawing/2014/main" id="{11C2EF3F-F267-40A4-BC06-F3F5FE44C3F8}"/>
+                <a16:creationId xmlns:a16="http://schemas.microsoft.com/office/drawing/2014/main" id="{033AB3E2-7945-41BD-9597-6148DE95C95D}"/>
               </a:ext>
             </a:extLst>
           </p:cNvPr>
@@ -4515,8 +5626,8 @@
         </p:nvSpPr>
         <p:spPr>
           <a:xfrm xmlns:a="http://schemas.openxmlformats.org/drawingml/2006/main">
-            <a:off x="638175" y="5495925"/>
-            <a:ext cx="10801350" cy="523875"/>
+            <a:off x="5133975" y="2390775"/>
+            <a:ext cx="6296025" cy="809625"/>
           </a:xfrm>
           <a:prstGeom xmlns:a="http://schemas.openxmlformats.org/drawingml/2006/main" prst="rect">
             <a:avLst/>
@@ -4551,6 +5662,348 @@
                 <a:ea typeface="Helvetica Neue"/>
                 <a:cs typeface="Helvetica Neue"/>
               </a:rPr>
+              <a:t>Recover a failure with its files and checkpoints</a:t>
+            </a:r>
+          </a:p>
+        </p:txBody>
+      </p:sp>
+      <p:sp>
+        <p:nvSpPr>
+          <p:cNvPr id="6" name="text-5">
+            <a:extLst xmlns:a="http://schemas.openxmlformats.org/drawingml/2006/main">
+              <a:ext uri="{FF2B5EF4-FFF2-40B4-BE49-F238E27FC236}">
+                <a16:creationId xmlns:a16="http://schemas.microsoft.com/office/drawing/2014/main" id="{8C82E30F-B833-497A-9939-7880AD36808D}"/>
+              </a:ext>
+            </a:extLst>
+          </p:cNvPr>
+          <p:cNvSpPr>
+            <a:spLocks xmlns:a="http://schemas.openxmlformats.org/drawingml/2006/main" noGrp="1"/>
+          </p:cNvSpPr>
+          <p:nvPr/>
+        </p:nvSpPr>
+        <p:spPr>
+          <a:xfrm xmlns:a="http://schemas.openxmlformats.org/drawingml/2006/main">
+            <a:off x="638175" y="3419475"/>
+            <a:ext cx="4238625" cy="581025"/>
+          </a:xfrm>
+          <a:prstGeom xmlns:a="http://schemas.openxmlformats.org/drawingml/2006/main" prst="rect">
+            <a:avLst/>
+          </a:prstGeom>
+          <a:noFill xmlns:a="http://schemas.openxmlformats.org/drawingml/2006/main"/>
+          <a:ln xmlns:a="http://schemas.openxmlformats.org/drawingml/2006/main" w="0">
+            <a:noFill/>
+          </a:ln>
+        </p:spPr>
+        <p:txBody>
+          <a:bodyPr xmlns:a="http://schemas.openxmlformats.org/drawingml/2006/main">
+            <a:noAutofit/>
+          </a:bodyPr>
+          <a:lstStyle xmlns:a="http://schemas.openxmlformats.org/drawingml/2006/main"/>
+          <a:p xmlns:a="http://schemas.openxmlformats.org/drawingml/2006/main">
+            <a:pPr>
+              <a:defRPr sz="2625" b="1">
+                <a:solidFill>
+                  <a:srgbClr val="00ED64"/>
+                </a:solidFill>
+                <a:latin typeface="Helvetica Neue"/>
+                <a:ea typeface="Helvetica Neue"/>
+                <a:cs typeface="Helvetica Neue"/>
+              </a:defRPr>
+            </a:pPr>
+            <a:r>
+              <a:rPr sz="2625" b="1">
+                <a:solidFill>
+                  <a:srgbClr val="00ED64"/>
+                </a:solidFill>
+                <a:latin typeface="Helvetica Neue"/>
+                <a:ea typeface="Helvetica Neue"/>
+                <a:cs typeface="Helvetica Neue"/>
+              </a:rPr>
+              <a:t>Evaluation teams</a:t>
+            </a:r>
+          </a:p>
+        </p:txBody>
+      </p:sp>
+      <p:sp>
+        <p:nvSpPr>
+          <p:cNvPr id="7" name="text-6">
+            <a:extLst xmlns:a="http://schemas.openxmlformats.org/drawingml/2006/main">
+              <a:ext uri="{FF2B5EF4-FFF2-40B4-BE49-F238E27FC236}">
+                <a16:creationId xmlns:a16="http://schemas.microsoft.com/office/drawing/2014/main" id="{09C4CD8C-0A0D-4EFF-B93F-DA2333CA03C9}"/>
+              </a:ext>
+            </a:extLst>
+          </p:cNvPr>
+          <p:cNvSpPr>
+            <a:spLocks xmlns:a="http://schemas.openxmlformats.org/drawingml/2006/main" noGrp="1"/>
+          </p:cNvSpPr>
+          <p:nvPr/>
+        </p:nvSpPr>
+        <p:spPr>
+          <a:xfrm xmlns:a="http://schemas.openxmlformats.org/drawingml/2006/main">
+            <a:off x="5133975" y="3419475"/>
+            <a:ext cx="6296025" cy="809625"/>
+          </a:xfrm>
+          <a:prstGeom xmlns:a="http://schemas.openxmlformats.org/drawingml/2006/main" prst="rect">
+            <a:avLst/>
+          </a:prstGeom>
+          <a:noFill xmlns:a="http://schemas.openxmlformats.org/drawingml/2006/main"/>
+          <a:ln xmlns:a="http://schemas.openxmlformats.org/drawingml/2006/main" w="0">
+            <a:noFill/>
+          </a:ln>
+        </p:spPr>
+        <p:txBody>
+          <a:bodyPr xmlns:a="http://schemas.openxmlformats.org/drawingml/2006/main">
+            <a:noAutofit/>
+          </a:bodyPr>
+          <a:lstStyle xmlns:a="http://schemas.openxmlformats.org/drawingml/2006/main"/>
+          <a:p xmlns:a="http://schemas.openxmlformats.org/drawingml/2006/main">
+            <a:pPr>
+              <a:defRPr sz="2250">
+                <a:solidFill>
+                  <a:srgbClr val="FFFFFF"/>
+                </a:solidFill>
+                <a:latin typeface="Helvetica Neue"/>
+                <a:ea typeface="Helvetica Neue"/>
+                <a:cs typeface="Helvetica Neue"/>
+              </a:defRPr>
+            </a:pPr>
+            <a:r>
+              <a:rPr sz="2250">
+                <a:solidFill>
+                  <a:srgbClr val="FFFFFF"/>
+                </a:solidFill>
+                <a:latin typeface="Helvetica Neue"/>
+                <a:ea typeface="Helvetica Neue"/>
+                <a:cs typeface="Helvetica Neue"/>
+              </a:rPr>
+              <a:t>Compare a deliberate live alternative</a:t>
+            </a:r>
+          </a:p>
+        </p:txBody>
+      </p:sp>
+      <p:sp>
+        <p:nvSpPr>
+          <p:cNvPr id="8" name="text-7">
+            <a:extLst xmlns:a="http://schemas.openxmlformats.org/drawingml/2006/main">
+              <a:ext uri="{FF2B5EF4-FFF2-40B4-BE49-F238E27FC236}">
+                <a16:creationId xmlns:a16="http://schemas.microsoft.com/office/drawing/2014/main" id="{F104A42E-90DB-4254-B682-ABD1F220684D}"/>
+              </a:ext>
+            </a:extLst>
+          </p:cNvPr>
+          <p:cNvSpPr>
+            <a:spLocks xmlns:a="http://schemas.openxmlformats.org/drawingml/2006/main" noGrp="1"/>
+          </p:cNvSpPr>
+          <p:nvPr/>
+        </p:nvSpPr>
+        <p:spPr>
+          <a:xfrm xmlns:a="http://schemas.openxmlformats.org/drawingml/2006/main">
+            <a:off x="638175" y="4448175"/>
+            <a:ext cx="4238625" cy="581025"/>
+          </a:xfrm>
+          <a:prstGeom xmlns:a="http://schemas.openxmlformats.org/drawingml/2006/main" prst="rect">
+            <a:avLst/>
+          </a:prstGeom>
+          <a:noFill xmlns:a="http://schemas.openxmlformats.org/drawingml/2006/main"/>
+          <a:ln xmlns:a="http://schemas.openxmlformats.org/drawingml/2006/main" w="0">
+            <a:noFill/>
+          </a:ln>
+        </p:spPr>
+        <p:txBody>
+          <a:bodyPr xmlns:a="http://schemas.openxmlformats.org/drawingml/2006/main">
+            <a:noAutofit/>
+          </a:bodyPr>
+          <a:lstStyle xmlns:a="http://schemas.openxmlformats.org/drawingml/2006/main"/>
+          <a:p xmlns:a="http://schemas.openxmlformats.org/drawingml/2006/main">
+            <a:pPr>
+              <a:defRPr sz="2625" b="1">
+                <a:solidFill>
+                  <a:srgbClr val="00ED64"/>
+                </a:solidFill>
+                <a:latin typeface="Helvetica Neue"/>
+                <a:ea typeface="Helvetica Neue"/>
+                <a:cs typeface="Helvetica Neue"/>
+              </a:defRPr>
+            </a:pPr>
+            <a:r>
+              <a:rPr sz="2625" b="1">
+                <a:solidFill>
+                  <a:srgbClr val="00ED64"/>
+                </a:solidFill>
+                <a:latin typeface="Helvetica Neue"/>
+                <a:ea typeface="Helvetica Neue"/>
+                <a:cs typeface="Helvetica Neue"/>
+              </a:rPr>
+              <a:t>Teammates</a:t>
+            </a:r>
+          </a:p>
+        </p:txBody>
+      </p:sp>
+      <p:sp>
+        <p:nvSpPr>
+          <p:cNvPr id="9" name="text-8">
+            <a:extLst xmlns:a="http://schemas.openxmlformats.org/drawingml/2006/main">
+              <a:ext uri="{FF2B5EF4-FFF2-40B4-BE49-F238E27FC236}">
+                <a16:creationId xmlns:a16="http://schemas.microsoft.com/office/drawing/2014/main" id="{F0D95EF3-D459-4E4C-8B17-DB90249F1DE2}"/>
+              </a:ext>
+            </a:extLst>
+          </p:cNvPr>
+          <p:cNvSpPr>
+            <a:spLocks xmlns:a="http://schemas.openxmlformats.org/drawingml/2006/main" noGrp="1"/>
+          </p:cNvSpPr>
+          <p:nvPr/>
+        </p:nvSpPr>
+        <p:spPr>
+          <a:xfrm xmlns:a="http://schemas.openxmlformats.org/drawingml/2006/main">
+            <a:off x="5133975" y="4448175"/>
+            <a:ext cx="6296025" cy="857250"/>
+          </a:xfrm>
+          <a:prstGeom xmlns:a="http://schemas.openxmlformats.org/drawingml/2006/main" prst="rect">
+            <a:avLst/>
+          </a:prstGeom>
+          <a:noFill xmlns:a="http://schemas.openxmlformats.org/drawingml/2006/main"/>
+          <a:ln xmlns:a="http://schemas.openxmlformats.org/drawingml/2006/main" w="0">
+            <a:noFill/>
+          </a:ln>
+        </p:spPr>
+        <p:txBody>
+          <a:bodyPr xmlns:a="http://schemas.openxmlformats.org/drawingml/2006/main">
+            <a:noAutofit/>
+          </a:bodyPr>
+          <a:lstStyle xmlns:a="http://schemas.openxmlformats.org/drawingml/2006/main"/>
+          <a:p xmlns:a="http://schemas.openxmlformats.org/drawingml/2006/main">
+            <a:pPr>
+              <a:defRPr sz="2250">
+                <a:solidFill>
+                  <a:srgbClr val="FFFFFF"/>
+                </a:solidFill>
+                <a:latin typeface="Helvetica Neue"/>
+                <a:ea typeface="Helvetica Neue"/>
+                <a:cs typeface="Helvetica Neue"/>
+              </a:defRPr>
+            </a:pPr>
+            <a:r>
+              <a:rPr sz="2250">
+                <a:solidFill>
+                  <a:srgbClr val="FFFFFF"/>
+                </a:solidFill>
+                <a:latin typeface="Helvetica Neue"/>
+                <a:ea typeface="Helvetica Neue"/>
+                <a:cs typeface="Helvetica Neue"/>
+              </a:rPr>
+              <a:t>Reopen the experiment without new replay inference</a:t>
+            </a:r>
+          </a:p>
+        </p:txBody>
+      </p:sp>
+      <p:sp>
+        <p:nvSpPr>
+          <p:cNvPr id="10" name="text-9">
+            <a:extLst xmlns:a="http://schemas.openxmlformats.org/drawingml/2006/main">
+              <a:ext uri="{FF2B5EF4-FFF2-40B4-BE49-F238E27FC236}">
+                <a16:creationId xmlns:a16="http://schemas.microsoft.com/office/drawing/2014/main" id="{E333071A-006A-4CAF-B1F7-33992B4C55FD}"/>
+              </a:ext>
+            </a:extLst>
+          </p:cNvPr>
+          <p:cNvSpPr>
+            <a:spLocks xmlns:a="http://schemas.openxmlformats.org/drawingml/2006/main" noGrp="1"/>
+          </p:cNvSpPr>
+          <p:nvPr/>
+        </p:nvSpPr>
+        <p:spPr>
+          <a:xfrm xmlns:a="http://schemas.openxmlformats.org/drawingml/2006/main">
+            <a:off x="638175" y="5762625"/>
+            <a:ext cx="6096000" cy="504825"/>
+          </a:xfrm>
+          <a:prstGeom xmlns:a="http://schemas.openxmlformats.org/drawingml/2006/main" prst="rect">
+            <a:avLst/>
+          </a:prstGeom>
+          <a:noFill xmlns:a="http://schemas.openxmlformats.org/drawingml/2006/main"/>
+          <a:ln xmlns:a="http://schemas.openxmlformats.org/drawingml/2006/main" w="0">
+            <a:noFill/>
+          </a:ln>
+        </p:spPr>
+        <p:txBody>
+          <a:bodyPr xmlns:a="http://schemas.openxmlformats.org/drawingml/2006/main">
+            <a:noAutofit/>
+          </a:bodyPr>
+          <a:lstStyle xmlns:a="http://schemas.openxmlformats.org/drawingml/2006/main"/>
+          <a:p xmlns:a="http://schemas.openxmlformats.org/drawingml/2006/main">
+            <a:pPr>
+              <a:defRPr sz="2775" b="1">
+                <a:solidFill>
+                  <a:srgbClr val="FFFFFF"/>
+                </a:solidFill>
+                <a:latin typeface="Helvetica Neue"/>
+                <a:ea typeface="Helvetica Neue"/>
+                <a:cs typeface="Helvetica Neue"/>
+              </a:defRPr>
+            </a:pPr>
+            <a:r>
+              <a:rPr sz="2775" b="1">
+                <a:solidFill>
+                  <a:srgbClr val="FFFFFF"/>
+                </a:solidFill>
+                <a:latin typeface="Helvetica Neue"/>
+                <a:ea typeface="Helvetica Neue"/>
+                <a:cs typeface="Helvetica Neue"/>
+              </a:rPr>
+              <a:t>Bring one failing run.</a:t>
+            </a:r>
+          </a:p>
+        </p:txBody>
+      </p:sp>
+      <p:sp>
+        <p:nvSpPr>
+          <p:cNvPr id="11" name="text-10">
+            <a:extLst xmlns:a="http://schemas.openxmlformats.org/drawingml/2006/main">
+              <a:ext uri="{FF2B5EF4-FFF2-40B4-BE49-F238E27FC236}">
+                <a16:creationId xmlns:a16="http://schemas.microsoft.com/office/drawing/2014/main" id="{3E6AE9E4-548D-4C8F-9D1C-A26D46E8136C}"/>
+              </a:ext>
+            </a:extLst>
+          </p:cNvPr>
+          <p:cNvSpPr>
+            <a:spLocks xmlns:a="http://schemas.openxmlformats.org/drawingml/2006/main" noGrp="1"/>
+          </p:cNvSpPr>
+          <p:nvPr/>
+        </p:nvSpPr>
+        <p:spPr>
+          <a:xfrm xmlns:a="http://schemas.openxmlformats.org/drawingml/2006/main">
+            <a:off x="6648450" y="5915025"/>
+            <a:ext cx="4905375" cy="390525"/>
+          </a:xfrm>
+          <a:prstGeom xmlns:a="http://schemas.openxmlformats.org/drawingml/2006/main" prst="rect">
+            <a:avLst/>
+          </a:prstGeom>
+          <a:noFill xmlns:a="http://schemas.openxmlformats.org/drawingml/2006/main"/>
+          <a:ln xmlns:a="http://schemas.openxmlformats.org/drawingml/2006/main" w="0">
+            <a:noFill/>
+          </a:ln>
+        </p:spPr>
+        <p:txBody>
+          <a:bodyPr xmlns:a="http://schemas.openxmlformats.org/drawingml/2006/main">
+            <a:noAutofit/>
+          </a:bodyPr>
+          <a:lstStyle xmlns:a="http://schemas.openxmlformats.org/drawingml/2006/main"/>
+          <a:p xmlns:a="http://schemas.openxmlformats.org/drawingml/2006/main">
+            <a:pPr>
+              <a:defRPr sz="1725">
+                <a:solidFill>
+                  <a:srgbClr val="AEC6BC"/>
+                </a:solidFill>
+                <a:latin typeface="Helvetica Neue"/>
+                <a:ea typeface="Helvetica Neue"/>
+                <a:cs typeface="Helvetica Neue"/>
+              </a:defRPr>
+            </a:pPr>
+            <a:r>
+              <a:rPr sz="1725">
+                <a:solidFill>
+                  <a:srgbClr val="AEC6BC"/>
+                </a:solidFill>
+                <a:latin typeface="Helvetica Neue"/>
+                <a:ea typeface="Helvetica Neue"/>
+                <a:cs typeface="Helvetica Neue"/>
+              </a:rPr>
               <a:t>github.com/gfade/tapedeck_ai</a:t>
             </a:r>
           </a:p>
@@ -4559,7 +6012,7 @@
     </p:spTree>
     <p:extLst>
       <p:ext uri="{BB962C8B-B14F-4D97-AF65-F5344CB8AC3E}">
-        <p14:creationId xmlns:p14="http://schemas.microsoft.com/office/powerpoint/2010/main" val="174784117"/>
+        <p14:creationId xmlns:p14="http://schemas.microsoft.com/office/powerpoint/2010/main" val="540774596"/>
       </p:ext>
     </p:extLst>
   </p:cSld>

</xml_diff>